<commit_message>
Deck: explain the AI router, where the dials come from, tune-once families, overall winner
Co-Authored-By: Claude Opus 5.5 <noreply@anthropic.com>
</commit_message>
<xml_diff>
--- a/slides/Q-Router_presentation.pptx
+++ b/slides/Q-Router_presentation.pptx
@@ -1147,7 +1147,7 @@
           <c:showBubbleSize val="0"/>
           <c:showLeaderLines val="1"/>
         </c:dLbls>
-        <c:gapWidth val="45"/>
+        <c:gapWidth val="40"/>
         <c:axId val="-2068027336"/>
         <c:axId val="-2113994440"/>
       </c:barChart>
@@ -2998,7 +2998,7 @@
           </a:p>
           <a:p>
             <a:r>
-              <a:t>"How does the router see a problem? We draw a connection map: one dot per choice, and a line wherever two choices affect each other. Drug funding is fully connected, because 'fund exactly 4' ties every drug to every other one. A trial-site network is sparse: each site touches only its neighbors. From the map we count size, density and links. Then we compile the actual quantum recipe onto IBM's real chip and count its link steps and its chance of running with zero errors, using IBM's own error measurements. Those nine numbers are the problem's fingerprint."</a:t>
+              <a:t>"How does the router see a problem? We draw a connection map: one dot per choice, and a line wherever two choices affect each other. Drug funding is fully connected, because 'fund exactly 4' ties every drug to every other one. A trial-site network is sparse: each site touches only its neighbors. From the map we count size, density and links. Then we compile the actual quantum recipe onto IBM's real chip and count its link steps and its chance of running with zero errors, using IBM's own error measurements. Those nine numbers are the problem's fingerprint. Then the AI learns: we made 60 practice problems, solved each one three ways on a simulator, and a random forest learned which solver scores best for which fingerprint. For a new problem it picks the best quantum kind, or the laptop if no quantum option reaches 0.5."</a:t>
             </a:r>
           </a:p>
           <a:p/>
@@ -3236,7 +3236,7 @@
           <a:lstStyle/>
           <a:p>
             <a:r>
-              <a:t>SLIDE 7 · COPY SETTINGS FROM A TWIN · target 0:40</a:t>
+              <a:t>SLIDE 7 · WHERE THE DIALS COME FROM · target 0:45</a:t>
             </a:r>
           </a:p>
           <a:p/>
@@ -3247,44 +3247,65 @@
           </a:p>
           <a:p>
             <a:r>
-              <a:t>"First payoff: tuning a quantum recipe normally takes about 60 trial runs. Q-Router instead finds the closest problem from a different industry, its twin, copies its dials, and runs once. Across all 60 problems, copied settings score 0.60, close to 0.63 for full tuning. The key check: copying from a random problem scores 0.58, no better than not tuning at all, so it's the shape match that helps. That's about half the benefit of tuning for one sixtieth of the effort."</a:t>
+              <a:t>"The gate-based recipe has two dials, two numbers that control how hard it pushes and links choices and how much it shuffles answers. Normally you find good settings by trial and error, about 60 tries per problem. Here's where ours come from: during training we tuned the dials for each of our 60 practice problems once, on a simulator, so no quantum time, and saved them in a library next to each problem's shape. When a new problem arrives, Q-Router finds the closest shape from a different industry and copies its dials, then runs once. Testing every problem this way: copied dials score 0.60, close to 0.63 for full tuning, while copying from a random problem scores 0.58, no better than no tuning. So it's the shape match that works: about half the benefit of tuning for one sixtieth of the effort."</a:t>
             </a:r>
           </a:p>
           <a:p/>
           <a:p>
             <a:r>
-              <a:t>HOW TO READ THE CHART</a:t>
-            </a:r>
-          </a:p>
-          <a:p>
-            <a:r>
-              <a:t>- The gap between "default dials" (0.581) and "tuned from scratch" (0.633) is what tuning buys. The twin (0.599) closes about half of it with 1 try instead of 60.</a:t>
-            </a:r>
-          </a:p>
-          <a:p>
-            <a:r>
-              <a:t>- The random copy (0.577) is the control: same cost, also from another industry, no gain.</a:t>
-            </a:r>
-          </a:p>
-          <a:p>
-            <a:r>
-              <a:t>- Table: results by industry. It works best for stocks and drugs and doesn't help medical tests (0.532 vs 0.555 default); we say that openly.</a:t>
-            </a:r>
-          </a:p>
-          <a:p>
-            <a:r>
-              <a:t>- Statistics: the twin beats the random copy by 0.023 ± 0.010 (standard error) and wins on 65% of problems.</a:t>
+              <a:t>WHAT'S ON THE SLIDE</a:t>
+            </a:r>
+          </a:p>
+          <a:p>
+            <a:r>
+              <a:t>- Top strip, left to right: 60 practice problems → tune each once on a simulator (about 60 tries) → save a library (shape + best 2 dials) → new problem: find the closest shape in another industry → copy the dials and run once.</a:t>
+            </a:r>
+          </a:p>
+          <a:p>
+            <a:r>
+              <a:t>- Bar chart: four ways to set the dials, tested on all 60 problems by pretending each one is new. Longer bar = better.</a:t>
+            </a:r>
+          </a:p>
+          <a:p>
+            <a:r>
+              <a:t>  Tuned from scratch 0.633 (60 tries) · copied from twin 0.599 (1 try) · copied from random 0.577 (1 try) · default dials 0.581 (1 try).</a:t>
+            </a:r>
+          </a:p>
+          <a:p>
+            <a:r>
+              <a:t>- The gap between default (0.581) and tuned (0.633) is what tuning buys; the twin closes about half of it.</a:t>
+            </a:r>
+          </a:p>
+          <a:p>
+            <a:r>
+              <a:t>- Table: by industry. Works best for stocks and drugs; doesn't help medical tests (0.532 vs 0.555 default).</a:t>
+            </a:r>
+          </a:p>
+          <a:p>
+            <a:r>
+              <a:t>- Statistics: twin beats random by 0.023 ± 0.010 and wins on 65% of problems.</a:t>
             </a:r>
           </a:p>
           <a:p/>
           <a:p>
             <a:r>
+              <a:t>WHAT THE DIALS ARE</a:t>
+            </a:r>
+          </a:p>
+          <a:p>
+            <a:r>
+              <a:t>γ (gamma) = how strongly each choice is pushed toward its value and how strongly linked choices pull on each other. β (beta) = how much the recipe shuffles answers. One round of the recipe = one pair of numbers, for example β = 0.35, γ = −0.42.</a:t>
+            </a:r>
+          </a:p>
+          <a:p/>
+          <a:p>
+            <a:r>
               <a:t>HOW THE TWIN IS FOUND</a:t>
             </a:r>
           </a:p>
           <a:p>
             <a:r>
-              <a:t>Rescale the nine fingerprint numbers so none dominates, measure the distance between fingerprints, keep only other industries, take the closest. A lookup, not a guess.</a:t>
+              <a:t>Rescale the nine fingerprint numbers so none dominates, measure the distance between fingerprints, keep only other industries, take the closest. A lookup in the library, not a guess.</a:t>
             </a:r>
           </a:p>
           <a:p/>
@@ -3295,12 +3316,22 @@
           </a:p>
           <a:p>
             <a:r>
+              <a:t>Q: Where do the copied dials come from?</a:t>
+            </a:r>
+          </a:p>
+          <a:p>
+            <a:r>
+              <a:t>A: From our library: each of the 60 practice problems was tuned once on a simulator and its best two dials were saved with its shape.</a:t>
+            </a:r>
+          </a:p>
+          <a:p>
+            <a:r>
               <a:t>Q: Hasn't copying QAOA settings been done before?</a:t>
             </a:r>
           </a:p>
           <a:p>
             <a:r>
-              <a:t>A: Yes, between similar math problems (parameter concentration), and a 2025 study did it across problem types. What's new in ours: real industry decisions with real data, a random-copy control, and combining it with routing and packing to measure the quantum time saved.</a:t>
+              <a:t>A: Between similar math problems yes (parameter concentration), and a 2025 study did it across problem types. Ours tests it across real industry decisions with real data, with a random-copy control, and combines it with routing and packing.</a:t>
             </a:r>
           </a:p>
           <a:p>
@@ -3379,7 +3410,7 @@
           </a:p>
           <a:p>
             <a:r>
-              <a:t>"Second payoff: problems with the same shape can share one run. We grouped four problems from four industries into two shape families, tuned only one problem per family, and packed all four side by side into a single 16-qubit job. Compared with the normal way, that's half the tunings, one chip job instead of four, and four times fewer quantum shots, which is what you pay for. In simulation we kept 96% of the quality; on the real IBM chip, 90%."</a:t>
+              <a:t>"Second payoff: problems with the same shape can share one run. We grouped four problems from four industries into two shape families, tuned only the most typical problem in each family and let the others copy its dials, and packed all four side by side into a single 16-qubit job. Compared with the normal way, that's half the tunings, one chip job instead of four, and four times fewer quantum shots, which is what you pay for. In simulation we kept 96% of the quality; on the real IBM chip, 90%."</a:t>
             </a:r>
           </a:p>
           <a:p/>
@@ -3638,7 +3669,7 @@
           </a:p>
           <a:p>
             <a:r>
-              <a:t>"Finally, the full real-hardware test on IBM's 156-qubit ibm_kingston. We ran our drug problem, fund 3 of 8, four ways. With no errors, annealing beats gate-based, 0.80 to 0.72. On the real chip it flips: gate-based 0.64, annealing 0.55, because annealing needs about six times more link steps. That's exactly why a router is needed. What did the chip actually answer? Its most common answer was a good set, but not the best one. Still, the true best set was among its answers in every run, two to three times more often than random guessing, and a laptop finds it directly. One surprise: IBM's error-reducing tricks made our scores worse, especially for long recipes. We report that honestly."</a:t>
+              <a:t>"Finally, the full real-hardware test on IBM's 156-qubit ibm_kingston. We ran our drug problem, fund 3 of 8, four ways. With no errors, annealing beats gate-based, 0.80 to 0.72. On the real chip it flips: gate-based 0.64, annealing 0.55, because annealing needs about six times more link steps. That's exactly why a router is needed. What did the chip actually answer? Its most common answer was a good set, but not the best one. Still, the true best set was among its answers in every run, two to three times more often than random guessing, and a laptop finds it directly. One surprise: IBM's error-reducing tricks made our scores worse, especially for long recipes. We report that honestly. So overall, on the real chip, gate-based beat annealing, and the laptop still beat both."</a:t>
             </a:r>
           </a:p>
           <a:p/>
@@ -25759,360 +25790,28 @@
           </a:p>
         </p:txBody>
       </p:sp>
-      <p:graphicFrame>
-        <p:nvGraphicFramePr>
-          <p:cNvPr id="301" name="Table 300"/>
-          <p:cNvGraphicFramePr>
-            <a:graphicFrameLocks noGrp="1"/>
-          </p:cNvGraphicFramePr>
-          <p:nvPr/>
-        </p:nvGraphicFramePr>
-        <p:xfrm>
-          <a:off x="9144000" y="2240280"/>
-          <a:ext cx="2514600" cy="1170432"/>
-        </p:xfrm>
-        <a:graphic>
-          <a:graphicData uri="http://schemas.openxmlformats.org/drawingml/2006/table">
-            <a:tbl>
-              <a:tblPr firstRow="0" bandRow="0"/>
-              <a:tblGrid>
-                <a:gridCol w="1143000"/>
-                <a:gridCol w="640080"/>
-                <a:gridCol w="731520"/>
-              </a:tblGrid>
-              <a:tr h="292608">
-                <a:tc>
-                  <a:txBody>
-                    <a:bodyPr/>
-                    <a:lstStyle/>
-                    <a:p>
-                      <a:r>
-                        <a:rPr sz="1000" b="1">
-                          <a:solidFill>
-                            <a:srgbClr val="F4F8FF"/>
-                          </a:solidFill>
-                          <a:latin typeface="Arial"/>
-                        </a:rPr>
-                        <a:t>8-choice example</a:t>
-                      </a:r>
-                    </a:p>
-                  </a:txBody>
-                  <a:tcPr marL="54864" marR="54864" marT="18288" marB="18288" anchor="ctr">
-                    <a:solidFill>
-                      <a:srgbClr val="233558"/>
-                    </a:solidFill>
-                  </a:tcPr>
-                </a:tc>
-                <a:tc>
-                  <a:txBody>
-                    <a:bodyPr/>
-                    <a:lstStyle/>
-                    <a:p>
-                      <a:r>
-                        <a:rPr sz="1000" b="1">
-                          <a:solidFill>
-                            <a:srgbClr val="F4F8FF"/>
-                          </a:solidFill>
-                          <a:latin typeface="Arial"/>
-                        </a:rPr>
-                        <a:t>Density</a:t>
-                      </a:r>
-                    </a:p>
-                  </a:txBody>
-                  <a:tcPr marL="54864" marR="54864" marT="18288" marB="18288" anchor="ctr">
-                    <a:solidFill>
-                      <a:srgbClr val="233558"/>
-                    </a:solidFill>
-                  </a:tcPr>
-                </a:tc>
-                <a:tc>
-                  <a:txBody>
-                    <a:bodyPr/>
-                    <a:lstStyle/>
-                    <a:p>
-                      <a:r>
-                        <a:rPr sz="1000" b="1">
-                          <a:solidFill>
-                            <a:srgbClr val="F4F8FF"/>
-                          </a:solidFill>
-                          <a:latin typeface="Arial"/>
-                        </a:rPr>
-                        <a:t>Link steps</a:t>
-                      </a:r>
-                    </a:p>
-                  </a:txBody>
-                  <a:tcPr marL="54864" marR="54864" marT="18288" marB="18288" anchor="ctr">
-                    <a:solidFill>
-                      <a:srgbClr val="233558"/>
-                    </a:solidFill>
-                  </a:tcPr>
-                </a:tc>
-              </a:tr>
-              <a:tr h="292608">
-                <a:tc>
-                  <a:txBody>
-                    <a:bodyPr/>
-                    <a:lstStyle/>
-                    <a:p>
-                      <a:r>
-                        <a:rPr sz="1000" b="0">
-                          <a:solidFill>
-                            <a:srgbClr val="A1B1CD"/>
-                          </a:solidFill>
-                          <a:latin typeface="Arial"/>
-                        </a:rPr>
-                        <a:t>Drugs</a:t>
-                      </a:r>
-                    </a:p>
-                  </a:txBody>
-                  <a:tcPr marL="54864" marR="54864" marT="18288" marB="18288" anchor="ctr">
-                    <a:solidFill>
-                      <a:srgbClr val="0D132A"/>
-                    </a:solidFill>
-                  </a:tcPr>
-                </a:tc>
-                <a:tc>
-                  <a:txBody>
-                    <a:bodyPr/>
-                    <a:lstStyle/>
-                    <a:p>
-                      <a:r>
-                        <a:rPr sz="1000" b="0">
-                          <a:solidFill>
-                            <a:srgbClr val="A1B1CD"/>
-                          </a:solidFill>
-                          <a:latin typeface="Arial"/>
-                        </a:rPr>
-                        <a:t>1.00</a:t>
-                      </a:r>
-                    </a:p>
-                  </a:txBody>
-                  <a:tcPr marL="54864" marR="54864" marT="18288" marB="18288" anchor="ctr">
-                    <a:solidFill>
-                      <a:srgbClr val="0D132A"/>
-                    </a:solidFill>
-                  </a:tcPr>
-                </a:tc>
-                <a:tc>
-                  <a:txBody>
-                    <a:bodyPr/>
-                    <a:lstStyle/>
-                    <a:p>
-                      <a:r>
-                        <a:rPr sz="1000" b="0">
-                          <a:solidFill>
-                            <a:srgbClr val="A1B1CD"/>
-                          </a:solidFill>
-                          <a:latin typeface="Arial"/>
-                        </a:rPr>
-                        <a:t>99</a:t>
-                      </a:r>
-                    </a:p>
-                  </a:txBody>
-                  <a:tcPr marL="54864" marR="54864" marT="18288" marB="18288" anchor="ctr">
-                    <a:solidFill>
-                      <a:srgbClr val="0D132A"/>
-                    </a:solidFill>
-                  </a:tcPr>
-                </a:tc>
-              </a:tr>
-              <a:tr h="292608">
-                <a:tc>
-                  <a:txBody>
-                    <a:bodyPr/>
-                    <a:lstStyle/>
-                    <a:p>
-                      <a:r>
-                        <a:rPr sz="1000" b="0">
-                          <a:solidFill>
-                            <a:srgbClr val="A1B1CD"/>
-                          </a:solidFill>
-                          <a:latin typeface="Arial"/>
-                        </a:rPr>
-                        <a:t>Network</a:t>
-                      </a:r>
-                    </a:p>
-                  </a:txBody>
-                  <a:tcPr marL="54864" marR="54864" marT="18288" marB="18288" anchor="ctr">
-                    <a:solidFill>
-                      <a:srgbClr val="0D132A"/>
-                    </a:solidFill>
-                  </a:tcPr>
-                </a:tc>
-                <a:tc>
-                  <a:txBody>
-                    <a:bodyPr/>
-                    <a:lstStyle/>
-                    <a:p>
-                      <a:r>
-                        <a:rPr sz="1000" b="0">
-                          <a:solidFill>
-                            <a:srgbClr val="A1B1CD"/>
-                          </a:solidFill>
-                          <a:latin typeface="Arial"/>
-                        </a:rPr>
-                        <a:t>0.50</a:t>
-                      </a:r>
-                    </a:p>
-                  </a:txBody>
-                  <a:tcPr marL="54864" marR="54864" marT="18288" marB="18288" anchor="ctr">
-                    <a:solidFill>
-                      <a:srgbClr val="0D132A"/>
-                    </a:solidFill>
-                  </a:tcPr>
-                </a:tc>
-                <a:tc>
-                  <a:txBody>
-                    <a:bodyPr/>
-                    <a:lstStyle/>
-                    <a:p>
-                      <a:r>
-                        <a:rPr sz="1000" b="0">
-                          <a:solidFill>
-                            <a:srgbClr val="A1B1CD"/>
-                          </a:solidFill>
-                          <a:latin typeface="Arial"/>
-                        </a:rPr>
-                        <a:t>49</a:t>
-                      </a:r>
-                    </a:p>
-                  </a:txBody>
-                  <a:tcPr marL="54864" marR="54864" marT="18288" marB="18288" anchor="ctr">
-                    <a:solidFill>
-                      <a:srgbClr val="0D132A"/>
-                    </a:solidFill>
-                  </a:tcPr>
-                </a:tc>
-              </a:tr>
-              <a:tr h="292608">
-                <a:tc>
-                  <a:txBody>
-                    <a:bodyPr/>
-                    <a:lstStyle/>
-                    <a:p>
-                      <a:r>
-                        <a:rPr sz="1000" b="0">
-                          <a:solidFill>
-                            <a:srgbClr val="A1B1CD"/>
-                          </a:solidFill>
-                          <a:latin typeface="Arial"/>
-                        </a:rPr>
-                        <a:t>Medical tests</a:t>
-                      </a:r>
-                    </a:p>
-                  </a:txBody>
-                  <a:tcPr marL="54864" marR="54864" marT="18288" marB="18288" anchor="ctr">
-                    <a:solidFill>
-                      <a:srgbClr val="0D132A"/>
-                    </a:solidFill>
-                  </a:tcPr>
-                </a:tc>
-                <a:tc>
-                  <a:txBody>
-                    <a:bodyPr/>
-                    <a:lstStyle/>
-                    <a:p>
-                      <a:r>
-                        <a:rPr sz="1000" b="0">
-                          <a:solidFill>
-                            <a:srgbClr val="A1B1CD"/>
-                          </a:solidFill>
-                          <a:latin typeface="Arial"/>
-                        </a:rPr>
-                        <a:t>0.61</a:t>
-                      </a:r>
-                    </a:p>
-                  </a:txBody>
-                  <a:tcPr marL="54864" marR="54864" marT="18288" marB="18288" anchor="ctr">
-                    <a:solidFill>
-                      <a:srgbClr val="0D132A"/>
-                    </a:solidFill>
-                  </a:tcPr>
-                </a:tc>
-                <a:tc>
-                  <a:txBody>
-                    <a:bodyPr/>
-                    <a:lstStyle/>
-                    <a:p>
-                      <a:r>
-                        <a:rPr sz="1000" b="0">
-                          <a:solidFill>
-                            <a:srgbClr val="A1B1CD"/>
-                          </a:solidFill>
-                          <a:latin typeface="Arial"/>
-                        </a:rPr>
-                        <a:t>53</a:t>
-                      </a:r>
-                    </a:p>
-                  </a:txBody>
-                  <a:tcPr marL="54864" marR="54864" marT="18288" marB="18288" anchor="ctr">
-                    <a:solidFill>
-                      <a:srgbClr val="0D132A"/>
-                    </a:solidFill>
-                  </a:tcPr>
-                </a:tc>
-              </a:tr>
-            </a:tbl>
-          </a:graphicData>
-        </a:graphic>
-      </p:graphicFrame>
       <p:sp>
         <p:nvSpPr>
-          <p:cNvPr id="302" name="TextBox 301"/>
-          <p:cNvSpPr txBox="1"/>
+          <p:cNvPr id="301" name="Rounded Rectangle 300"/>
+          <p:cNvSpPr/>
           <p:nvPr/>
         </p:nvSpPr>
         <p:spPr>
           <a:xfrm>
-            <a:off x="9144000" y="3520440"/>
-            <a:ext cx="2514600" cy="1371600"/>
-          </a:xfrm>
-          <a:prstGeom prst="rect">
-            <a:avLst/>
-          </a:prstGeom>
-          <a:noFill/>
-        </p:spPr>
-        <p:txBody>
-          <a:bodyPr wrap="square" lIns="27425" rIns="27425" tIns="22850" bIns="22850" anchor="t">
-            <a:spAutoFit/>
-          </a:bodyPr>
-          <a:lstStyle/>
-          <a:p>
-            <a:pPr algn="l"/>
-            <a:r>
-              <a:rPr sz="1100" b="0">
-                <a:solidFill>
-                  <a:srgbClr val="A1B1CD"/>
-                </a:solidFill>
-                <a:latin typeface="Arial"/>
-              </a:rPr>
-              <a:t>Fewer lines → fewer link steps → fewer chip errors. Link steps are the noisiest part of any quantum recipe.</a:t>
-            </a:r>
-          </a:p>
-        </p:txBody>
-      </p:sp>
-      <p:sp>
-        <p:nvSpPr>
-          <p:cNvPr id="303" name="Rounded Rectangle 302"/>
-          <p:cNvSpPr/>
-          <p:nvPr/>
-        </p:nvSpPr>
-        <p:spPr>
-          <a:xfrm>
-            <a:off x="822960" y="5349240"/>
-            <a:ext cx="10424160" cy="502920"/>
+            <a:off x="9144000" y="2240280"/>
+            <a:ext cx="2514600" cy="2926080"/>
           </a:xfrm>
           <a:prstGeom prst="roundRect">
             <a:avLst>
-              <a:gd name="adj" fmla="val 20000"/>
+              <a:gd name="adj" fmla="val 12000"/>
             </a:avLst>
           </a:prstGeom>
           <a:solidFill>
-            <a:srgbClr val="121B37"/>
+            <a:srgbClr val="0D132A"/>
           </a:solidFill>
           <a:ln w="12700">
             <a:solidFill>
-              <a:srgbClr val="FFCA5C"/>
+              <a:srgbClr val="233558"/>
             </a:solidFill>
           </a:ln>
           <a:effectLst/>
@@ -26141,7 +25840,228 @@
       </p:sp>
       <p:sp>
         <p:nvSpPr>
+          <p:cNvPr id="302" name="Rectangle 301"/>
+          <p:cNvSpPr/>
+          <p:nvPr/>
+        </p:nvSpPr>
+        <p:spPr>
+          <a:xfrm>
+            <a:off x="9308592" y="2423160"/>
+            <a:ext cx="50292" cy="2560320"/>
+          </a:xfrm>
+          <a:prstGeom prst="rect">
+            <a:avLst/>
+          </a:prstGeom>
+          <a:solidFill>
+            <a:srgbClr val="FFCA5C"/>
+          </a:solidFill>
+          <a:ln>
+            <a:noFill/>
+          </a:ln>
+          <a:effectLst/>
+        </p:spPr>
+        <p:style>
+          <a:lnRef idx="1">
+            <a:schemeClr val="accent1"/>
+          </a:lnRef>
+          <a:fillRef idx="3">
+            <a:schemeClr val="accent1"/>
+          </a:fillRef>
+          <a:effectRef idx="2">
+            <a:schemeClr val="accent1"/>
+          </a:effectRef>
+          <a:fontRef idx="minor">
+            <a:schemeClr val="lt1"/>
+          </a:fontRef>
+        </p:style>
+        <p:txBody>
+          <a:bodyPr rtlCol="0" anchor="ctr"/>
+          <a:lstStyle/>
+          <a:p>
+            <a:pPr algn="ctr"/>
+          </a:p>
+        </p:txBody>
+      </p:sp>
+      <p:sp>
+        <p:nvSpPr>
+          <p:cNvPr id="303" name="TextBox 302"/>
+          <p:cNvSpPr txBox="1"/>
+          <p:nvPr/>
+        </p:nvSpPr>
+        <p:spPr>
+          <a:xfrm>
+            <a:off x="9473184" y="2404872"/>
+            <a:ext cx="2057400" cy="201168"/>
+          </a:xfrm>
+          <a:prstGeom prst="rect">
+            <a:avLst/>
+          </a:prstGeom>
+          <a:noFill/>
+        </p:spPr>
+        <p:txBody>
+          <a:bodyPr wrap="square" lIns="27425" rIns="27425" tIns="22850" bIns="22850" anchor="t">
+            <a:spAutoFit/>
+          </a:bodyPr>
+          <a:lstStyle/>
+          <a:p>
+            <a:pPr algn="l"/>
+            <a:r>
+              <a:rPr sz="900" b="1">
+                <a:solidFill>
+                  <a:srgbClr val="FFCA5C"/>
+                </a:solidFill>
+                <a:latin typeface="Arial"/>
+              </a:rPr>
+              <a:t>THEN THE AI LEARNS</a:t>
+            </a:r>
+          </a:p>
+        </p:txBody>
+      </p:sp>
+      <p:sp>
+        <p:nvSpPr>
           <p:cNvPr id="304" name="TextBox 303"/>
+          <p:cNvSpPr txBox="1"/>
+          <p:nvPr/>
+        </p:nvSpPr>
+        <p:spPr>
+          <a:xfrm>
+            <a:off x="9473184" y="2651760"/>
+            <a:ext cx="2039112" cy="2404872"/>
+          </a:xfrm>
+          <a:prstGeom prst="rect">
+            <a:avLst/>
+          </a:prstGeom>
+          <a:noFill/>
+        </p:spPr>
+        <p:txBody>
+          <a:bodyPr wrap="square" lIns="27425" rIns="27425" tIns="22850" bIns="22850" anchor="t">
+            <a:spAutoFit/>
+          </a:bodyPr>
+          <a:lstStyle/>
+          <a:p>
+            <a:pPr algn="l"/>
+            <a:r>
+              <a:rPr sz="1100" b="1">
+                <a:solidFill>
+                  <a:srgbClr val="F4F8FF"/>
+                </a:solidFill>
+                <a:latin typeface="Arial"/>
+              </a:rPr>
+              <a:t>60 practice problems</a:t>
+            </a:r>
+            <a:r>
+              <a:rPr sz="1100" b="0">
+                <a:solidFill>
+                  <a:srgbClr val="A1B1CD"/>
+                </a:solidFill>
+                <a:latin typeface="Arial"/>
+              </a:rPr>
+              <a:t> (stocks, tests, drugs, networks), each solved 3 ways on a simulator.</a:t>
+            </a:r>
+          </a:p>
+          <a:p>
+            <a:pPr algn="l">
+              <a:spcBef>
+                <a:spcPts val="400"/>
+              </a:spcBef>
+            </a:pPr>
+            <a:r>
+              <a:rPr sz="1100" b="1">
+                <a:solidFill>
+                  <a:srgbClr val="F4F8FF"/>
+                </a:solidFill>
+                <a:latin typeface="Arial"/>
+              </a:rPr>
+              <a:t>A random forest</a:t>
+            </a:r>
+            <a:r>
+              <a:rPr sz="1100" b="0">
+                <a:solidFill>
+                  <a:srgbClr val="A1B1CD"/>
+                </a:solidFill>
+                <a:latin typeface="Arial"/>
+              </a:rPr>
+              <a:t> learns: this fingerprint → this solver scores best.</a:t>
+            </a:r>
+          </a:p>
+          <a:p>
+            <a:pPr algn="l">
+              <a:spcBef>
+                <a:spcPts val="400"/>
+              </a:spcBef>
+            </a:pPr>
+            <a:r>
+              <a:rPr sz="1100" b="1">
+                <a:solidFill>
+                  <a:srgbClr val="F4F8FF"/>
+                </a:solidFill>
+                <a:latin typeface="Arial"/>
+              </a:rPr>
+              <a:t>New problem:</a:t>
+            </a:r>
+            <a:r>
+              <a:rPr sz="1100" b="0">
+                <a:solidFill>
+                  <a:srgbClr val="A1B1CD"/>
+                </a:solidFill>
+                <a:latin typeface="Arial"/>
+              </a:rPr>
+              <a:t> best quantum kind, or the laptop if no quantum option reaches 0.5.</a:t>
+            </a:r>
+          </a:p>
+        </p:txBody>
+      </p:sp>
+      <p:sp>
+        <p:nvSpPr>
+          <p:cNvPr id="305" name="Rounded Rectangle 304"/>
+          <p:cNvSpPr/>
+          <p:nvPr/>
+        </p:nvSpPr>
+        <p:spPr>
+          <a:xfrm>
+            <a:off x="822960" y="5349240"/>
+            <a:ext cx="10424160" cy="502920"/>
+          </a:xfrm>
+          <a:prstGeom prst="roundRect">
+            <a:avLst>
+              <a:gd name="adj" fmla="val 20000"/>
+            </a:avLst>
+          </a:prstGeom>
+          <a:solidFill>
+            <a:srgbClr val="121B37"/>
+          </a:solidFill>
+          <a:ln w="12700">
+            <a:solidFill>
+              <a:srgbClr val="FFCA5C"/>
+            </a:solidFill>
+          </a:ln>
+          <a:effectLst/>
+        </p:spPr>
+        <p:style>
+          <a:lnRef idx="1">
+            <a:schemeClr val="accent1"/>
+          </a:lnRef>
+          <a:fillRef idx="3">
+            <a:schemeClr val="accent1"/>
+          </a:fillRef>
+          <a:effectRef idx="2">
+            <a:schemeClr val="accent1"/>
+          </a:effectRef>
+          <a:fontRef idx="minor">
+            <a:schemeClr val="lt1"/>
+          </a:fontRef>
+        </p:style>
+        <p:txBody>
+          <a:bodyPr rtlCol="0" anchor="ctr"/>
+          <a:lstStyle/>
+          <a:p>
+            <a:pPr algn="ctr"/>
+          </a:p>
+        </p:txBody>
+      </p:sp>
+      <p:sp>
+        <p:nvSpPr>
+          <p:cNvPr id="306" name="TextBox 305"/>
           <p:cNvSpPr txBox="1"/>
           <p:nvPr/>
         </p:nvSpPr>
@@ -28992,7 +28912,7 @@
                 <a:cs typeface="Arial"/>
                 <a:sym typeface="Arial"/>
               </a:rPr>
-              <a:t>Copy settings from a twin: one try instead of sixty.</a:t>
+              <a:t>Where the dials come from, and why copying works.</a:t>
             </a:r>
             <a:endParaRPr/>
           </a:p>
@@ -29042,23 +28962,662 @@
                 <a:cs typeface="Arial"/>
                 <a:sym typeface="Arial"/>
               </a:rPr>
-              <a:t>Tuning a quantum recipe takes about 60 tries. Q-Router copies the dials from the closest problem in another industry.</a:t>
+              <a:t>Dials are tuned once per practice problem on a simulator, saved in a library, and copied to new problems with a similar shape.</a:t>
             </a:r>
             <a:endParaRPr/>
+          </a:p>
+        </p:txBody>
+      </p:sp>
+      <p:sp>
+        <p:nvSpPr>
+          <p:cNvPr id="252" name="Rounded Rectangle 251"/>
+          <p:cNvSpPr/>
+          <p:nvPr/>
+        </p:nvSpPr>
+        <p:spPr>
+          <a:xfrm>
+            <a:off x="548640" y="2148840"/>
+            <a:ext cx="2039112" cy="841248"/>
+          </a:xfrm>
+          <a:prstGeom prst="roundRect">
+            <a:avLst>
+              <a:gd name="adj" fmla="val 20000"/>
+            </a:avLst>
+          </a:prstGeom>
+          <a:solidFill>
+            <a:srgbClr val="0D132A"/>
+          </a:solidFill>
+          <a:ln w="12700">
+            <a:solidFill>
+              <a:srgbClr val="27D6FF"/>
+            </a:solidFill>
+          </a:ln>
+          <a:effectLst/>
+        </p:spPr>
+        <p:style>
+          <a:lnRef idx="1">
+            <a:schemeClr val="accent1"/>
+          </a:lnRef>
+          <a:fillRef idx="3">
+            <a:schemeClr val="accent1"/>
+          </a:fillRef>
+          <a:effectRef idx="2">
+            <a:schemeClr val="accent1"/>
+          </a:effectRef>
+          <a:fontRef idx="minor">
+            <a:schemeClr val="lt1"/>
+          </a:fontRef>
+        </p:style>
+        <p:txBody>
+          <a:bodyPr rtlCol="0" anchor="ctr"/>
+          <a:lstStyle/>
+          <a:p>
+            <a:pPr algn="ctr"/>
+          </a:p>
+        </p:txBody>
+      </p:sp>
+      <p:sp>
+        <p:nvSpPr>
+          <p:cNvPr id="253" name="TextBox 252"/>
+          <p:cNvSpPr txBox="1"/>
+          <p:nvPr/>
+        </p:nvSpPr>
+        <p:spPr>
+          <a:xfrm>
+            <a:off x="594360" y="2148840"/>
+            <a:ext cx="1947672" cy="841248"/>
+          </a:xfrm>
+          <a:prstGeom prst="rect">
+            <a:avLst/>
+          </a:prstGeom>
+          <a:noFill/>
+        </p:spPr>
+        <p:txBody>
+          <a:bodyPr wrap="square" lIns="27425" rIns="27425" tIns="22850" bIns="22850" anchor="ctr">
+            <a:spAutoFit/>
+          </a:bodyPr>
+          <a:lstStyle/>
+          <a:p>
+            <a:pPr algn="ctr"/>
+            <a:r>
+              <a:rPr sz="1000" b="1">
+                <a:solidFill>
+                  <a:srgbClr val="27D6FF"/>
+                </a:solidFill>
+                <a:latin typeface="Arial"/>
+              </a:rPr>
+              <a:t>60 PRACTICE PROBLEMS</a:t>
+            </a:r>
+          </a:p>
+          <a:p>
+            <a:pPr algn="ctr">
+              <a:spcBef>
+                <a:spcPts val="400"/>
+              </a:spcBef>
+            </a:pPr>
+            <a:r>
+              <a:rPr sz="1000" b="0">
+                <a:solidFill>
+                  <a:srgbClr val="F4F8FF"/>
+                </a:solidFill>
+                <a:latin typeface="Arial"/>
+              </a:rPr>
+              <a:t>stocks · tests · drugs · networks</a:t>
+            </a:r>
+          </a:p>
+        </p:txBody>
+      </p:sp>
+      <p:cxnSp>
+        <p:nvCxnSpPr>
+          <p:cNvPr id="254" name="Connector 253"/>
+          <p:cNvCxnSpPr/>
+          <p:nvPr/>
+        </p:nvCxnSpPr>
+        <p:spPr>
+          <a:xfrm>
+            <a:off x="2606040" y="2569464"/>
+            <a:ext cx="192024" cy="0"/>
+          </a:xfrm>
+          <a:prstGeom prst="line">
+            <a:avLst/>
+          </a:prstGeom>
+          <a:ln w="15875">
+            <a:solidFill>
+              <a:srgbClr val="374D73"/>
+            </a:solidFill>
+            <a:tailEnd type="triangle" w="med" len="med"/>
+          </a:ln>
+        </p:spPr>
+        <p:style>
+          <a:lnRef idx="2">
+            <a:schemeClr val="accent1"/>
+          </a:lnRef>
+          <a:fillRef idx="0">
+            <a:schemeClr val="accent1"/>
+          </a:fillRef>
+          <a:effectRef idx="1">
+            <a:schemeClr val="accent1"/>
+          </a:effectRef>
+          <a:fontRef idx="minor">
+            <a:schemeClr val="tx1"/>
+          </a:fontRef>
+        </p:style>
+      </p:cxnSp>
+      <p:sp>
+        <p:nvSpPr>
+          <p:cNvPr id="255" name="Rounded Rectangle 254"/>
+          <p:cNvSpPr/>
+          <p:nvPr/>
+        </p:nvSpPr>
+        <p:spPr>
+          <a:xfrm>
+            <a:off x="2816352" y="2148840"/>
+            <a:ext cx="2039112" cy="841248"/>
+          </a:xfrm>
+          <a:prstGeom prst="roundRect">
+            <a:avLst>
+              <a:gd name="adj" fmla="val 20000"/>
+            </a:avLst>
+          </a:prstGeom>
+          <a:solidFill>
+            <a:srgbClr val="0D132A"/>
+          </a:solidFill>
+          <a:ln w="12700">
+            <a:solidFill>
+              <a:srgbClr val="D948FF"/>
+            </a:solidFill>
+          </a:ln>
+          <a:effectLst/>
+        </p:spPr>
+        <p:style>
+          <a:lnRef idx="1">
+            <a:schemeClr val="accent1"/>
+          </a:lnRef>
+          <a:fillRef idx="3">
+            <a:schemeClr val="accent1"/>
+          </a:fillRef>
+          <a:effectRef idx="2">
+            <a:schemeClr val="accent1"/>
+          </a:effectRef>
+          <a:fontRef idx="minor">
+            <a:schemeClr val="lt1"/>
+          </a:fontRef>
+        </p:style>
+        <p:txBody>
+          <a:bodyPr rtlCol="0" anchor="ctr"/>
+          <a:lstStyle/>
+          <a:p>
+            <a:pPr algn="ctr"/>
+          </a:p>
+        </p:txBody>
+      </p:sp>
+      <p:sp>
+        <p:nvSpPr>
+          <p:cNvPr id="256" name="TextBox 255"/>
+          <p:cNvSpPr txBox="1"/>
+          <p:nvPr/>
+        </p:nvSpPr>
+        <p:spPr>
+          <a:xfrm>
+            <a:off x="2862072" y="2148840"/>
+            <a:ext cx="1947672" cy="841248"/>
+          </a:xfrm>
+          <a:prstGeom prst="rect">
+            <a:avLst/>
+          </a:prstGeom>
+          <a:noFill/>
+        </p:spPr>
+        <p:txBody>
+          <a:bodyPr wrap="square" lIns="27425" rIns="27425" tIns="22850" bIns="22850" anchor="ctr">
+            <a:spAutoFit/>
+          </a:bodyPr>
+          <a:lstStyle/>
+          <a:p>
+            <a:pPr algn="ctr"/>
+            <a:r>
+              <a:rPr sz="1000" b="1">
+                <a:solidFill>
+                  <a:srgbClr val="D948FF"/>
+                </a:solidFill>
+                <a:latin typeface="Arial"/>
+              </a:rPr>
+              <a:t>TUNE EACH ONCE</a:t>
+            </a:r>
+          </a:p>
+          <a:p>
+            <a:pPr algn="ctr">
+              <a:spcBef>
+                <a:spcPts val="400"/>
+              </a:spcBef>
+            </a:pPr>
+            <a:r>
+              <a:rPr sz="1000" b="0">
+                <a:solidFill>
+                  <a:srgbClr val="F4F8FF"/>
+                </a:solidFill>
+                <a:latin typeface="Arial"/>
+              </a:rPr>
+              <a:t>~60 tries on a simulator: no quantum time</a:t>
+            </a:r>
+          </a:p>
+        </p:txBody>
+      </p:sp>
+      <p:cxnSp>
+        <p:nvCxnSpPr>
+          <p:cNvPr id="257" name="Connector 256"/>
+          <p:cNvCxnSpPr/>
+          <p:nvPr/>
+        </p:nvCxnSpPr>
+        <p:spPr>
+          <a:xfrm>
+            <a:off x="4873752" y="2569464"/>
+            <a:ext cx="192024" cy="0"/>
+          </a:xfrm>
+          <a:prstGeom prst="line">
+            <a:avLst/>
+          </a:prstGeom>
+          <a:ln w="15875">
+            <a:solidFill>
+              <a:srgbClr val="374D73"/>
+            </a:solidFill>
+            <a:tailEnd type="triangle" w="med" len="med"/>
+          </a:ln>
+        </p:spPr>
+        <p:style>
+          <a:lnRef idx="2">
+            <a:schemeClr val="accent1"/>
+          </a:lnRef>
+          <a:fillRef idx="0">
+            <a:schemeClr val="accent1"/>
+          </a:fillRef>
+          <a:effectRef idx="1">
+            <a:schemeClr val="accent1"/>
+          </a:effectRef>
+          <a:fontRef idx="minor">
+            <a:schemeClr val="tx1"/>
+          </a:fontRef>
+        </p:style>
+      </p:cxnSp>
+      <p:sp>
+        <p:nvSpPr>
+          <p:cNvPr id="258" name="Rounded Rectangle 257"/>
+          <p:cNvSpPr/>
+          <p:nvPr/>
+        </p:nvSpPr>
+        <p:spPr>
+          <a:xfrm>
+            <a:off x="5084064" y="2148840"/>
+            <a:ext cx="2039112" cy="841248"/>
+          </a:xfrm>
+          <a:prstGeom prst="roundRect">
+            <a:avLst>
+              <a:gd name="adj" fmla="val 20000"/>
+            </a:avLst>
+          </a:prstGeom>
+          <a:solidFill>
+            <a:srgbClr val="0D132A"/>
+          </a:solidFill>
+          <a:ln w="12700">
+            <a:solidFill>
+              <a:srgbClr val="8C5DFF"/>
+            </a:solidFill>
+          </a:ln>
+          <a:effectLst/>
+        </p:spPr>
+        <p:style>
+          <a:lnRef idx="1">
+            <a:schemeClr val="accent1"/>
+          </a:lnRef>
+          <a:fillRef idx="3">
+            <a:schemeClr val="accent1"/>
+          </a:fillRef>
+          <a:effectRef idx="2">
+            <a:schemeClr val="accent1"/>
+          </a:effectRef>
+          <a:fontRef idx="minor">
+            <a:schemeClr val="lt1"/>
+          </a:fontRef>
+        </p:style>
+        <p:txBody>
+          <a:bodyPr rtlCol="0" anchor="ctr"/>
+          <a:lstStyle/>
+          <a:p>
+            <a:pPr algn="ctr"/>
+          </a:p>
+        </p:txBody>
+      </p:sp>
+      <p:sp>
+        <p:nvSpPr>
+          <p:cNvPr id="259" name="TextBox 258"/>
+          <p:cNvSpPr txBox="1"/>
+          <p:nvPr/>
+        </p:nvSpPr>
+        <p:spPr>
+          <a:xfrm>
+            <a:off x="5129783" y="2148840"/>
+            <a:ext cx="1947672" cy="841248"/>
+          </a:xfrm>
+          <a:prstGeom prst="rect">
+            <a:avLst/>
+          </a:prstGeom>
+          <a:noFill/>
+        </p:spPr>
+        <p:txBody>
+          <a:bodyPr wrap="square" lIns="27425" rIns="27425" tIns="22850" bIns="22850" anchor="ctr">
+            <a:spAutoFit/>
+          </a:bodyPr>
+          <a:lstStyle/>
+          <a:p>
+            <a:pPr algn="ctr"/>
+            <a:r>
+              <a:rPr sz="1000" b="1">
+                <a:solidFill>
+                  <a:srgbClr val="8C5DFF"/>
+                </a:solidFill>
+                <a:latin typeface="Arial"/>
+              </a:rPr>
+              <a:t>SAVE A LIBRARY</a:t>
+            </a:r>
+          </a:p>
+          <a:p>
+            <a:pPr algn="ctr">
+              <a:spcBef>
+                <a:spcPts val="400"/>
+              </a:spcBef>
+            </a:pPr>
+            <a:r>
+              <a:rPr sz="1000" b="0">
+                <a:solidFill>
+                  <a:srgbClr val="F4F8FF"/>
+                </a:solidFill>
+                <a:latin typeface="Arial"/>
+              </a:rPr>
+              <a:t>each problem's shape + its best 2 dials</a:t>
+            </a:r>
+          </a:p>
+        </p:txBody>
+      </p:sp>
+      <p:cxnSp>
+        <p:nvCxnSpPr>
+          <p:cNvPr id="260" name="Connector 259"/>
+          <p:cNvCxnSpPr/>
+          <p:nvPr/>
+        </p:nvCxnSpPr>
+        <p:spPr>
+          <a:xfrm>
+            <a:off x="7141463" y="2569464"/>
+            <a:ext cx="192025" cy="0"/>
+          </a:xfrm>
+          <a:prstGeom prst="line">
+            <a:avLst/>
+          </a:prstGeom>
+          <a:ln w="15875">
+            <a:solidFill>
+              <a:srgbClr val="374D73"/>
+            </a:solidFill>
+            <a:tailEnd type="triangle" w="med" len="med"/>
+          </a:ln>
+        </p:spPr>
+        <p:style>
+          <a:lnRef idx="2">
+            <a:schemeClr val="accent1"/>
+          </a:lnRef>
+          <a:fillRef idx="0">
+            <a:schemeClr val="accent1"/>
+          </a:fillRef>
+          <a:effectRef idx="1">
+            <a:schemeClr val="accent1"/>
+          </a:effectRef>
+          <a:fontRef idx="minor">
+            <a:schemeClr val="tx1"/>
+          </a:fontRef>
+        </p:style>
+      </p:cxnSp>
+      <p:sp>
+        <p:nvSpPr>
+          <p:cNvPr id="261" name="Rounded Rectangle 260"/>
+          <p:cNvSpPr/>
+          <p:nvPr/>
+        </p:nvSpPr>
+        <p:spPr>
+          <a:xfrm>
+            <a:off x="7351775" y="2148840"/>
+            <a:ext cx="2039112" cy="841248"/>
+          </a:xfrm>
+          <a:prstGeom prst="roundRect">
+            <a:avLst>
+              <a:gd name="adj" fmla="val 20000"/>
+            </a:avLst>
+          </a:prstGeom>
+          <a:solidFill>
+            <a:srgbClr val="0D132A"/>
+          </a:solidFill>
+          <a:ln w="12700">
+            <a:solidFill>
+              <a:srgbClr val="5BF0B9"/>
+            </a:solidFill>
+          </a:ln>
+          <a:effectLst/>
+        </p:spPr>
+        <p:style>
+          <a:lnRef idx="1">
+            <a:schemeClr val="accent1"/>
+          </a:lnRef>
+          <a:fillRef idx="3">
+            <a:schemeClr val="accent1"/>
+          </a:fillRef>
+          <a:effectRef idx="2">
+            <a:schemeClr val="accent1"/>
+          </a:effectRef>
+          <a:fontRef idx="minor">
+            <a:schemeClr val="lt1"/>
+          </a:fontRef>
+        </p:style>
+        <p:txBody>
+          <a:bodyPr rtlCol="0" anchor="ctr"/>
+          <a:lstStyle/>
+          <a:p>
+            <a:pPr algn="ctr"/>
+          </a:p>
+        </p:txBody>
+      </p:sp>
+      <p:sp>
+        <p:nvSpPr>
+          <p:cNvPr id="262" name="TextBox 261"/>
+          <p:cNvSpPr txBox="1"/>
+          <p:nvPr/>
+        </p:nvSpPr>
+        <p:spPr>
+          <a:xfrm>
+            <a:off x="7397496" y="2148840"/>
+            <a:ext cx="1947672" cy="841248"/>
+          </a:xfrm>
+          <a:prstGeom prst="rect">
+            <a:avLst/>
+          </a:prstGeom>
+          <a:noFill/>
+        </p:spPr>
+        <p:txBody>
+          <a:bodyPr wrap="square" lIns="27425" rIns="27425" tIns="22850" bIns="22850" anchor="ctr">
+            <a:spAutoFit/>
+          </a:bodyPr>
+          <a:lstStyle/>
+          <a:p>
+            <a:pPr algn="ctr"/>
+            <a:r>
+              <a:rPr sz="1000" b="1">
+                <a:solidFill>
+                  <a:srgbClr val="5BF0B9"/>
+                </a:solidFill>
+                <a:latin typeface="Arial"/>
+              </a:rPr>
+              <a:t>NEW PROBLEM ARRIVES</a:t>
+            </a:r>
+          </a:p>
+          <a:p>
+            <a:pPr algn="ctr">
+              <a:spcBef>
+                <a:spcPts val="400"/>
+              </a:spcBef>
+            </a:pPr>
+            <a:r>
+              <a:rPr sz="1000" b="0">
+                <a:solidFill>
+                  <a:srgbClr val="F4F8FF"/>
+                </a:solidFill>
+                <a:latin typeface="Arial"/>
+              </a:rPr>
+              <a:t>find the closest shape in another industry</a:t>
+            </a:r>
+          </a:p>
+        </p:txBody>
+      </p:sp>
+      <p:cxnSp>
+        <p:nvCxnSpPr>
+          <p:cNvPr id="263" name="Connector 262"/>
+          <p:cNvCxnSpPr/>
+          <p:nvPr/>
+        </p:nvCxnSpPr>
+        <p:spPr>
+          <a:xfrm>
+            <a:off x="9409176" y="2569464"/>
+            <a:ext cx="192024" cy="0"/>
+          </a:xfrm>
+          <a:prstGeom prst="line">
+            <a:avLst/>
+          </a:prstGeom>
+          <a:ln w="15875">
+            <a:solidFill>
+              <a:srgbClr val="374D73"/>
+            </a:solidFill>
+            <a:tailEnd type="triangle" w="med" len="med"/>
+          </a:ln>
+        </p:spPr>
+        <p:style>
+          <a:lnRef idx="2">
+            <a:schemeClr val="accent1"/>
+          </a:lnRef>
+          <a:fillRef idx="0">
+            <a:schemeClr val="accent1"/>
+          </a:fillRef>
+          <a:effectRef idx="1">
+            <a:schemeClr val="accent1"/>
+          </a:effectRef>
+          <a:fontRef idx="minor">
+            <a:schemeClr val="tx1"/>
+          </a:fontRef>
+        </p:style>
+      </p:cxnSp>
+      <p:sp>
+        <p:nvSpPr>
+          <p:cNvPr id="264" name="Rounded Rectangle 263"/>
+          <p:cNvSpPr/>
+          <p:nvPr/>
+        </p:nvSpPr>
+        <p:spPr>
+          <a:xfrm>
+            <a:off x="9619488" y="2148840"/>
+            <a:ext cx="2039112" cy="841248"/>
+          </a:xfrm>
+          <a:prstGeom prst="roundRect">
+            <a:avLst>
+              <a:gd name="adj" fmla="val 20000"/>
+            </a:avLst>
+          </a:prstGeom>
+          <a:solidFill>
+            <a:srgbClr val="0D132A"/>
+          </a:solidFill>
+          <a:ln w="12700">
+            <a:solidFill>
+              <a:srgbClr val="FFCA5C"/>
+            </a:solidFill>
+          </a:ln>
+          <a:effectLst/>
+        </p:spPr>
+        <p:style>
+          <a:lnRef idx="1">
+            <a:schemeClr val="accent1"/>
+          </a:lnRef>
+          <a:fillRef idx="3">
+            <a:schemeClr val="accent1"/>
+          </a:fillRef>
+          <a:effectRef idx="2">
+            <a:schemeClr val="accent1"/>
+          </a:effectRef>
+          <a:fontRef idx="minor">
+            <a:schemeClr val="lt1"/>
+          </a:fontRef>
+        </p:style>
+        <p:txBody>
+          <a:bodyPr rtlCol="0" anchor="ctr"/>
+          <a:lstStyle/>
+          <a:p>
+            <a:pPr algn="ctr"/>
+          </a:p>
+        </p:txBody>
+      </p:sp>
+      <p:sp>
+        <p:nvSpPr>
+          <p:cNvPr id="265" name="TextBox 264"/>
+          <p:cNvSpPr txBox="1"/>
+          <p:nvPr/>
+        </p:nvSpPr>
+        <p:spPr>
+          <a:xfrm>
+            <a:off x="9665208" y="2148840"/>
+            <a:ext cx="1947672" cy="841248"/>
+          </a:xfrm>
+          <a:prstGeom prst="rect">
+            <a:avLst/>
+          </a:prstGeom>
+          <a:noFill/>
+        </p:spPr>
+        <p:txBody>
+          <a:bodyPr wrap="square" lIns="27425" rIns="27425" tIns="22850" bIns="22850" anchor="ctr">
+            <a:spAutoFit/>
+          </a:bodyPr>
+          <a:lstStyle/>
+          <a:p>
+            <a:pPr algn="ctr"/>
+            <a:r>
+              <a:rPr sz="1000" b="1">
+                <a:solidFill>
+                  <a:srgbClr val="FFCA5C"/>
+                </a:solidFill>
+                <a:latin typeface="Arial"/>
+              </a:rPr>
+              <a:t>COPY + RUN ONCE</a:t>
+            </a:r>
+          </a:p>
+          <a:p>
+            <a:pPr algn="ctr">
+              <a:spcBef>
+                <a:spcPts val="400"/>
+              </a:spcBef>
+            </a:pPr>
+            <a:r>
+              <a:rPr sz="1000" b="0">
+                <a:solidFill>
+                  <a:srgbClr val="F4F8FF"/>
+                </a:solidFill>
+                <a:latin typeface="Arial"/>
+              </a:rPr>
+              <a:t>1 try instead of 60</a:t>
+            </a:r>
           </a:p>
         </p:txBody>
       </p:sp>
       <p:graphicFrame>
         <p:nvGraphicFramePr>
-          <p:cNvPr id="252" name="Chart 251"/>
+          <p:cNvPr id="266" name="Chart 265"/>
           <p:cNvGraphicFramePr>
             <a:graphicFrameLocks noGrp="1"/>
           </p:cNvGraphicFramePr>
           <p:nvPr/>
         </p:nvGraphicFramePr>
         <p:xfrm>
-          <a:off x="548640" y="2194560"/>
-          <a:ext cx="5760720" cy="3017520"/>
+          <a:off x="548640" y="3154680"/>
+          <a:ext cx="5760720" cy="2103120"/>
         </p:xfrm>
         <a:graphic>
           <a:graphicData uri="http://schemas.openxmlformats.org/drawingml/2006/chart">
@@ -29068,13 +29627,13 @@
       </p:graphicFrame>
       <p:sp>
         <p:nvSpPr>
-          <p:cNvPr id="253" name="TextBox 252"/>
+          <p:cNvPr id="267" name="TextBox 266"/>
           <p:cNvSpPr txBox="1"/>
           <p:nvPr/>
         </p:nvSpPr>
         <p:spPr>
           <a:xfrm>
-            <a:off x="548640" y="5230368"/>
+            <a:off x="548640" y="5257800"/>
             <a:ext cx="5760720" cy="274320"/>
           </a:xfrm>
           <a:prstGeom prst="rect">
@@ -29096,22 +29655,184 @@
                 </a:solidFill>
                 <a:latin typeface="Arial"/>
               </a:rPr>
-              <a:t>All 60 problems · score 1 = best, 0 = random guess · ± 0.02 standard error</a:t>
+              <a:t>All 60 problems tested this way · score 1 = best, 0 = random · ± 0.02</a:t>
+            </a:r>
+          </a:p>
+        </p:txBody>
+      </p:sp>
+      <p:sp>
+        <p:nvSpPr>
+          <p:cNvPr id="268" name="Rounded Rectangle 267"/>
+          <p:cNvSpPr/>
+          <p:nvPr/>
+        </p:nvSpPr>
+        <p:spPr>
+          <a:xfrm>
+            <a:off x="6583680" y="3154680"/>
+            <a:ext cx="5074920" cy="1051560"/>
+          </a:xfrm>
+          <a:prstGeom prst="roundRect">
+            <a:avLst>
+              <a:gd name="adj" fmla="val 12000"/>
+            </a:avLst>
+          </a:prstGeom>
+          <a:solidFill>
+            <a:srgbClr val="0D132A"/>
+          </a:solidFill>
+          <a:ln w="12700">
+            <a:solidFill>
+              <a:srgbClr val="233558"/>
+            </a:solidFill>
+          </a:ln>
+          <a:effectLst/>
+        </p:spPr>
+        <p:style>
+          <a:lnRef idx="1">
+            <a:schemeClr val="accent1"/>
+          </a:lnRef>
+          <a:fillRef idx="3">
+            <a:schemeClr val="accent1"/>
+          </a:fillRef>
+          <a:effectRef idx="2">
+            <a:schemeClr val="accent1"/>
+          </a:effectRef>
+          <a:fontRef idx="minor">
+            <a:schemeClr val="lt1"/>
+          </a:fontRef>
+        </p:style>
+        <p:txBody>
+          <a:bodyPr rtlCol="0" anchor="ctr"/>
+          <a:lstStyle/>
+          <a:p>
+            <a:pPr algn="ctr"/>
+          </a:p>
+        </p:txBody>
+      </p:sp>
+      <p:sp>
+        <p:nvSpPr>
+          <p:cNvPr id="269" name="Rectangle 268"/>
+          <p:cNvSpPr/>
+          <p:nvPr/>
+        </p:nvSpPr>
+        <p:spPr>
+          <a:xfrm>
+            <a:off x="6748272" y="3337560"/>
+            <a:ext cx="50292" cy="685799"/>
+          </a:xfrm>
+          <a:prstGeom prst="rect">
+            <a:avLst/>
+          </a:prstGeom>
+          <a:solidFill>
+            <a:srgbClr val="27D6FF"/>
+          </a:solidFill>
+          <a:ln>
+            <a:noFill/>
+          </a:ln>
+          <a:effectLst/>
+        </p:spPr>
+        <p:style>
+          <a:lnRef idx="1">
+            <a:schemeClr val="accent1"/>
+          </a:lnRef>
+          <a:fillRef idx="3">
+            <a:schemeClr val="accent1"/>
+          </a:fillRef>
+          <a:effectRef idx="2">
+            <a:schemeClr val="accent1"/>
+          </a:effectRef>
+          <a:fontRef idx="minor">
+            <a:schemeClr val="lt1"/>
+          </a:fontRef>
+        </p:style>
+        <p:txBody>
+          <a:bodyPr rtlCol="0" anchor="ctr"/>
+          <a:lstStyle/>
+          <a:p>
+            <a:pPr algn="ctr"/>
+          </a:p>
+        </p:txBody>
+      </p:sp>
+      <p:sp>
+        <p:nvSpPr>
+          <p:cNvPr id="270" name="TextBox 269"/>
+          <p:cNvSpPr txBox="1"/>
+          <p:nvPr/>
+        </p:nvSpPr>
+        <p:spPr>
+          <a:xfrm>
+            <a:off x="6912864" y="3319272"/>
+            <a:ext cx="4617720" cy="201168"/>
+          </a:xfrm>
+          <a:prstGeom prst="rect">
+            <a:avLst/>
+          </a:prstGeom>
+          <a:noFill/>
+        </p:spPr>
+        <p:txBody>
+          <a:bodyPr wrap="square" lIns="27425" rIns="27425" tIns="22850" bIns="22850" anchor="t">
+            <a:spAutoFit/>
+          </a:bodyPr>
+          <a:lstStyle/>
+          <a:p>
+            <a:pPr algn="l"/>
+            <a:r>
+              <a:rPr sz="900" b="1">
+                <a:solidFill>
+                  <a:srgbClr val="27D6FF"/>
+                </a:solidFill>
+                <a:latin typeface="Arial"/>
+              </a:rPr>
+              <a:t>WHAT "THE DIALS" ARE</a:t>
+            </a:r>
+          </a:p>
+        </p:txBody>
+      </p:sp>
+      <p:sp>
+        <p:nvSpPr>
+          <p:cNvPr id="271" name="TextBox 270"/>
+          <p:cNvSpPr txBox="1"/>
+          <p:nvPr/>
+        </p:nvSpPr>
+        <p:spPr>
+          <a:xfrm>
+            <a:off x="6912864" y="3566160"/>
+            <a:ext cx="4599431" cy="530351"/>
+          </a:xfrm>
+          <a:prstGeom prst="rect">
+            <a:avLst/>
+          </a:prstGeom>
+          <a:noFill/>
+        </p:spPr>
+        <p:txBody>
+          <a:bodyPr wrap="square" lIns="27425" rIns="27425" tIns="22850" bIns="22850" anchor="t">
+            <a:spAutoFit/>
+          </a:bodyPr>
+          <a:lstStyle/>
+          <a:p>
+            <a:pPr algn="l"/>
+            <a:r>
+              <a:rPr sz="1100" b="0">
+                <a:solidFill>
+                  <a:srgbClr val="A1B1CD"/>
+                </a:solidFill>
+                <a:latin typeface="Arial"/>
+              </a:rPr>
+              <a:t>Two numbers that set the gate-based recipe: how hard to push and link choices (γ) and how much to shuffle answers (β).</a:t>
             </a:r>
           </a:p>
         </p:txBody>
       </p:sp>
       <p:graphicFrame>
         <p:nvGraphicFramePr>
-          <p:cNvPr id="254" name="Table 253"/>
+          <p:cNvPr id="272" name="Table 271"/>
           <p:cNvGraphicFramePr>
             <a:graphicFrameLocks noGrp="1"/>
           </p:cNvGraphicFramePr>
           <p:nvPr/>
         </p:nvGraphicFramePr>
         <p:xfrm>
-          <a:off x="6583680" y="2194560"/>
-          <a:ext cx="5074920" cy="1463040"/>
+          <a:off x="6583680" y="4315968"/>
+          <a:ext cx="5074920" cy="1143000"/>
         </p:xfrm>
         <a:graphic>
           <a:graphicData uri="http://schemas.openxmlformats.org/drawingml/2006/table">
@@ -29124,14 +29845,14 @@
                 <a:gridCol w="914400"/>
                 <a:gridCol w="914400"/>
               </a:tblGrid>
-              <a:tr h="292608">
+              <a:tr h="228600">
                 <a:tc>
                   <a:txBody>
                     <a:bodyPr/>
                     <a:lstStyle/>
                     <a:p>
                       <a:r>
-                        <a:rPr sz="1000" b="1">
+                        <a:rPr sz="900" b="1">
                           <a:solidFill>
                             <a:srgbClr val="F4F8FF"/>
                           </a:solidFill>
@@ -29153,7 +29874,7 @@
                     <a:lstStyle/>
                     <a:p>
                       <a:r>
-                        <a:rPr sz="1000" b="1">
+                        <a:rPr sz="900" b="1">
                           <a:solidFill>
                             <a:srgbClr val="F4F8FF"/>
                           </a:solidFill>
@@ -29175,7 +29896,7 @@
                     <a:lstStyle/>
                     <a:p>
                       <a:r>
-                        <a:rPr sz="1000" b="1">
+                        <a:rPr sz="900" b="1">
                           <a:solidFill>
                             <a:srgbClr val="F4F8FF"/>
                           </a:solidFill>
@@ -29197,7 +29918,7 @@
                     <a:lstStyle/>
                     <a:p>
                       <a:r>
-                        <a:rPr sz="1000" b="1">
+                        <a:rPr sz="900" b="1">
                           <a:solidFill>
                             <a:srgbClr val="F4F8FF"/>
                           </a:solidFill>
@@ -29219,7 +29940,7 @@
                     <a:lstStyle/>
                     <a:p>
                       <a:r>
-                        <a:rPr sz="1000" b="1">
+                        <a:rPr sz="900" b="1">
                           <a:solidFill>
                             <a:srgbClr val="F4F8FF"/>
                           </a:solidFill>
@@ -29236,14 +29957,14 @@
                   </a:tcPr>
                 </a:tc>
               </a:tr>
-              <a:tr h="292608">
+              <a:tr h="228600">
                 <a:tc>
                   <a:txBody>
                     <a:bodyPr/>
                     <a:lstStyle/>
                     <a:p>
                       <a:r>
-                        <a:rPr sz="1000" b="0">
+                        <a:rPr sz="900" b="0">
                           <a:solidFill>
                             <a:srgbClr val="A1B1CD"/>
                           </a:solidFill>
@@ -29265,7 +29986,7 @@
                     <a:lstStyle/>
                     <a:p>
                       <a:r>
-                        <a:rPr sz="1000" b="0">
+                        <a:rPr sz="900" b="0">
                           <a:solidFill>
                             <a:srgbClr val="A1B1CD"/>
                           </a:solidFill>
@@ -29287,7 +30008,7 @@
                     <a:lstStyle/>
                     <a:p>
                       <a:r>
-                        <a:rPr sz="1000" b="0">
+                        <a:rPr sz="900" b="0">
                           <a:solidFill>
                             <a:srgbClr val="A1B1CD"/>
                           </a:solidFill>
@@ -29309,7 +30030,7 @@
                     <a:lstStyle/>
                     <a:p>
                       <a:r>
-                        <a:rPr sz="1000" b="0">
+                        <a:rPr sz="900" b="0">
                           <a:solidFill>
                             <a:srgbClr val="A1B1CD"/>
                           </a:solidFill>
@@ -29331,7 +30052,7 @@
                     <a:lstStyle/>
                     <a:p>
                       <a:r>
-                        <a:rPr sz="1000" b="0">
+                        <a:rPr sz="900" b="0">
                           <a:solidFill>
                             <a:srgbClr val="A1B1CD"/>
                           </a:solidFill>
@@ -29348,14 +30069,14 @@
                   </a:tcPr>
                 </a:tc>
               </a:tr>
-              <a:tr h="292608">
+              <a:tr h="228600">
                 <a:tc>
                   <a:txBody>
                     <a:bodyPr/>
                     <a:lstStyle/>
                     <a:p>
                       <a:r>
-                        <a:rPr sz="1000" b="0">
+                        <a:rPr sz="900" b="0">
                           <a:solidFill>
                             <a:srgbClr val="A1B1CD"/>
                           </a:solidFill>
@@ -29377,7 +30098,7 @@
                     <a:lstStyle/>
                     <a:p>
                       <a:r>
-                        <a:rPr sz="1000" b="0">
+                        <a:rPr sz="900" b="0">
                           <a:solidFill>
                             <a:srgbClr val="A1B1CD"/>
                           </a:solidFill>
@@ -29399,7 +30120,7 @@
                     <a:lstStyle/>
                     <a:p>
                       <a:r>
-                        <a:rPr sz="1000" b="0">
+                        <a:rPr sz="900" b="0">
                           <a:solidFill>
                             <a:srgbClr val="A1B1CD"/>
                           </a:solidFill>
@@ -29421,7 +30142,7 @@
                     <a:lstStyle/>
                     <a:p>
                       <a:r>
-                        <a:rPr sz="1000" b="0">
+                        <a:rPr sz="900" b="0">
                           <a:solidFill>
                             <a:srgbClr val="A1B1CD"/>
                           </a:solidFill>
@@ -29443,7 +30164,7 @@
                     <a:lstStyle/>
                     <a:p>
                       <a:r>
-                        <a:rPr sz="1000" b="0">
+                        <a:rPr sz="900" b="0">
                           <a:solidFill>
                             <a:srgbClr val="A1B1CD"/>
                           </a:solidFill>
@@ -29460,14 +30181,14 @@
                   </a:tcPr>
                 </a:tc>
               </a:tr>
-              <a:tr h="292608">
+              <a:tr h="228600">
                 <a:tc>
                   <a:txBody>
                     <a:bodyPr/>
                     <a:lstStyle/>
                     <a:p>
                       <a:r>
-                        <a:rPr sz="1000" b="0">
+                        <a:rPr sz="900" b="0">
                           <a:solidFill>
                             <a:srgbClr val="A1B1CD"/>
                           </a:solidFill>
@@ -29489,7 +30210,7 @@
                     <a:lstStyle/>
                     <a:p>
                       <a:r>
-                        <a:rPr sz="1000" b="0">
+                        <a:rPr sz="900" b="0">
                           <a:solidFill>
                             <a:srgbClr val="A1B1CD"/>
                           </a:solidFill>
@@ -29511,7 +30232,7 @@
                     <a:lstStyle/>
                     <a:p>
                       <a:r>
-                        <a:rPr sz="1000" b="0">
+                        <a:rPr sz="900" b="0">
                           <a:solidFill>
                             <a:srgbClr val="A1B1CD"/>
                           </a:solidFill>
@@ -29533,7 +30254,7 @@
                     <a:lstStyle/>
                     <a:p>
                       <a:r>
-                        <a:rPr sz="1000" b="0">
+                        <a:rPr sz="900" b="0">
                           <a:solidFill>
                             <a:srgbClr val="A1B1CD"/>
                           </a:solidFill>
@@ -29555,7 +30276,7 @@
                     <a:lstStyle/>
                     <a:p>
                       <a:r>
-                        <a:rPr sz="1000" b="0">
+                        <a:rPr sz="900" b="0">
                           <a:solidFill>
                             <a:srgbClr val="A1B1CD"/>
                           </a:solidFill>
@@ -29572,14 +30293,14 @@
                   </a:tcPr>
                 </a:tc>
               </a:tr>
-              <a:tr h="292608">
+              <a:tr h="228600">
                 <a:tc>
                   <a:txBody>
                     <a:bodyPr/>
                     <a:lstStyle/>
                     <a:p>
                       <a:r>
-                        <a:rPr sz="1000" b="0">
+                        <a:rPr sz="900" b="0">
                           <a:solidFill>
                             <a:srgbClr val="A1B1CD"/>
                           </a:solidFill>
@@ -29601,7 +30322,7 @@
                     <a:lstStyle/>
                     <a:p>
                       <a:r>
-                        <a:rPr sz="1000" b="0">
+                        <a:rPr sz="900" b="0">
                           <a:solidFill>
                             <a:srgbClr val="A1B1CD"/>
                           </a:solidFill>
@@ -29623,7 +30344,7 @@
                     <a:lstStyle/>
                     <a:p>
                       <a:r>
-                        <a:rPr sz="1000" b="0">
+                        <a:rPr sz="900" b="0">
                           <a:solidFill>
                             <a:srgbClr val="A1B1CD"/>
                           </a:solidFill>
@@ -29645,7 +30366,7 @@
                     <a:lstStyle/>
                     <a:p>
                       <a:r>
-                        <a:rPr sz="1000" b="0">
+                        <a:rPr sz="900" b="0">
                           <a:solidFill>
                             <a:srgbClr val="A1B1CD"/>
                           </a:solidFill>
@@ -29667,7 +30388,7 @@
                     <a:lstStyle/>
                     <a:p>
                       <a:r>
-                        <a:rPr sz="1000" b="0">
+                        <a:rPr sz="900" b="0">
                           <a:solidFill>
                             <a:srgbClr val="A1B1CD"/>
                           </a:solidFill>
@@ -29690,26 +30411,26 @@
       </p:graphicFrame>
       <p:sp>
         <p:nvSpPr>
-          <p:cNvPr id="255" name="Rounded Rectangle 254"/>
+          <p:cNvPr id="273" name="Rounded Rectangle 272"/>
           <p:cNvSpPr/>
           <p:nvPr/>
         </p:nvSpPr>
         <p:spPr>
           <a:xfrm>
-            <a:off x="6583680" y="3794760"/>
-            <a:ext cx="5074920" cy="1417320"/>
+            <a:off x="822960" y="5623560"/>
+            <a:ext cx="10424160" cy="438912"/>
           </a:xfrm>
           <a:prstGeom prst="roundRect">
             <a:avLst>
-              <a:gd name="adj" fmla="val 12000"/>
+              <a:gd name="adj" fmla="val 20000"/>
             </a:avLst>
           </a:prstGeom>
           <a:solidFill>
-            <a:srgbClr val="0D132A"/>
+            <a:srgbClr val="121B37"/>
           </a:solidFill>
           <a:ln w="12700">
             <a:solidFill>
-              <a:srgbClr val="233558"/>
+              <a:srgbClr val="FFCA5C"/>
             </a:solidFill>
           </a:ln>
           <a:effectLst/>
@@ -29738,176 +30459,14 @@
       </p:sp>
       <p:sp>
         <p:nvSpPr>
-          <p:cNvPr id="256" name="Rectangle 255"/>
-          <p:cNvSpPr/>
+          <p:cNvPr id="274" name="TextBox 273"/>
+          <p:cNvSpPr txBox="1"/>
           <p:nvPr/>
         </p:nvSpPr>
         <p:spPr>
           <a:xfrm>
-            <a:off x="6748272" y="3977640"/>
-            <a:ext cx="50292" cy="1051560"/>
-          </a:xfrm>
-          <a:prstGeom prst="rect">
-            <a:avLst/>
-          </a:prstGeom>
-          <a:solidFill>
-            <a:srgbClr val="27D6FF"/>
-          </a:solidFill>
-          <a:ln>
-            <a:noFill/>
-          </a:ln>
-          <a:effectLst/>
-        </p:spPr>
-        <p:style>
-          <a:lnRef idx="1">
-            <a:schemeClr val="accent1"/>
-          </a:lnRef>
-          <a:fillRef idx="3">
-            <a:schemeClr val="accent1"/>
-          </a:fillRef>
-          <a:effectRef idx="2">
-            <a:schemeClr val="accent1"/>
-          </a:effectRef>
-          <a:fontRef idx="minor">
-            <a:schemeClr val="lt1"/>
-          </a:fontRef>
-        </p:style>
-        <p:txBody>
-          <a:bodyPr rtlCol="0" anchor="ctr"/>
-          <a:lstStyle/>
-          <a:p>
-            <a:pPr algn="ctr"/>
-          </a:p>
-        </p:txBody>
-      </p:sp>
-      <p:sp>
-        <p:nvSpPr>
-          <p:cNvPr id="257" name="TextBox 256"/>
-          <p:cNvSpPr txBox="1"/>
-          <p:nvPr/>
-        </p:nvSpPr>
-        <p:spPr>
-          <a:xfrm>
-            <a:off x="6912864" y="3959352"/>
-            <a:ext cx="4617720" cy="201168"/>
-          </a:xfrm>
-          <a:prstGeom prst="rect">
-            <a:avLst/>
-          </a:prstGeom>
-          <a:noFill/>
-        </p:spPr>
-        <p:txBody>
-          <a:bodyPr wrap="square" lIns="27425" rIns="27425" tIns="22850" bIns="22850" anchor="t">
-            <a:spAutoFit/>
-          </a:bodyPr>
-          <a:lstStyle/>
-          <a:p>
-            <a:pPr algn="l"/>
-            <a:r>
-              <a:rPr sz="900" b="1">
-                <a:solidFill>
-                  <a:srgbClr val="27D6FF"/>
-                </a:solidFill>
-                <a:latin typeface="Arial"/>
-              </a:rPr>
-              <a:t>HOW THE TWIN IS FOUND</a:t>
-            </a:r>
-          </a:p>
-        </p:txBody>
-      </p:sp>
-      <p:sp>
-        <p:nvSpPr>
-          <p:cNvPr id="258" name="TextBox 257"/>
-          <p:cNvSpPr txBox="1"/>
-          <p:nvPr/>
-        </p:nvSpPr>
-        <p:spPr>
-          <a:xfrm>
-            <a:off x="6912864" y="4206240"/>
-            <a:ext cx="4599431" cy="896111"/>
-          </a:xfrm>
-          <a:prstGeom prst="rect">
-            <a:avLst/>
-          </a:prstGeom>
-          <a:noFill/>
-        </p:spPr>
-        <p:txBody>
-          <a:bodyPr wrap="square" lIns="27425" rIns="27425" tIns="22850" bIns="22850" anchor="t">
-            <a:spAutoFit/>
-          </a:bodyPr>
-          <a:lstStyle/>
-          <a:p>
-            <a:pPr algn="l"/>
-            <a:r>
-              <a:rPr sz="1100" b="0">
-                <a:solidFill>
-                  <a:srgbClr val="A1B1CD"/>
-                </a:solidFill>
-                <a:latin typeface="Arial"/>
-              </a:rPr>
-              <a:t>Rescale the nine numbers, measure the distance between fingerprints, keep only other industries, take the closest. A lookup, not a guess.</a:t>
-            </a:r>
-          </a:p>
-        </p:txBody>
-      </p:sp>
-      <p:sp>
-        <p:nvSpPr>
-          <p:cNvPr id="259" name="Rounded Rectangle 258"/>
-          <p:cNvSpPr/>
-          <p:nvPr/>
-        </p:nvSpPr>
-        <p:spPr>
-          <a:xfrm>
-            <a:off x="822960" y="5577840"/>
-            <a:ext cx="10424160" cy="457200"/>
-          </a:xfrm>
-          <a:prstGeom prst="roundRect">
-            <a:avLst>
-              <a:gd name="adj" fmla="val 20000"/>
-            </a:avLst>
-          </a:prstGeom>
-          <a:solidFill>
-            <a:srgbClr val="121B37"/>
-          </a:solidFill>
-          <a:ln w="12700">
-            <a:solidFill>
-              <a:srgbClr val="FFCA5C"/>
-            </a:solidFill>
-          </a:ln>
-          <a:effectLst/>
-        </p:spPr>
-        <p:style>
-          <a:lnRef idx="1">
-            <a:schemeClr val="accent1"/>
-          </a:lnRef>
-          <a:fillRef idx="3">
-            <a:schemeClr val="accent1"/>
-          </a:fillRef>
-          <a:effectRef idx="2">
-            <a:schemeClr val="accent1"/>
-          </a:effectRef>
-          <a:fontRef idx="minor">
-            <a:schemeClr val="lt1"/>
-          </a:fontRef>
-        </p:style>
-        <p:txBody>
-          <a:bodyPr rtlCol="0" anchor="ctr"/>
-          <a:lstStyle/>
-          <a:p>
-            <a:pPr algn="ctr"/>
-          </a:p>
-        </p:txBody>
-      </p:sp>
-      <p:sp>
-        <p:nvSpPr>
-          <p:cNvPr id="260" name="TextBox 259"/>
-          <p:cNvSpPr txBox="1"/>
-          <p:nvPr/>
-        </p:nvSpPr>
-        <p:spPr>
-          <a:xfrm>
-            <a:off x="1005840" y="5577840"/>
-            <a:ext cx="10058400" cy="457200"/>
+            <a:off x="1005840" y="5623560"/>
+            <a:ext cx="10058400" cy="438912"/>
           </a:xfrm>
           <a:prstGeom prst="rect">
             <a:avLst/>
@@ -29928,7 +30487,7 @@
                 </a:solidFill>
                 <a:latin typeface="Arial"/>
               </a:rPr>
-              <a:t>TWIN BEATS A RANDOM COPY BY 0.023 ± 0.010 ON 65% OF PROBLEMS: THE SHAPE MATCH IS WHAT HELPS</a:t>
+              <a:t>COPYING FROM A SIMILAR SHAPE BEATS A RANDOM COPY (0.599 VS 0.577): HALF THE GAIN OF TUNING, 1/60 THE COST</a:t>
             </a:r>
           </a:p>
         </p:txBody>
@@ -31547,6 +32106,22 @@
               <a:t>stocks · drugs · network</a:t>
             </a:r>
           </a:p>
+          <a:p>
+            <a:pPr algn="ctr">
+              <a:spcBef>
+                <a:spcPts val="400"/>
+              </a:spcBef>
+            </a:pPr>
+            <a:r>
+              <a:rPr sz="900" b="1">
+                <a:solidFill>
+                  <a:srgbClr val="F4F8FF"/>
+                </a:solidFill>
+                <a:latin typeface="Arial"/>
+              </a:rPr>
+              <a:t>tune 1, the rest copy</a:t>
+            </a:r>
+          </a:p>
         </p:txBody>
       </p:sp>
       <p:sp>
@@ -31644,6 +32219,22 @@
                 <a:latin typeface="Arial"/>
               </a:rPr>
               <a:t>medical tests</a:t>
+            </a:r>
+          </a:p>
+          <a:p>
+            <a:pPr algn="ctr">
+              <a:spcBef>
+                <a:spcPts val="400"/>
+              </a:spcBef>
+            </a:pPr>
+            <a:r>
+              <a:rPr sz="900" b="1">
+                <a:solidFill>
+                  <a:srgbClr val="F4F8FF"/>
+                </a:solidFill>
+                <a:latin typeface="Arial"/>
+              </a:rPr>
+              <a:t>tuned on its own</a:t>
             </a:r>
           </a:p>
         </p:txBody>
@@ -35940,7 +36531,7 @@
                 </a:solidFill>
                 <a:latin typeface="Arial"/>
               </a:rPr>
-              <a:t>REAL DEVICE + NOISE ANALYSIS: SIMULATOR VS. CHIP COPY VS. IBM_KINGSTON, RAW AND MITIGATED</a:t>
+              <a:t>OVERALL ON THE REAL CHIP: GATE-BASED 0.64 BEATS ANNEALING 0.55 · THE LAPTOP (0.93) STILL WINS</a:t>
             </a:r>
           </a:p>
         </p:txBody>

</xml_diff>

<commit_message>
Speaker notes explain every number; correct twin gain to about a third of tuning's gain
Co-Authored-By: Claude Opus 5.5 <noreply@anthropic.com>
</commit_message>
<xml_diff>
--- a/slides/Q-Router_presentation.pptx
+++ b/slides/Q-Router_presentation.pptx
@@ -2592,7 +2592,7 @@
           <a:lstStyle/>
           <a:p>
             <a:r>
-              <a:t>SLIDE 1 · TITLE · target 0:20</a:t>
+              <a:t>SLIDE 1 · TITLE · speak for about 20 seconds</a:t>
             </a:r>
           </a:p>
           <a:p/>
@@ -2603,7 +2603,7 @@
           </a:p>
           <a:p>
             <a:r>
-              <a:t>"Hi, we're Team Q-Router from Florida Atlantic University. You can now rent quantum computers over the internet, and there are two very different kinds. Q-Router is a traffic controller for that scarce quantum time: it looks at the shape of a business decision and sends each piece to the right machine, or to a normal laptop when quantum isn't worth it. And we tested it on a real IBM quantum computer."</a:t>
+              <a:t>"Hi, we're Team Q-Router from Florida Atlantic University. You can now rent quantum computers over the internet, and there are two very different kinds. Q-Router is a traffic controller for scarce quantum time: it sends each piece of a business decision to the right machine, or to a laptop when quantum isn't worth it, and we tested it on a real IBM quantum computer."</a:t>
             </a:r>
           </a:p>
           <a:p/>
@@ -2614,23 +2614,28 @@
           </a:p>
           <a:p>
             <a:r>
-              <a:t>The four boxes (Problem, Fingerprint, Router, Method) are the pipeline in one line: a decision comes in, we measure its shape, the router picks, a method solves it.</a:t>
+              <a:t>The four boxes (Problem → Fingerprint → Router → Method) are the whole project in one line: a decision comes in, we measure its shape, the router picks a computer, and that computer solves it.</a:t>
             </a:r>
           </a:p>
           <a:p/>
           <a:p>
             <a:r>
-              <a:t>KEY FACTS TO HAVE READY</a:t>
-            </a:r>
-          </a:p>
-          <a:p>
-            <a:r>
-              <a:t>- Real hardware used: IBM's ibm_kingston, a 156-qubit Heron r2 processor (us-east), on the free Open Plan.</a:t>
-            </a:r>
-          </a:p>
-          <a:p>
-            <a:r>
-              <a:t>- 7 real quantum jobs, all batched; most of our 10 free minutes are still unused.</a:t>
+              <a:t>NUMBERS YOU MAY BE ASKED ABOUT</a:t>
+            </a:r>
+          </a:p>
+          <a:p>
+            <a:r>
+              <a:t>- ibm_kingston, 156 qubits = the real IBM quantum chip we used; it has 156 qubits (quantum bits), far more than our problems need.</a:t>
+            </a:r>
+          </a:p>
+          <a:p>
+            <a:r>
+              <a:t>- 7 jobs = we sent work to the real chip 7 separate times; everything else ran on normal computers.</a:t>
+            </a:r>
+          </a:p>
+          <a:p>
+            <a:r>
+              <a:t>- 10 minutes = all the real quantum computer time our free IBM plan gives us per 28 days. We used only a few minutes.</a:t>
             </a:r>
           </a:p>
           <a:p/>
@@ -2656,7 +2661,7 @@
           </a:p>
           <a:p>
             <a:r>
-              <a:t>A: (Fill in real names.) Our coder built the Qiskit program and ran the IBM jobs; the rest of the team framed the drug-funding problem, wrote the use case and limitations, and built this presentation. Everyone can explain the pipeline.</a:t>
+              <a:t>A: (Fill in real names.) Our coder built the Qiskit program and ran the IBM jobs; the rest of the team framed the drug-funding problem, wrote the use case and limitations, and built this presentation.</a:t>
             </a:r>
           </a:p>
         </p:txBody>
@@ -2796,7 +2801,7 @@
           <a:lstStyle/>
           <a:p>
             <a:r>
-              <a:t>SLIDE 11 · WHAT'S NEXT + TAKEAWAY · target 0:30</a:t>
+              <a:t>SLIDE 11 · WHAT'S NEXT + TAKEAWAY · speak for about 30 seconds</a:t>
             </a:r>
           </a:p>
           <a:p/>
@@ -2807,23 +2812,44 @@
           </a:p>
           <a:p>
             <a:r>
-              <a:t>"Next: repeat the real-chip runs to measure variation, use real drug-trial data from ClinicalTrials.gov, add a real D-Wave annealer as a third option, and wait for chips with 10 to 100 times fewer errors and 50 to 200 usable qubits, which is roughly what it would take for quantum to compete. Our takeaway: shape decides the solver. Dense goes to gate-based, sparse goes to annealing. And today the laptop still wins, and Q-Router knows when. Thank you, we'd love your questions."</a:t>
+              <a:t>"Next: repeat the real-chip runs to see how much results vary, use real drug-trial data, add a real D-Wave annealer as a third option, and wait for chips with 10 to 100 times fewer errors and 50 to 200 usable qubits, which is roughly what it would take for quantum to compete. Our takeaway: shape decides the solver. Dense goes to gate-based, sparse goes to annealing. And today the laptop still wins, and Q-Router knows when. Thank you, we'd love your questions."</a:t>
             </a:r>
           </a:p>
           <a:p/>
           <a:p>
             <a:r>
-              <a:t>WHAT'S NEW (for the novelty question)</a:t>
-            </a:r>
-          </a:p>
-          <a:p>
-            <a:r>
-              <a:t>1. Gate-based vs. annealing chosen piece by piece inside one problem, measured on real hardware.</a:t>
-            </a:r>
-          </a:p>
-          <a:p>
-            <a:r>
-              <a:t>2. Settings reused across real industries, with a random-copy control proving the shape match matters.</a:t>
+              <a:t>WHAT EACH NUMBER MEANS</a:t>
+            </a:r>
+          </a:p>
+          <a:p>
+            <a:r>
+              <a:t>- "10-100× fewer errors" = today's chips would need to make 10 to 100 times fewer mistakes per step before quantum could compete with a laptop on these problems.</a:t>
+            </a:r>
+          </a:p>
+          <a:p>
+            <a:r>
+              <a:t>- "50-200 usable qubits" = enough working qubits for real-size decisions (50 to 200 yes/no choices), plus extra for the chip's wiring.</a:t>
+            </a:r>
+          </a:p>
+          <a:p>
+            <a:r>
+              <a:t>- "Option 3" = a real D-Wave annealer would become a third quantum choice the router can pick, alongside gate-based and our copied annealing.</a:t>
+            </a:r>
+          </a:p>
+          <a:p/>
+          <a:p>
+            <a:r>
+              <a:t>WHAT'S NEW IN OUR PROJECT (for the novelty question)</a:t>
+            </a:r>
+          </a:p>
+          <a:p>
+            <a:r>
+              <a:t>1. Choosing gate-based or annealing piece by piece inside one problem, tested on real hardware.</a:t>
+            </a:r>
+          </a:p>
+          <a:p>
+            <a:r>
+              <a:t>2. Copying quantum settings across real industries, with a fair random comparison proving the shape match matters.</a:t>
             </a:r>
           </a:p>
           <a:p>
@@ -2833,12 +2859,12 @@
           </a:p>
           <a:p>
             <a:r>
-              <a:t>4. Quantum time saved, measured: 4× fewer shots, 1 job instead of 4.</a:t>
-            </a:r>
-          </a:p>
-          <a:p>
-            <a:r>
-              <a:t>Prior work exists for each ingredient (QAOA parameter transfer, solver selection, multi-programming); the combination and the cross-industry test on hardware are ours. Say "we didn't find prior work testing this", never "first ever".</a:t>
+              <a:t>4. Measured savings: 4× fewer quantum measurements, 1 job instead of 4.</a:t>
+            </a:r>
+          </a:p>
+          <a:p>
+            <a:r>
+              <a:t>Each ingredient has prior work; the combination and the cross-industry test on hardware are ours. Say "we didn't find prior work testing this", never "first ever".</a:t>
             </a:r>
           </a:p>
           <a:p/>
@@ -2849,7 +2875,7 @@
           </a:p>
           <a:p>
             <a:r>
-              <a:t>No quantum advantage; tiny problems (3-18 qubits); annealing is a copy on IBM's chip; drug data is simulated; single hardware runs; error fixes hurt on long recipes.</a:t>
+              <a:t>No quantum advantage (the laptop wins); our tests are tiny (3-18 choices vs 50-200 real); our annealing is a copy on IBM's chip; the drug data is made up; each hardware test ran once; IBM's error fixes hurt long recipes.</a:t>
             </a:r>
           </a:p>
           <a:p/>
@@ -2860,7 +2886,17 @@
           </a:p>
           <a:p>
             <a:r>
-              <a:t>Honest scoring matters: an early version made everything look 0.99 and hid a sign bug that sent recipes to the worst answer (−1.37 → 0.79 after the fix). The best quantum method depends on the problem's shape and the chip's errors, not on theory. And how to run real experiments on 10 minutes: tune on simulators, batch jobs, dry-run on a fake chip first.</a:t>
+              <a:t>- Honest scoring matters: an early version made everything look 99% good and hid a bug. The bug made our recipes search for the WORST answer: the score was −1.37 (worse than random guessing) until we fixed one sign, after which it was 0.79 (79% of the way to perfect).</a:t>
+            </a:r>
+          </a:p>
+          <a:p>
+            <a:r>
+              <a:t>- The best quantum method depends on the problem's shape and the chip's errors, not on theory.</a:t>
+            </a:r>
+          </a:p>
+          <a:p>
+            <a:r>
+              <a:t>- How to run real experiments with only 10 minutes: tune on simulators, batch jobs, test on a fake chip first.</a:t>
             </a:r>
           </a:p>
           <a:p/>
@@ -2876,7 +2912,7 @@
           </a:p>
           <a:p>
             <a:r>
-              <a:t>A: Repeat hardware runs for error bars, deeper circuits where copying settings saves more, a real D-Wave backend, real drug data, and a better error model for long recipes.</a:t>
+              <a:t>A: Repeat hardware runs to measure variation, try bigger recipes where copying settings saves more, add a real D-Wave, use real drug data, and improve our error model for long recipes.</a:t>
             </a:r>
           </a:p>
           <a:p>
@@ -2987,7 +3023,7 @@
           <a:lstStyle/>
           <a:p>
             <a:r>
-              <a:t>SLIDE 5 · HOW SHAPES ARE BUILT · target 0:40</a:t>
+              <a:t>SLIDE 5 · HOW SHAPES ARE BUILT · speak for about 40 seconds</a:t>
             </a:r>
           </a:p>
           <a:p/>
@@ -2998,44 +3034,63 @@
           </a:p>
           <a:p>
             <a:r>
-              <a:t>"How does the router see a problem? We draw a connection map: one dot per choice, and a line wherever two choices affect each other. Drug funding is fully connected, because 'fund exactly 4' ties every drug to every other one. A trial-site network is sparse: each site touches only its neighbors. From the map we count size, density and links. Then we compile the actual quantum recipe onto IBM's real chip and count its link steps and its chance of running with zero errors, using IBM's own error measurements. Those nine numbers are the problem's fingerprint. Then the AI learns: we made 60 practice problems, solved each one three ways on a simulator, and a random forest learned which solver scores best for which fingerprint. For a new problem it picks the best quantum kind, or the laptop if no quantum option reaches 0.5."</a:t>
+              <a:t>"How does the router see a problem? We draw a connection map: one dot per choice, and a line wherever two choices affect each other. Drug funding is fully connected, because 'fund exactly 4' ties every drug to every other one. A trial-site network is sparse: each site touches only its neighbors. We measure the map, then fit the quantum recipe onto IBM's real chip and count its error-prone steps. Those nine numbers are the problem's fingerprint. An AI trained on 60 practice problems, each solved three ways on a simulator, learned which solver scores best for which fingerprint."</a:t>
             </a:r>
           </a:p>
           <a:p/>
           <a:p>
             <a:r>
-              <a:t>WHAT'S ON THE SLIDE</a:t>
-            </a:r>
-          </a:p>
-          <a:p>
-            <a:r>
-              <a:t>Left: a dense map (every pair linked, density 1.00) next to a sparse one (density 0.40). Middle: the three steps. Right: real examples. An 8-choice drug problem needs 99 link steps; a network 49; a medical-test problem 53.</a:t>
+              <a:t>WHAT EACH NUMBER MEANS</a:t>
+            </a:r>
+          </a:p>
+          <a:p>
+            <a:r>
+              <a:t>- "15 of 15 lines, density 1.00" (drug map) = 6 drugs can be paired 15 different ways, and all 15 pairs are linked. Density = lines drawn ÷ lines possible, so 15 ÷ 15 = 1.00 = 100% connected (dense).</a:t>
+            </a:r>
+          </a:p>
+          <a:p>
+            <a:r>
+              <a:t>- "6 of 15 lines, density 0.40" (network map) = only 6 of the 15 possible pairs are linked, so 6 ÷ 15 = 0.40 = 40% connected (sparse).</a:t>
+            </a:r>
+          </a:p>
+          <a:p>
+            <a:r>
+              <a:t>- "Nine numbers" = the fingerprint. Five describe the map: (1) how many choices, (2) density, (3) average links per choice, (4) most links on any one choice, (5) how spread out the score sheet's numbers are. Four describe running on IBM's chip: (6) chance the gate-based recipe runs with zero errors, (7) the same for annealing, (8) number of linking steps, (9) how many steps long the recipe is.</a:t>
+            </a:r>
+          </a:p>
+          <a:p>
+            <a:r>
+              <a:t>- "Chance of zero errors" = we multiply together the success chance of every single step, using IBM's measured error rate for each part of the chip.</a:t>
+            </a:r>
+          </a:p>
+          <a:p>
+            <a:r>
+              <a:t>- "60 practice problems" = small made-up problems from our four industries that the AI learns from. They ran only on a simulator.</a:t>
+            </a:r>
+          </a:p>
+          <a:p>
+            <a:r>
+              <a:t>- "solved 3 ways" = each practice problem was solved by gate-based, annealing, and the laptop, and we recorded each score.</a:t>
+            </a:r>
+          </a:p>
+          <a:p>
+            <a:r>
+              <a:t>- "Random forest" = the AI: 300 small yes/no flowcharts that each make a guess, then vote. "300" is just how many flowcharts vote.</a:t>
+            </a:r>
+          </a:p>
+          <a:p>
+            <a:r>
+              <a:t>- "0.5" = the router's bar: if no quantum option is predicted to get at least halfway from a random guess to the perfect answer, it sends the problem to the laptop.</a:t>
+            </a:r>
+          </a:p>
+          <a:p>
+            <a:r>
+              <a:t>- "53%" (if asked) = of everything the AI uses to decide, 53% of its decisions rely on number 7, the annealing recipe's chance of zero errors. It learned on its own that this matters most.</a:t>
             </a:r>
           </a:p>
           <a:p/>
           <a:p>
             <a:r>
-              <a:t>THE NINE NUMBERS</a:t>
-            </a:r>
-          </a:p>
-          <a:p>
-            <a:r>
-              <a:t>1 size · 2 density (lines ÷ possible) · 3 average links · 4 most links · 5 number spread (biggest ÷ smallest score number) · 6 chance of an error-free gate-based run · 7 the same for annealing · 8 link (two-qubit) steps · 9 recipe length.</a:t>
-            </a:r>
-          </a:p>
-          <a:p>
-            <a:r>
-              <a:t>- Error-free chance = multiply (1 − error rate) for every step, using IBM Torino's calibration data.</a:t>
-            </a:r>
-          </a:p>
-          <a:p>
-            <a:r>
-              <a:t>- An AI (a random forest: 300 small decision trees that vote) learned from 60 practice problems which solver fits which fingerprint. Its most important input: the annealing recipe's error-free chance (53% of its decisions).</a:t>
-            </a:r>
-          </a:p>
-          <a:p/>
-          <a:p>
-            <a:r>
               <a:t>IF A JUDGE ASKS</a:t>
             </a:r>
           </a:p>
@@ -3046,7 +3101,7 @@
           </a:p>
           <a:p>
             <a:r>
-              <a:t>A: Nine measured numbers; nobody labels a problem "dense". The AI learns what the numbers mean.</a:t>
+              <a:t>A: From nine measured numbers; nobody labels a problem "dense". The AI learns what the numbers mean.</a:t>
             </a:r>
           </a:p>
           <a:p>
@@ -3056,7 +3111,7 @@
           </a:p>
           <a:p>
             <a:r>
-              <a:t>A: No, on a simulator, three ways each, with known best answers. The real chip was used for our final tests.</a:t>
+              <a:t>A: No, on a simulator. The real chip was used for our final tests (slides 9 and 10).</a:t>
             </a:r>
           </a:p>
         </p:txBody>
@@ -3114,7 +3169,7 @@
           <a:lstStyle/>
           <a:p>
             <a:r>
-              <a:t>SLIDE 6 · PATTERN RECOGNITION · target 0:35</a:t>
+              <a:t>SLIDE 6 · PATTERN RECOGNITION · speak for about 35 seconds</a:t>
             </a:r>
           </a:p>
           <a:p/>
@@ -3125,34 +3180,49 @@
           </a:p>
           <a:p>
             <a:r>
-              <a:t>"This is the pattern recognition. Each dot is one of our 60 practice problems, placed by its nine-number fingerprint, so problems with similar shapes land close together. Stocks and drug funding cluster on the right, because both are fully connected. Networks and medical tests mix together on the left, because both are loosely connected. So the shape of a problem, not its industry, decides which solver fits, and what we learn in one industry carries over to another."</a:t>
+              <a:t>"This is the pattern recognition. Each dot is one of our 60 practice problems, placed by its nine-number fingerprint, so problems with similar shapes land close together. Stocks and drug funding cluster together, because both are fully connected. Networks and medical tests mix together, because both are loosely connected. So the shape of a problem, not its industry, decides which solver fits, and what we learn in one industry carries over to another."</a:t>
             </a:r>
           </a:p>
           <a:p/>
           <a:p>
             <a:r>
-              <a:t>HOW TO READ THE CHART</a:t>
-            </a:r>
-          </a:p>
-          <a:p>
-            <a:r>
-              <a:t>- The nine numbers are compressed onto two axes with a method called PCA; the axes have no units, only distance matters.</a:t>
-            </a:r>
-          </a:p>
-          <a:p>
-            <a:r>
-              <a:t>- Colors = industry. Overlapping colors = different industries with the same shape.</a:t>
+              <a:t>WHAT EACH NUMBER MEANS</a:t>
+            </a:r>
+          </a:p>
+          <a:p>
+            <a:r>
+              <a:t>- Each dot = one practice problem. The numbers in the legend, Stocks (11), Drugs (16), Medical tests (15), Networks (18), = how many of the 60 practice problems came from each industry (11 + 16 + 15 + 18 = 60).</a:t>
+            </a:r>
+          </a:p>
+          <a:p>
+            <a:r>
+              <a:t>- The axes (−6 to 6, −3 to 3) have NO units. A computer squashes the nine fingerprint numbers down to two so we can draw them (a method called PCA). Only the distance between dots matters: close = similar shape.</a:t>
             </a:r>
           </a:p>
           <a:p/>
           <a:p>
             <a:r>
-              <a:t>SUPPORTING EVIDENCE</a:t>
-            </a:r>
-          </a:p>
-          <a:p>
-            <a:r>
-              <a:t>We trained the AI on three industries and tested it on the fourth, unseen one, four times: it still picked the better quantum kind 72-100% of the time, with prediction errors of only 0.01-0.05. Networks were hardest because they differ most from the others.</a:t>
+              <a:t>SUPPORTING NUMBERS (if asked)</a:t>
+            </a:r>
+          </a:p>
+          <a:p>
+            <a:r>
+              <a:t>- We trained the AI on three industries and tested it on the fourth, which it had never seen, four times (once per industry).</a:t>
+            </a:r>
+          </a:p>
+          <a:p>
+            <a:r>
+              <a:t>- "72-100%" = on the unseen industry, the AI still picked the better quantum computer between 72% and 100% of the time.</a:t>
+            </a:r>
+          </a:p>
+          <a:p>
+            <a:r>
+              <a:t>- "0.01-0.05" = its predicted scores were off by only 0.01 to 0.05 on our 0-to-1 scale, i.e. 1 to 5 points out of 100.</a:t>
+            </a:r>
+          </a:p>
+          <a:p>
+            <a:r>
+              <a:t>- Networks were hardest to predict (72%), because they differ most from the other three industries.</a:t>
             </a:r>
           </a:p>
           <a:p/>
@@ -3163,22 +3233,12 @@
           </a:p>
           <a:p>
             <a:r>
-              <a:t>Q: What does pattern recognition mean here?</a:t>
-            </a:r>
-          </a:p>
-          <a:p>
-            <a:r>
-              <a:t>A: Two things: the AI learns which solver fits which fingerprint, and we find each problem's closest-shaped "twin" to reuse its settings. Both work across industries because the shapes overlap.</a:t>
-            </a:r>
-          </a:p>
-          <a:p>
-            <a:r>
-              <a:t>Q: Why does that matter?</a:t>
-            </a:r>
-          </a:p>
-          <a:p>
-            <a:r>
-              <a:t>A: It lets us reuse what we learned instead of paying for it again in quantum time. The next two slides show the savings.</a:t>
+              <a:t>Q: What does "pattern recognition" mean here?</a:t>
+            </a:r>
+          </a:p>
+          <a:p>
+            <a:r>
+              <a:t>A: Two things: the AI learns which solver fits which fingerprint, and we find each problem's closest-shaped "twin" to reuse its settings (next slide). Both work across industries because the shapes overlap.</a:t>
             </a:r>
           </a:p>
         </p:txBody>
@@ -3236,7 +3296,7 @@
           <a:lstStyle/>
           <a:p>
             <a:r>
-              <a:t>SLIDE 7 · WHERE THE DIALS COME FROM · target 0:45</a:t>
+              <a:t>SLIDE 7 · WHERE THE DIALS COME FROM · speak for about 45 seconds</a:t>
             </a:r>
           </a:p>
           <a:p/>
@@ -3247,70 +3307,117 @@
           </a:p>
           <a:p>
             <a:r>
-              <a:t>"The gate-based recipe has two dials, two numbers that control how hard it pushes and links choices and how much it shuffles answers. Normally you find good settings by trial and error, about 60 tries per problem. Here's where ours come from: during training we tuned the dials for each of our 60 practice problems once, on a simulator, so no quantum time, and saved them in a library next to each problem's shape. When a new problem arrives, Q-Router finds the closest shape from a different industry and copies its dials, then runs once. Testing every problem this way: copied dials score 0.60, close to 0.63 for full tuning, while copying from a random problem scores 0.58, no better than no tuning. So it's the shape match that works: about half the benefit of tuning for one sixtieth of the effort."</a:t>
+              <a:t>"The gate-based recipe has two dials, two numbers that normally take about 60 tries to tune. Here's where ours come from: we tuned each of our 60 practice problems once, on a simulator, at no quantum cost, and saved the dials in a library next to each problem's shape. When a new problem arrives, Q-Router finds the closest shape from a different industry and copies its dials, then runs once. Copied dials scored 0.60 out of 1, close to 0.63 for full tuning, while copying from a random problem scored 0.58, no better than no tuning. So it's the shape match that works: about a third of the benefit of tuning, for one sixtieth of the effort."</a:t>
             </a:r>
           </a:p>
           <a:p/>
           <a:p>
             <a:r>
-              <a:t>WHAT'S ON THE SLIDE</a:t>
-            </a:r>
-          </a:p>
-          <a:p>
-            <a:r>
-              <a:t>- Top strip, left to right: 60 practice problems → tune each once on a simulator (about 60 tries) → save a library (shape + best 2 dials) → new problem: find the closest shape in another industry → copy the dials and run once.</a:t>
-            </a:r>
-          </a:p>
-          <a:p>
-            <a:r>
-              <a:t>- Bar chart: four ways to set the dials, tested on all 60 problems by pretending each one is new. Longer bar = better.</a:t>
-            </a:r>
-          </a:p>
-          <a:p>
-            <a:r>
-              <a:t>  Tuned from scratch 0.633 (60 tries) · copied from twin 0.599 (1 try) · copied from random 0.577 (1 try) · default dials 0.581 (1 try).</a:t>
-            </a:r>
-          </a:p>
-          <a:p>
-            <a:r>
-              <a:t>- The gap between default (0.581) and tuned (0.633) is what tuning buys; the twin closes about half of it.</a:t>
-            </a:r>
-          </a:p>
-          <a:p>
-            <a:r>
-              <a:t>- Table: by industry. Works best for stocks and drugs; doesn't help medical tests (0.532 vs 0.555 default).</a:t>
-            </a:r>
-          </a:p>
-          <a:p>
-            <a:r>
-              <a:t>- Statistics: twin beats random by 0.023 ± 0.010 and wins on 65% of problems.</a:t>
+              <a:t>HOW TO READ OUR SCORES: every score is between 0 and 1. 1 = the perfect (true best) answer. 0 = no better than picking at random. So 0.64 means "64% of the way from a random guess to the perfect answer."</a:t>
             </a:r>
           </a:p>
           <a:p/>
           <a:p>
             <a:r>
-              <a:t>WHAT THE DIALS ARE</a:t>
-            </a:r>
-          </a:p>
-          <a:p>
-            <a:r>
-              <a:t>γ (gamma) = how strongly each choice is pushed toward its value and how strongly linked choices pull on each other. β (beta) = how much the recipe shuffles answers. One round of the recipe = one pair of numbers, for example β = 0.35, γ = −0.42.</a:t>
+              <a:t>WHAT EACH NUMBER MEANS</a:t>
+            </a:r>
+          </a:p>
+          <a:p>
+            <a:r>
+              <a:t>- "Two dials" = two numbers that set the recipe: gamma (γ), how hard to push each choice toward its value and pull linked choices together, and beta (β), how much to shuffle answers. Example setting: β = 0.35, γ = −0.42.</a:t>
+            </a:r>
+          </a:p>
+          <a:p>
+            <a:r>
+              <a:t>- "~60 tries" = finding good dial values by trial and error takes about 60 test runs per problem.</a:t>
+            </a:r>
+          </a:p>
+          <a:p>
+            <a:r>
+              <a:t>- "60 practice problems" = the library. Each one was tuned once on a simulator (a normal computer), and its best two numbers were saved with its shape.</a:t>
+            </a:r>
+          </a:p>
+          <a:p>
+            <a:r>
+              <a:t>- "1 try instead of 60" = copying means running the recipe once instead of about 60 times. That's 1/60 of the effort.</a:t>
             </a:r>
           </a:p>
           <a:p/>
           <a:p>
             <a:r>
-              <a:t>HOW THE TWIN IS FOUND</a:t>
-            </a:r>
-          </a:p>
-          <a:p>
-            <a:r>
-              <a:t>Rescale the nine fingerprint numbers so none dominates, measure the distance between fingerprints, keep only other industries, take the closest. A lookup in the library, not a guess.</a:t>
+              <a:t>THE BAR CHART (longer bar = better answer)</a:t>
+            </a:r>
+          </a:p>
+          <a:p>
+            <a:r>
+              <a:t>- 0.633 "Tuned from scratch (60 tries)" = the best you can do: the answers averaged 63% of the way from random to perfect. Costs about 60 runs.</a:t>
+            </a:r>
+          </a:p>
+          <a:p>
+            <a:r>
+              <a:t>- 0.599 "Copied from twin (1 try)" = our method: 60% of the way, for 1 run.</a:t>
+            </a:r>
+          </a:p>
+          <a:p>
+            <a:r>
+              <a:t>- 0.577 "Copied from random (1 try)" = the fair comparison: same cost, also from another industry, but not matched by shape. 58%.</a:t>
+            </a:r>
+          </a:p>
+          <a:p>
+            <a:r>
+              <a:t>- 0.581 "Default dials (1 try)" = a generic setting, no learning at all. 58%.</a:t>
+            </a:r>
+          </a:p>
+          <a:p>
+            <a:r>
+              <a:t>- "A third of tuning's gain" = full tuning raises the score from 0.581 (no learning) to 0.633, a gain of 0.052. Copying from a twin raises it to 0.599, a gain of 0.018. 0.018 ÷ 0.052 ≈ 0.35, so about a third of the benefit of tuning, for 1 run instead of about 60.</a:t>
+            </a:r>
+          </a:p>
+          <a:p>
+            <a:r>
+              <a:t>- "± 0.02" (under the chart) = how much these averages could wobble just by chance; the differences between bars are bigger than random wobble.</a:t>
             </a:r>
           </a:p>
           <a:p/>
           <a:p>
             <a:r>
+              <a:t>THE TABLE (same four methods, by industry)</a:t>
+            </a:r>
+          </a:p>
+          <a:p>
+            <a:r>
+              <a:t>- Stocks: tuned 0.736, twin 0.737 = copying worked as well as full tuning.</a:t>
+            </a:r>
+          </a:p>
+          <a:p>
+            <a:r>
+              <a:t>- Drugs: tuned 0.749, twin 0.737 = copying was almost as good.</a:t>
+            </a:r>
+          </a:p>
+          <a:p>
+            <a:r>
+              <a:t>- Medical tests: twin 0.532 vs default 0.555 = copying did NOT help here; it was slightly worse than no learning. We say that honestly.</a:t>
+            </a:r>
+          </a:p>
+          <a:p>
+            <a:r>
+              <a:t>- Networks: twin 0.448 vs default 0.434 = a small gain.</a:t>
+            </a:r>
+          </a:p>
+          <a:p/>
+          <a:p>
+            <a:r>
+              <a:t>THE YELLOW BANNER</a:t>
+            </a:r>
+          </a:p>
+          <a:p>
+            <a:r>
+              <a:t>"0.599 vs 0.577" = twin 0.599 vs random copy 0.577: = copying from a similar shape beat copying from a random problem. Across all 60 problems, the twin won 65% of the time (about 2 out of 3).</a:t>
+            </a:r>
+          </a:p>
+          <a:p/>
+          <a:p>
+            <a:r>
               <a:t>IF A JUDGE ASKS</a:t>
             </a:r>
           </a:p>
@@ -3321,27 +3428,27 @@
           </a:p>
           <a:p>
             <a:r>
-              <a:t>A: From our library: each of the 60 practice problems was tuned once on a simulator and its best two dials were saved with its shape.</a:t>
-            </a:r>
-          </a:p>
-          <a:p>
-            <a:r>
-              <a:t>Q: Hasn't copying QAOA settings been done before?</a:t>
-            </a:r>
-          </a:p>
-          <a:p>
-            <a:r>
-              <a:t>A: Between similar math problems yes (parameter concentration), and a 2025 study did it across problem types. Ours tests it across real industry decisions with real data, with a random-copy control, and combines it with routing and packing.</a:t>
-            </a:r>
-          </a:p>
-          <a:p>
-            <a:r>
-              <a:t>Q: Why does copying work at all?</a:t>
-            </a:r>
-          </a:p>
-          <a:p>
-            <a:r>
-              <a:t>A: All score sheets are rescaled to the same size, so problems with similar shapes need similar dial settings.</a:t>
+              <a:t>A: From our library: each of the 60 practice problems was tuned once on a simulator and its best two numbers were saved with its shape.</a:t>
+            </a:r>
+          </a:p>
+          <a:p>
+            <a:r>
+              <a:t>Q: Hasn't this been done before?</a:t>
+            </a:r>
+          </a:p>
+          <a:p>
+            <a:r>
+              <a:t>A: Copying settings between similar math problems has been done, and a 2025 study did it across problem types. Ours tests it across real industry decisions with real data, with a fair random comparison, and combines it with routing and packing.</a:t>
+            </a:r>
+          </a:p>
+          <a:p>
+            <a:r>
+              <a:t>Q: Why does copying work?</a:t>
+            </a:r>
+          </a:p>
+          <a:p>
+            <a:r>
+              <a:t>A: Every score sheet is rescaled to the same size, so problems with similar shapes need similar dial settings.</a:t>
             </a:r>
           </a:p>
         </p:txBody>
@@ -3399,7 +3506,7 @@
           <a:lstStyle/>
           <a:p>
             <a:r>
-              <a:t>SLIDE 8 · MANY PROBLEMS, ONE RUN · target 0:40</a:t>
+              <a:t>SLIDE 8 · MANY PROBLEMS, ONE RUN · speak for about 40 seconds</a:t>
             </a:r>
           </a:p>
           <a:p/>
@@ -3410,38 +3517,86 @@
           </a:p>
           <a:p>
             <a:r>
-              <a:t>"Second payoff: problems with the same shape can share one run. We grouped four problems from four industries into two shape families, tuned only the most typical problem in each family and let the others copy its dials, and packed all four side by side into a single 16-qubit job. Compared with the normal way, that's half the tunings, one chip job instead of four, and four times fewer quantum shots, which is what you pay for. In simulation we kept 96% of the quality; on the real IBM chip, 90%."</a:t>
+              <a:t>"Second payoff: problems with the same shape can share one run. We took four problems from four industries and grouped them into two shape families. We tuned only the most typical problem in each family and let the others copy its dials, then packed all four side by side into a single job on the chip. Compared with the normal way, that's half the tuning, one chip job instead of four, and four times fewer quantum measurements, which is what you pay for. We kept 96% of the quality in simulation and 90% on the real IBM chip."</a:t>
             </a:r>
           </a:p>
           <a:p/>
           <a:p>
             <a:r>
-              <a:t>HOW TO READ IT</a:t>
-            </a:r>
-          </a:p>
-          <a:p>
-            <a:r>
-              <a:t>- Left: 4 problems → 2 shape families (grouped by fingerprint with k-means) → 1 chip job.</a:t>
-            </a:r>
-          </a:p>
-          <a:p>
-            <a:r>
-              <a:t>- Chart: what Q-Router used as a percentage of the normal way (shorter is better): 50% of the tunings, 48% of the tuning runs, 25% of the jobs, 25% of the shots (4,096 instead of 16,384).</a:t>
-            </a:r>
-          </a:p>
-          <a:p>
-            <a:r>
-              <a:t>- Table: quality (1 = best). Simulation 0.524 → 0.504 packed. Real ibm_kingston 0.528 → 0.475 packed.</a:t>
-            </a:r>
-          </a:p>
-          <a:p>
-            <a:r>
-              <a:t>- Where the loss comes from: almost entirely one network problem grouped with the finance problems (0.58 alone → about 0.42 shared on the real chip). Packing itself costs very little: when we packed three industries on the real chip, each lost only 0.01-0.03.</a:t>
+              <a:t>HOW TO READ OUR SCORES: every score is between 0 and 1. 1 = the perfect (true best) answer. 0 = no better than picking at random. So 0.64 means "64% of the way from a random guess to the perfect answer."</a:t>
             </a:r>
           </a:p>
           <a:p/>
           <a:p>
             <a:r>
+              <a:t>WHAT EACH NUMBER MEANS</a:t>
+            </a:r>
+          </a:p>
+          <a:p>
+            <a:r>
+              <a:t>- "4 problems, 2 shape families" = stocks, drugs and network were similar enough to share settings (family 1); medical tests was different (family 2).</a:t>
+            </a:r>
+          </a:p>
+          <a:p>
+            <a:r>
+              <a:t>- "16 qubits" = the four problems used 4 qubits each, placed side by side: 4 × 4 = 16 qubits in one job.</a:t>
+            </a:r>
+          </a:p>
+          <a:p/>
+          <a:p>
+            <a:r>
+              <a:t>THE GREEN BARS: "Q-Router as % of normal" (shorter = better; 100% would mean no saving)</a:t>
+            </a:r>
+          </a:p>
+          <a:p>
+            <a:r>
+              <a:t>- Problems tuned 50% = we tuned 2 problems instead of 4.</a:t>
+            </a:r>
+          </a:p>
+          <a:p>
+            <a:r>
+              <a:t>- Tuning runs 48% = 55 tuning tries instead of 114 (about half).</a:t>
+            </a:r>
+          </a:p>
+          <a:p>
+            <a:r>
+              <a:t>- Chip jobs 25% = 1 trip to the quantum computer instead of 4.</a:t>
+            </a:r>
+          </a:p>
+          <a:p>
+            <a:r>
+              <a:t>- Quantum shots 25% = 4,096 measurements instead of 16,384. A "shot" is one measurement of the chip giving one answer; shots are what use up quantum time. 4× fewer shots = 4× less quantum time.</a:t>
+            </a:r>
+          </a:p>
+          <a:p/>
+          <a:p>
+            <a:r>
+              <a:t>THE TABLE (average score of the 4 problems)</a:t>
+            </a:r>
+          </a:p>
+          <a:p>
+            <a:r>
+              <a:t>- Simulation: 0.524 (each tuned alone) → 0.504 (shared settings, packed together). 0.504 ÷ 0.524 = 96% of the quality kept.</a:t>
+            </a:r>
+          </a:p>
+          <a:p>
+            <a:r>
+              <a:t>- Real ibm_kingston chip: 0.528 → 0.475. 0.475 ÷ 0.528 = 90% of the quality kept.</a:t>
+            </a:r>
+          </a:p>
+          <a:p>
+            <a:r>
+              <a:t>- Where the loss came from: almost all from the network problem, whose settings were borrowed from the finance problems (it dropped from about 0.58 to 0.42).</a:t>
+            </a:r>
+          </a:p>
+          <a:p>
+            <a:r>
+              <a:t>- Packing itself costs very little: when we packed three industries on the real chip (a separate test), each one's score dropped by only 0.01-0.03 (1 to 3 points out of 100) compared with running alone.</a:t>
+            </a:r>
+          </a:p>
+          <a:p/>
+          <a:p>
+            <a:r>
               <a:t>IF A JUDGE ASKS</a:t>
             </a:r>
           </a:p>
@@ -3452,17 +3607,17 @@
           </a:p>
           <a:p>
             <a:r>
-              <a:t>A: The chip has 156 qubits, so more fit, but more neighbors means more crosstalk. We measured 0.01-0.03 with three problems; scaling up is a next step.</a:t>
-            </a:r>
-          </a:p>
-          <a:p>
-            <a:r>
-              <a:t>Q: Is 90% quality worth it?</a:t>
-            </a:r>
-          </a:p>
-          <a:p>
-            <a:r>
-              <a:t>A: For exploring with scarce quantum time, yes: 4× less quantum time for a small quality loss. For a final decision, you'd check the best answers on a laptop anyway.</a:t>
+              <a:t>A: The chip has 156 qubits, so more would fit, but more neighbors means more interference. We measured only 1-3 points of interference with three problems; scaling up is a next step.</a:t>
+            </a:r>
+          </a:p>
+          <a:p>
+            <a:r>
+              <a:t>Q: Is losing 10% worth it?</a:t>
+            </a:r>
+          </a:p>
+          <a:p>
+            <a:r>
+              <a:t>A: For exploring with scarce quantum time, yes: 4× less quantum time for a small loss in quality.</a:t>
             </a:r>
           </a:p>
         </p:txBody>
@@ -3520,7 +3675,7 @@
           <a:lstStyle/>
           <a:p>
             <a:r>
-              <a:t>SLIDE 9 · GATE-BASED VS. ANNEALING, PIECE BY PIECE · target 0:45</a:t>
+              <a:t>SLIDE 9 · GATE-BASED VS. ANNEALING, PIECE BY PIECE · speak for about 45 seconds</a:t>
             </a:r>
           </a:p>
           <a:p/>
@@ -3531,66 +3686,92 @@
           </a:p>
           <a:p>
             <a:r>
-              <a:t>"Now the key comparison, on the real IBM chip. We split one decision, drug funding plus clinical-trial sites, into three pieces and ran both quantum kinds on every piece. Gate-based wins the dense drug piece, 0.55 to 0.34. Annealing wins both sparse trial-site pieces, 0.42 to 0.38 and 0.73 to 0.41. Why? Annealing needs about seven times more link steps, and every step can fail, so it only pays off where choices are loosely linked. Mixing them beats either one alone: 0.55, versus 0.45 for all gate-based and 0.49 for all annealing. Our chip simulation predicted the same winners."</a:t>
+              <a:t>"Now the key comparison, on the real IBM chip. We split one decision, drug funding plus clinical-trial sites, into three pieces and ran both quantum computers on every piece. Gate-based wins the dense drug piece: 0.55 versus 0.34. Annealing wins both loosely connected trial-site pieces: 0.42 versus 0.38, and 0.73 versus 0.41. Annealing needs about seven times more error-prone linking steps, so it only pays off where choices are loosely linked. Q-Router's mix scores 0.55, beating all gate-based at 0.45 and all annealing at 0.49."</a:t>
             </a:r>
           </a:p>
           <a:p/>
           <a:p>
             <a:r>
-              <a:t>HOW TO READ THE CHART</a:t>
-            </a:r>
-          </a:p>
-          <a:p>
-            <a:r>
-              <a:t>Each pair of bars is one piece solved both ways on ibm_kingston. Score 1 = true best, 0 = random guess.</a:t>
+              <a:t>HOW TO READ OUR SCORES: every score is between 0 and 1. 1 = the perfect (true best) answer. 0 = no better than picking at random. So 0.64 means "64% of the way from a random guess to the perfect answer."</a:t>
             </a:r>
           </a:p>
           <a:p/>
           <a:p>
             <a:r>
-              <a:t>THE TEST PROBLEM</a:t>
-            </a:r>
-          </a:p>
-          <a:p>
-            <a:r>
-              <a:t>- Part A (dense): fund 3 of 8 drugs; every choice affects every other.</a:t>
-            </a:r>
-          </a:p>
-          <a:p>
-            <a:r>
-              <a:t>- Part B (sparse): split 10 trial sites between two research partners; each site affects only a few neighbors.</a:t>
-            </a:r>
-          </a:p>
-          <a:p>
-            <a:r>
-              <a:t>- A small link between parts: a bonus when a funded drug's trial site is chosen. Spectral clustering split it into pieces of 8, 7 and 3.</a:t>
+              <a:t>THE BAR CHART (blue = gate-based, pink = annealing; taller = better)</a:t>
+            </a:r>
+          </a:p>
+          <a:p>
+            <a:r>
+              <a:t>- "Drug funding (8, dense)" = a piece with 8 yes/no choices where every choice affects every other. Gate-based 0.55 vs annealing 0.34 → gate-based wins clearly.</a:t>
+            </a:r>
+          </a:p>
+          <a:p>
+            <a:r>
+              <a:t>- "Trial sites A (7, sparse)" = 7 choices, each affecting only a few others. Gate 0.38 vs annealing 0.42 → annealing wins narrowly.</a:t>
+            </a:r>
+          </a:p>
+          <a:p>
+            <a:r>
+              <a:t>- "Trial sites B (3, small)" = only 3 choices. Gate 0.41 vs annealing 0.73 → annealing wins big.</a:t>
             </a:r>
           </a:p>
           <a:p/>
           <a:p>
             <a:r>
-              <a:t>ACROSS ALL 60 PRACTICE PROBLEMS (simulation)</a:t>
-            </a:r>
-          </a:p>
-          <a:p>
-            <a:r>
-              <a:t>Annealing won 0 of 11 stock problems and 2 of 16 drug problems (fully connected), but 4 of 15 medical-test problems and 10 of 18 network problems (looser). The same density pattern.</a:t>
+              <a:t>THE STRATEGY BARS ("average score by strategy", averaged over the 3 pieces)</a:t>
+            </a:r>
+          </a:p>
+          <a:p>
+            <a:r>
+              <a:t>- All gate-based 0.45 = use gate-based on every piece.</a:t>
+            </a:r>
+          </a:p>
+          <a:p>
+            <a:r>
+              <a:t>- All annealing 0.49 = use annealing on every piece.</a:t>
+            </a:r>
+          </a:p>
+          <a:p>
+            <a:r>
+              <a:t>- Q-Router's mix 0.55 = use whichever the router picked for each piece. Mixing is best.</a:t>
             </a:r>
           </a:p>
           <a:p/>
           <a:p>
             <a:r>
+              <a:t>OTHER NUMBERS</a:t>
+            </a:r>
+          </a:p>
+          <a:p>
+            <a:r>
+              <a:t>- "About 7× more linking steps" = on the drug piece, the annealing recipe needed roughly seven times as many of the chip's error-prone linking steps as gate-based.</a:t>
+            </a:r>
+          </a:p>
+          <a:p>
+            <a:r>
+              <a:t>- The router chose correctly on 2 of the 3 pieces. It picked gate-based for trial sites A, where annealing was slightly better.</a:t>
+            </a:r>
+          </a:p>
+          <a:p>
+            <a:r>
+              <a:t>- Across our 60 practice problems (simulation): annealing beat gate-based on 0 of 11 stock problems and 2 of 16 drug problems (both fully connected), but on 4 of 15 medical-test problems and 10 of 18 network problems (looser). The same pattern: dense → gate-based, sparse → annealing.</a:t>
+            </a:r>
+          </a:p>
+          <a:p/>
+          <a:p>
+            <a:r>
               <a:t>IF A JUDGE ASKS</a:t>
             </a:r>
           </a:p>
           <a:p>
             <a:r>
-              <a:t>Q: Did the router choose correctly?</a:t>
-            </a:r>
-          </a:p>
-          <a:p>
-            <a:r>
-              <a:t>A: Two of three pieces, the same on the simulator and the real chip. It chose gate-based for trial sites A, where annealing was slightly better, because its error estimate for long annealing recipes is imperfect.</a:t>
+              <a:t>Q: When was each type of quantum computer effective?</a:t>
+            </a:r>
+          </a:p>
+          <a:p>
+            <a:r>
+              <a:t>A: Gate-based on tightly connected pieces, annealing on loosely connected ones, and mixing them per piece beats either one alone.</a:t>
             </a:r>
           </a:p>
           <a:p>
@@ -3600,7 +3781,7 @@
           </a:p>
           <a:p>
             <a:r>
-              <a:t>A: This one shows it clearly on hardware; the 60 practice problems show the same pattern statistically.</a:t>
+              <a:t>A: This one shows it clearly on real hardware; the 60 practice problems show the same pattern statistically.</a:t>
             </a:r>
           </a:p>
         </p:txBody>
@@ -3658,7 +3839,7 @@
           <a:lstStyle/>
           <a:p>
             <a:r>
-              <a:t>SLIDE 10 · REAL IBM HARDWARE · target 0:40</a:t>
+              <a:t>SLIDE 10 · REAL IBM HARDWARE · speak for about 40 seconds</a:t>
             </a:r>
           </a:p>
           <a:p/>
@@ -3669,80 +3850,85 @@
           </a:p>
           <a:p>
             <a:r>
-              <a:t>"Finally, the full real-hardware test on IBM's 156-qubit ibm_kingston. We ran our drug problem, fund 3 of 8, four ways. With no errors, annealing beats gate-based, 0.80 to 0.72. On the real chip it flips: gate-based 0.64, annealing 0.55, because annealing needs about six times more link steps. That's exactly why a router is needed. What did the chip actually answer? Its most common answer was a good set, but not the best one. Still, the true best set was among its answers in every run, two to three times more often than random guessing, and a laptop finds it directly. One surprise: IBM's error-reducing tricks made our scores worse, especially for long recipes. We report that honestly. So overall, on the real chip, gate-based beat annealing, and the laptop still beat both."</a:t>
+              <a:t>"Finally, the full real-hardware test on IBM's 156-qubit ibm_kingston. We ran our drug problem, choosing 3 of 8 drugs, four ways. On a perfect simulator with no errors, annealing beats gate-based: 0.80 versus 0.72. On the real chip it flips: gate-based 0.64, annealing 0.55, because annealing needs about six times more error-prone steps. That's exactly why a router is needed. The chip's most common answer was a good set, not the best, but the true best showed up in every run, two to three times more often than random guessing. IBM's error fixes actually made scores worse. Overall: on the real chip gate-based beat annealing, and the laptop beat both."</a:t>
             </a:r>
           </a:p>
           <a:p/>
           <a:p>
             <a:r>
-              <a:t>HOW TO READ THE CHART</a:t>
-            </a:r>
-          </a:p>
-          <a:p>
-            <a:r>
-              <a:t>Four bars per method, from ideal to real: perfect simulator → copy of the chip with its errors → real chip → real chip with error fixes. Score 1 = true best, 0 = random guess.</a:t>
-            </a:r>
-          </a:p>
-          <a:p>
-            <a:r>
-              <a:t>- Gate-based (102 link steps): 0.72 → 0.67 → 0.64 → 0.58</a:t>
-            </a:r>
-          </a:p>
-          <a:p>
-            <a:r>
-              <a:t>- Annealing (658 link steps): 0.80 → 0.67 → 0.55 → 0.36</a:t>
-            </a:r>
-          </a:p>
-          <a:p>
-            <a:r>
-              <a:t>- Laptop: 0.93</a:t>
+              <a:t>HOW TO READ OUR SCORES: every score is between 0 and 1. 1 = the perfect (true best) answer. 0 = no better than picking at random. So 0.64 means "64% of the way from a random guess to the perfect answer."</a:t>
             </a:r>
           </a:p>
           <a:p/>
           <a:p>
             <a:r>
-              <a:t>THE CHIP'S ACTUAL ANSWERS (4,096 shots per run)</a:t>
-            </a:r>
-          </a:p>
-          <a:p>
-            <a:r>
-              <a:t>- True best set: onco-II-0, immu-III-2, card-III-3 (names = disease area, trial phase, candidate number).</a:t>
-            </a:r>
-          </a:p>
-          <a:p>
-            <a:r>
-              <a:t>- Most common answers on the chip were other good sets (e.g. annealing: immu-III-2, card-III-3, card-I-4, two of three right).</a:t>
-            </a:r>
-          </a:p>
-          <a:p>
-            <a:r>
-              <a:t>- The true best appeared in 0.7-1.1% of shots vs 0.4% for random guessing, and it was the best-scoring answer in every run's shots. In practice you check each shot on the score sheet and keep the best one.</a:t>
+              <a:t>THE BAR CHART (four bars per method, from ideal to real)</a:t>
+            </a:r>
+          </a:p>
+          <a:p>
+            <a:r>
+              <a:t>- Green "Perfect simulator" = a normal computer pretending to be a flawless quantum computer. Gate 0.72, annealing 0.80.</a:t>
+            </a:r>
+          </a:p>
+          <a:p>
+            <a:r>
+              <a:t>- Purple "Copy of chip (errors)" = the simulator imitating ibm_kingston's errors, using IBM's measurements. Gate 0.67, annealing 0.67. This was our prediction.</a:t>
+            </a:r>
+          </a:p>
+          <a:p>
+            <a:r>
+              <a:t>- Blue "Real chip, raw" = the actual quantum computer. Gate 0.64 (64% of the way to perfect), annealing 0.55 (55%).</a:t>
+            </a:r>
+          </a:p>
+          <a:p>
+            <a:r>
+              <a:t>- Pink "Real chip + fixes" = the real chip with IBM's error-reducing tricks turned on. Gate 0.58, annealing 0.36. The fixes made it worse.</a:t>
+            </a:r>
+          </a:p>
+          <a:p>
+            <a:r>
+              <a:t>- Laptop 0.93 = the normal computer's answers were 93% of the way to perfect.</a:t>
             </a:r>
           </a:p>
           <a:p/>
           <a:p>
             <a:r>
-              <a:t>NOISE ANALYSIS</a:t>
-            </a:r>
-          </a:p>
-          <a:p>
-            <a:r>
-              <a:t>- Our chip-copy model was close for gate-based (0.67 predicted vs 0.64 real) but too optimistic for annealing (0.67 vs 0.55): long recipes suffer extra errors the model misses.</a:t>
-            </a:r>
-          </a:p>
-          <a:p>
-            <a:r>
-              <a:t>- Error fixes (dynamical decoupling + Pauli twirling) lowered scores: gate 0.64 → 0.58, annealing 0.55 → 0.36. Twirling randomizes every step; on long circuits it added more harm than it removed.</a:t>
-            </a:r>
-          </a:p>
-          <a:p>
-            <a:r>
-              <a:t>- In simulation, zero-noise extrapolation recovered about 25% of the lost quality.</a:t>
-            </a:r>
-          </a:p>
-          <a:p>
-            <a:r>
-              <a:t>- QPU use: 7 jobs, a few minutes of our 10.</a:t>
+              <a:t>OTHER NUMBERS</a:t>
+            </a:r>
+          </a:p>
+          <a:p>
+            <a:r>
+              <a:t>- "8 drugs, fund 3" = 8 candidates, money for 3. There are 56 possible groups of 3 (and 256 combinations if you don't follow the rule).</a:t>
+            </a:r>
+          </a:p>
+          <a:p>
+            <a:r>
+              <a:t>- "About 6× more steps" = the annealing recipe used 658 linking steps vs 102 for gate-based.</a:t>
+            </a:r>
+          </a:p>
+          <a:p>
+            <a:r>
+              <a:t>- "4,096 answers" = each run measured the chip 4,096 times; each measurement is one complete answer (one set of drugs).</a:t>
+            </a:r>
+          </a:p>
+          <a:p>
+            <a:r>
+              <a:t>- True best set = onco-II-0, immu-III-2, card-III-3. (Names = disease area, testing phase, candidate number: e.g. onco-II-0 = a cancer drug in Phase II, candidate #0.)</a:t>
+            </a:r>
+          </a:p>
+          <a:p>
+            <a:r>
+              <a:t>- "2-3× more often than random" = the true best set came up in about 1% of the chip's 4,096 answers (0.7-1.1%), while a random guess would hit it only 0.4% of the time (1 in 256).</a:t>
+            </a:r>
+          </a:p>
+          <a:p>
+            <a:r>
+              <a:t>- Prediction check: our copy-of-chip predicted gate-based 0.67 and the real chip gave 0.64 (close). For annealing it predicted 0.67 and the real chip gave 0.55 (too optimistic): long recipes suffer extra errors our model misses.</a:t>
+            </a:r>
+          </a:p>
+          <a:p>
+            <a:r>
+              <a:t>- "Packing 3 problems cost only 0.01-0.03" = running three industries side by side on the real chip lowered each one's score by just 1-3 points out of 100.</a:t>
             </a:r>
           </a:p>
           <a:p/>
@@ -3753,12 +3939,12 @@
           </a:p>
           <a:p>
             <a:r>
-              <a:t>Q: Simulator vs. hardware, what did you learn?</a:t>
-            </a:r>
-          </a:p>
-          <a:p>
-            <a:r>
-              <a:t>A: The ranking held: gate-based wins dense problems on the real chip. The chip was worse than our model for long recipes, and mitigation didn't help here.</a:t>
+              <a:t>Q: Simulator vs. hardware: what did you learn?</a:t>
+            </a:r>
+          </a:p>
+          <a:p>
+            <a:r>
+              <a:t>A: The ranking held on the real chip (gate-based wins dense problems), the chip was worse than our model for long recipes, and IBM's error fixes didn't help here.</a:t>
             </a:r>
           </a:p>
           <a:p>
@@ -3768,7 +3954,7 @@
           </a:p>
           <a:p>
             <a:r>
-              <a:t>A: Yes: the chip's samples contained the true best set in every run, but its most common answer wasn't it. A laptop finds the best set every time, which is why we claim no quantum advantage.</a:t>
+              <a:t>A: Yes: the true best set was among the chip's answers in every run, but its most common answer wasn't it. A laptop finds the best set every time, which is why we claim no quantum advantage.</a:t>
             </a:r>
           </a:p>
         </p:txBody>
@@ -3865,7 +4051,7 @@
           <a:lstStyle/>
           <a:p>
             <a:r>
-              <a:t>SLIDE 2 · THE PROBLEM · target 0:40</a:t>
+              <a:t>SLIDE 2 · THE PROBLEM · speak for about 40 seconds</a:t>
             </a:r>
           </a:p>
           <a:p/>
@@ -3876,39 +4062,49 @@
           </a:p>
           <a:p>
             <a:r>
-              <a:t>"Companies keep making the same kind of decision: pick the best few out of many. Which 4 of 10 drug candidates to fund, which stocks to hold, which medical tests to order. Quantum computers might help with these, but quantum time is rare and expensive: our free IBM plan gives 10 minutes a month, and companies pay by the second. There are two different kinds of quantum computer, and today's chips make errors, so sending a problem to the wrong machine wastes money and gives a bad answer. Q-Router answers three questions: is quantum worth it, which kind, and for which part of the problem."</a:t>
+              <a:t>"Companies keep making the same kind of decision: pick the best few out of many. Which 4 of 10 drug candidates to fund, which stocks to hold, which medical tests to order. Quantum computers might help, but quantum time is rare and expensive: our free IBM plan gives us 10 minutes a month, and companies pay by the second. There are two kinds of quantum computer, and today's chips make errors, so sending a problem to the wrong machine wastes money and gives a bad answer. Q-Router answers three questions: is quantum worth it, which kind, and for which part of the problem."</a:t>
             </a:r>
           </a:p>
           <a:p/>
           <a:p>
             <a:r>
-              <a:t>WHAT'S ON THE SLIDE</a:t>
-            </a:r>
-          </a:p>
-          <a:p>
-            <a:r>
-              <a:t>Three industries with the same shape of decision (choose a subset under value, risk and rules). The banner names who is affected.</a:t>
+              <a:t>WHAT EACH NUMBER MEANS</a:t>
+            </a:r>
+          </a:p>
+          <a:p>
+            <a:r>
+              <a:t>- "4 of 10 drug candidates" = a company has 10 possible medicines in testing and money to develop only 4. Our main example.</a:t>
+            </a:r>
+          </a:p>
+          <a:p>
+            <a:r>
+              <a:t>- "10 minutes per 28 days" = the total time IBM lets a free account use its real quantum computers. Minutes used today come back only after 28 days.</a:t>
+            </a:r>
+          </a:p>
+          <a:p>
+            <a:r>
+              <a:t>- "pay by the second" = paying customers are billed for every second of quantum computer use, so wasted runs cost real money.</a:t>
+            </a:r>
+          </a:p>
+          <a:p>
+            <a:r>
+              <a:t>- 1,024 combinations = with 10 yes/no choices there are 1,024 possible combinations (2 × 2 × ... ten times). With 50 choices it becomes about a quadrillion, which is why these decisions are hard.</a:t>
             </a:r>
           </a:p>
           <a:p/>
           <a:p>
             <a:r>
-              <a:t>WHY IT MATTERS (background)</a:t>
-            </a:r>
-          </a:p>
-          <a:p>
-            <a:r>
-              <a:t>- The number of possible choices explodes: 10 items have 1,024 combinations; 50 items about a quadrillion.</a:t>
-            </a:r>
-          </a:p>
-          <a:p>
-            <a:r>
-              <a:t>- IBM, D-Wave and Amazon rent different kinds of quantum hardware, and users mostly guess which to use. D-Wave's hybrid solvers already split work between classical and quantum behind the scenes, so routing is a real industry need.</a:t>
-            </a:r>
-          </a:p>
-          <a:p>
-            <a:r>
-              <a:t>- The event's theme, "a decade of quantum on the cloud", is exactly this: shared, scarce quantum machines.</a:t>
+              <a:t>BACKGROUND</a:t>
+            </a:r>
+          </a:p>
+          <a:p>
+            <a:r>
+              <a:t>- IBM, D-Wave and Amazon rent out different kinds of quantum computers, and users mostly guess which to use. D-Wave's "hybrid" service already splits work between normal and quantum computers behind the scenes, so deciding where work goes is a real industry need.</a:t>
+            </a:r>
+          </a:p>
+          <a:p>
+            <a:r>
+              <a:t>- This year's theme, "a decade of quantum on the cloud", is exactly this: shared, scarce quantum machines.</a:t>
             </a:r>
           </a:p>
           <a:p/>
@@ -3924,7 +4120,7 @@
           </a:p>
           <a:p>
             <a:r>
-              <a:t>A: Knowing when and how to use quantum computing so scarce quantum time isn't wasted. For companies paying for quantum time, for cloud providers routing jobs, and for researchers with small budgets.</a:t>
+              <a:t>A: Knowing when and how to use a quantum computer, so scarce quantum time isn't wasted. For companies paying for quantum time, for the companies renting it out, and for researchers with small budgets.</a:t>
             </a:r>
           </a:p>
           <a:p>
@@ -3934,7 +4130,7 @@
           </a:p>
           <a:p>
             <a:r>
-              <a:t>A: Yes. Today the honest answer is usually "use the laptop", and Q-Router says so. As chips improve, deciding which problems and which kind of quantum computer becomes more valuable, and choosing between the two quantum kinds already matters for anyone running quantum experiments now.</a:t>
+              <a:t>A: Yes. Today the honest answer is usually "use the laptop", and Q-Router says so. As chips improve, choosing which problems and which kind of quantum computer becomes more valuable.</a:t>
             </a:r>
           </a:p>
         </p:txBody>
@@ -4074,7 +4270,7 @@
           <a:lstStyle/>
           <a:p>
             <a:r>
-              <a:t>SLIDE 3 · DECISION → SCORE (QUBO) · target 0:30</a:t>
+              <a:t>SLIDE 3 · DECISION → SCORE (QUBO) · speak for about 30 seconds</a:t>
             </a:r>
           </a:p>
           <a:p/>
@@ -4085,49 +4281,64 @@
           </a:p>
           <a:p>
             <a:r>
-              <a:t>"First, every decision becomes one shared score sheet called a QUBO. Each yes-or-no choice is one qubit. Each choice has a value, each pair of choices has a risk, and rules like 'fund exactly 4' become a penalty. The lowest score is the best decision. Because every industry uses this same format, one router can serve all of them. Honest note: our tests use 3 to 18 qubits; real decisions need 50 to 200."</a:t>
+              <a:t>"First, every decision becomes one shared score sheet called a QUBO. Each yes-or-no choice is one qubit. Each choice has a value, each pair of choices has a risk, and rules like 'fund exactly 4' become a penalty. The lowest score is the best decision. Because every industry uses this same format, one router can serve all of them. Honest note: our tests use 3 to 18 qubits, meaning 3 to 18 yes/no choices; real company decisions need 50 to 200."</a:t>
             </a:r>
           </a:p>
           <a:p/>
           <a:p>
             <a:r>
-              <a:t>WHAT'S ON THE SLIDE</a:t>
-            </a:r>
-          </a:p>
-          <a:p>
-            <a:r>
-              <a:t>Ten choices (x1-x10) feed a score: minus expected value, plus pair risk, plus a size penalty. The energy landscape is a picture of searching for the lowest valley; it's conceptual.</a:t>
+              <a:t>WHAT EACH NUMBER MEANS</a:t>
+            </a:r>
+          </a:p>
+          <a:p>
+            <a:r>
+              <a:t>- x1 ... x10 on the slide = ten yes/no choices, for example "fund drug 1?" through "fund drug 10?". Each one becomes one qubit.</a:t>
+            </a:r>
+          </a:p>
+          <a:p>
+            <a:r>
+              <a:t>- "3-18 qubits" = our test problems had between 3 and 18 yes/no choices.</a:t>
+            </a:r>
+          </a:p>
+          <a:p>
+            <a:r>
+              <a:t>- "50-200" = how many choices real company decisions have (for example, a big drug company's pipeline). Our tests are much smaller.</a:t>
+            </a:r>
+          </a:p>
+          <a:p>
+            <a:r>
+              <a:t>- "Lower score = better" = the score sheet adds up good things as negative numbers and bad things as positive numbers, so the smallest total is the best decision.</a:t>
             </a:r>
           </a:p>
           <a:p/>
           <a:p>
             <a:r>
-              <a:t>DETAILS (if needed)</a:t>
-            </a:r>
-          </a:p>
-          <a:p>
-            <a:r>
-              <a:t>- Drug value = chance of approval × sales if approved − development cost. Approval rates by phase: about 8% (Phase I), 15% (Phase II), 55% (Phase III).</a:t>
-            </a:r>
-          </a:p>
-          <a:p>
-            <a:r>
-              <a:t>- Drugs for the same disease are strongly linked (correlation 0.6), different diseases weakly (0.1).</a:t>
-            </a:r>
-          </a:p>
-          <a:p>
-            <a:r>
-              <a:t>- Penalty = P × (number funded − 4)², with P bigger than any gain, so breaking the rule never pays.</a:t>
-            </a:r>
-          </a:p>
-          <a:p>
-            <a:r>
-              <a:t>- The same math investors use for stock portfolios (Markowitz), applied to drugs.</a:t>
-            </a:r>
-          </a:p>
-          <a:p>
-            <a:r>
-              <a:t>- Data: stock prices are real (12 healthcare stocks, 2023-2025); medical tests are a real breast-cancer dataset (569 patients); the drug list is simulated with real phase success rates.</a:t>
+              <a:t>HOW THE DRUG SCORE IS BUILT (if asked)</a:t>
+            </a:r>
+          </a:p>
+          <a:p>
+            <a:r>
+              <a:t>- Each drug's value = (chance it gets approved) × (sales if approved) − (cost to develop it).</a:t>
+            </a:r>
+          </a:p>
+          <a:p>
+            <a:r>
+              <a:t>- Approval chances by testing stage: about 8% for early (Phase I) drugs, 15% for middle (Phase II), 55% for late (Phase III). So a late-stage drug is about 7 times more likely to succeed than an early one.</a:t>
+            </a:r>
+          </a:p>
+          <a:p>
+            <a:r>
+              <a:t>- 0.6 vs 0.1 = how strongly two drugs' success is tied together: 0.6 (strong) if they treat the same disease, 0.1 (weak) if they treat different diseases. Strong ties add risk.</a:t>
+            </a:r>
+          </a:p>
+          <a:p>
+            <a:r>
+              <a:t>- The rule "fund exactly 4" is a penalty so large that breaking the rule can never improve the score.</a:t>
+            </a:r>
+          </a:p>
+          <a:p>
+            <a:r>
+              <a:t>- Data: stock prices are real (12 healthcare stocks, 2023-2025); the medical-test data is a real breast-cancer dataset (569 patients); the drug list is made up but uses those real approval rates.</a:t>
             </a:r>
           </a:p>
           <a:p/>
@@ -4144,16 +4355,6 @@
           <a:p>
             <a:r>
               <a:t>A: A score sheet for yes/no choices: points for each yes and for each pair of yeses; lower is better. Rules become penalties. Every solver in our project reads it.</a:t>
-            </a:r>
-          </a:p>
-          <a:p>
-            <a:r>
-              <a:t>Q: Is the data real?</a:t>
-            </a:r>
-          </a:p>
-          <a:p>
-            <a:r>
-              <a:t>A: Stocks and medical tests yes; the drug pipeline is simulated using real industry approval rates. Real ClinicalTrials.gov data is a next step.</a:t>
             </a:r>
           </a:p>
         </p:txBody>
@@ -4293,7 +4494,7 @@
           <a:lstStyle/>
           <a:p>
             <a:r>
-              <a:t>SLIDE 4 · THREE SOLVERS · target 0:40</a:t>
+              <a:t>SLIDE 4 · THREE SOLVERS · speak for about 40 seconds</a:t>
             </a:r>
           </a:p>
           <a:p/>
@@ -4304,49 +4505,75 @@
           </a:p>
           <a:p>
             <a:r>
-              <a:t>"We compare three ways to solve the score sheet. Gate-based QAOA is a short quantum recipe: mix all answers, link choices that affect each other, shuffle, measure. It has two dials that we tune on a simulator. The digital anneal copies D-Wave-style annealing on IBM's chip using many small steps: a smoother sweep, but many more error-prone steps. And a normal laptop running simulated annealing scores 0.95 to 0.98 in a hundredth of a second. At this size the laptop wins, and we say so. Quantum is interesting because paired choices map onto linked qubits, but every step on today's chips can fail."</a:t>
+              <a:t>"We compare three ways to solve the score sheet. Gate-based QAOA is a short quantum recipe with two tunable dials. The digital anneal copies D-Wave-style annealing on IBM's chip with many small steps: smoother, but more steps that can go wrong. And a normal laptop running simulated annealing scores between 0.95 and 0.98 out of 1, nearly perfect, in about a hundredth of a second. At this size the laptop wins, and we say so."</a:t>
             </a:r>
           </a:p>
           <a:p/>
           <a:p>
             <a:r>
-              <a:t>WHAT'S ON THE SLIDE</a:t>
-            </a:r>
-          </a:p>
-          <a:p>
-            <a:r>
-              <a:t>Three cards (two quantum methods and the baseline) and the noise banner: 100 link steps at 0.5% error each gives only a 61% chance the whole run is error-free.</a:t>
+              <a:t>HOW TO READ OUR SCORES: every score is between 0 and 1. 1 = the perfect (true best) answer. 0 = no better than picking at random. So 0.64 means "64% of the way from a random guess to the perfect answer."</a:t>
             </a:r>
           </a:p>
           <a:p/>
           <a:p>
             <a:r>
-              <a:t>HOW EACH WORKS (if needed)</a:t>
-            </a:r>
-          </a:p>
-          <a:p>
-            <a:r>
-              <a:t>- QAOA circuit: Hadamards put every qubit in a 50/50 mix; an RZ rotation per qubit for its value; an RZZ gate per connected pair (this is the entanglement); RX rotations to shuffle; repeat 1-2 rounds; measure thousands of times ("shots").</a:t>
-            </a:r>
-          </a:p>
-          <a:p>
-            <a:r>
-              <a:t>- Tuning: an optimizer (COBYLA) tries dial settings about 60-120 times on the simulator, never on the chip.</a:t>
-            </a:r>
-          </a:p>
-          <a:p>
-            <a:r>
-              <a:t>- Digital anneal: the same building blocks repeated 3-6 rounds on a fixed even ramp (shuffle fades out, problem fades in). Also called linear-ramp QAOA; used on IBM hardware at 100+ qubits by other groups.</a:t>
-            </a:r>
-          </a:p>
-          <a:p>
-            <a:r>
-              <a:t>- Scoring: 1 = the true best answer (found by checking every combination), 0 = no better than random guessing; we average over every shot.</a:t>
+              <a:t>WHAT EACH NUMBER MEANS</a:t>
+            </a:r>
+          </a:p>
+          <a:p>
+            <a:r>
+              <a:t>- "1-2 rounds" (gate-based) = the recipe's steps are repeated only once or twice, so it's short.</a:t>
+            </a:r>
+          </a:p>
+          <a:p>
+            <a:r>
+              <a:t>- "60-120 simulator tries" = to find good dial settings, a program tries 60 to 120 different settings on a normal computer pretending to be quantum (a simulator), never on the real chip.</a:t>
+            </a:r>
+          </a:p>
+          <a:p>
+            <a:r>
+              <a:t>- "two dials" = two numbers that control the recipe (explained on slide 7).</a:t>
+            </a:r>
+          </a:p>
+          <a:p>
+            <a:r>
+              <a:t>- "3-6 rounds" (digital anneal) = its steps repeat 3 to 6 times, so it's longer, with more chances for errors.</a:t>
+            </a:r>
+          </a:p>
+          <a:p>
+            <a:r>
+              <a:t>- "0.95-0.98" (laptop) = on every test problem, the laptop's answers were 95-98% of the way from a random guess to the perfect answer, basically always right.</a:t>
+            </a:r>
+          </a:p>
+          <a:p>
+            <a:r>
+              <a:t>- "0.01 s" = the laptop takes about one hundredth of a second.</a:t>
+            </a:r>
+          </a:p>
+          <a:p>
+            <a:r>
+              <a:t>- The yellow banner: "100 link steps at 0.5% error each → 39% chance something went wrong" = each of the chip's linking steps fails 0.5% of the time (1 in 200). Do 100 of them and the chance that ALL succeed is only about 61%, so there's a 39% chance at least one went wrong. Longer recipes are riskier.</a:t>
             </a:r>
           </a:p>
           <a:p/>
           <a:p>
             <a:r>
+              <a:t>HOW EACH WORKS (if asked)</a:t>
+            </a:r>
+          </a:p>
+          <a:p>
+            <a:r>
+              <a:t>- Gate-based recipe: put every qubit in a 50/50 mix of yes and no; nudge each choice by its value; link every pair of choices that affect each other (this linking is "entanglement"); shuffle; repeat; then measure thousands of times. Each measurement ("shot") gives one complete answer.</a:t>
+            </a:r>
+          </a:p>
+          <a:p>
+            <a:r>
+              <a:t>- Digital anneal: the same building blocks repeated more times on a fixed schedule, imitating a slow "settle into the best answer" process.</a:t>
+            </a:r>
+          </a:p>
+          <a:p/>
+          <a:p>
+            <a:r>
               <a:t>IF A JUDGE ASKS</a:t>
             </a:r>
           </a:p>
@@ -4357,7 +4584,7 @@
           </a:p>
           <a:p>
             <a:r>
-              <a:t>A: At this size classical wins, and we show it. Quantum fits the structure (paired choices map to linked qubits); the question is whether that pays off for bigger problems on better chips.</a:t>
+              <a:t>A: At this size classical wins, and we show it. Quantum fits the structure (pairs of linked choices match pairs of linked qubits); the open question is whether that pays off for bigger problems on better chips.</a:t>
             </a:r>
           </a:p>
           <a:p>
@@ -4367,17 +4594,7 @@
           </a:p>
           <a:p>
             <a:r>
-              <a:t>A: It's annealing copied onto IBM's gate-based chip; a real D-Wave could plug into the same router.</a:t>
-            </a:r>
-          </a:p>
-          <a:p>
-            <a:r>
-              <a:t>Q: Walk me through your circuit.</a:t>
-            </a:r>
-          </a:p>
-          <a:p>
-            <a:r>
-              <a:t>A: Mix, nudge each choice by its value, link connected pairs, shuffle, repeat, measure.</a:t>
+              <a:t>A: It's annealing copied onto IBM's gate-based chip; a real D-Wave annealer could plug into the same router.</a:t>
             </a:r>
           </a:p>
         </p:txBody>
@@ -30487,7 +30704,7 @@
                 </a:solidFill>
                 <a:latin typeface="Arial"/>
               </a:rPr>
-              <a:t>COPYING FROM A SIMILAR SHAPE BEATS A RANDOM COPY (0.599 VS 0.577): HALF THE GAIN OF TUNING, 1/60 THE COST</a:t>
+              <a:t>COPYING FROM A SIMILAR SHAPE BEATS A RANDOM COPY (0.599 VS 0.577): A THIRD OF TUNING'S GAIN FOR 1/60 OF THE COST</a:t>
             </a:r>
           </a:p>
         </p:txBody>

</xml_diff>

<commit_message>
Deck: add worked solutions from two industries using the twin method
Co-Authored-By: Claude Opus 5.5 <noreply@anthropic.com>
</commit_message>
<xml_diff>
--- a/slides/Q-Router_presentation.pptx
+++ b/slides/Q-Router_presentation.pptx
@@ -15,6 +15,7 @@
     <p:sldId id="266" r:id="rId17"/>
     <p:sldId id="267" r:id="rId18"/>
     <p:sldId id="268" r:id="rId19"/>
+    <p:sldId id="273" r:id="rId24"/>
     <p:sldId id="269" r:id="rId20"/>
     <p:sldId id="270" r:id="rId21"/>
     <p:sldId id="272" r:id="rId23"/>
@@ -2801,7 +2802,7 @@
           <a:lstStyle/>
           <a:p>
             <a:r>
-              <a:t>SLIDE 11 · WHAT'S NEXT + TAKEAWAY · speak for about 30 seconds</a:t>
+              <a:t>SLIDE 12 · WHAT'S NEXT + TAKEAWAY · speak for about 30 seconds</a:t>
             </a:r>
           </a:p>
           <a:p/>
@@ -3111,7 +3112,7 @@
           </a:p>
           <a:p>
             <a:r>
-              <a:t>A: No, on a simulator. The real chip was used for our final tests (slides 9 and 10).</a:t>
+              <a:t>A: No, on a simulator. The real chip was used for our final tests (slides 10 and 11).</a:t>
             </a:r>
           </a:p>
         </p:txBody>
@@ -3180,7 +3181,7 @@
           </a:p>
           <a:p>
             <a:r>
-              <a:t>"This is the pattern recognition. Each dot is one of our 60 practice problems, placed by its nine-number fingerprint, so problems with similar shapes land close together. Stocks and drug funding cluster together, because both are fully connected. Networks and medical tests mix together, because both are loosely connected. So the shape of a problem, not its industry, decides which solver fits, and what we learn in one industry carries over to another."</a:t>
+              <a:t>"This is the pattern recognition: each dot is a practice problem placed by its fingerprint. Stocks and drugs cluster together, both fully connected; networks and medical tests cluster together, both loose. Shape, not industry, decides which solver fits, so lessons carry across industries."</a:t>
             </a:r>
           </a:p>
           <a:p/>
@@ -3307,7 +3308,7 @@
           </a:p>
           <a:p>
             <a:r>
-              <a:t>"The gate-based recipe has two dials, two numbers that normally take about 60 tries to tune. Here's where ours come from: we tuned each of our 60 practice problems once, on a simulator, at no quantum cost, and saved the dials in a library next to each problem's shape. When a new problem arrives, Q-Router finds the closest shape from a different industry and copies its dials, then runs once. Copied dials scored 0.60 out of 1, close to 0.63 for full tuning, while copying from a random problem scored 0.58, no better than no tuning. So it's the shape match that works: about a third of the benefit of tuning, for one sixtieth of the effort."</a:t>
+              <a:t>"The gate-based recipe has two dials, two numbers that normally take about 60 tries to tune. We tuned each of our 60 practice problems once, on a simulator, and saved the dials in a library next to each problem's shape. When a new problem arrives, Q-Router finds the closest shape from a different industry and copies its dials, then runs once. Copied dials scored 0.60 out of 1, close to 0.63 for full tuning, while copying from a random problem scored 0.58, no better than no tuning. So it's the shape match that works: about a third of the benefit of tuning, for one sixtieth of the effort."</a:t>
             </a:r>
           </a:p>
           <a:p/>
@@ -3506,7 +3507,7 @@
           <a:lstStyle/>
           <a:p>
             <a:r>
-              <a:t>SLIDE 8 · MANY PROBLEMS, ONE RUN · speak for about 40 seconds</a:t>
+              <a:t>SLIDE 9 · MANY PROBLEMS, ONE RUN · speak for about 40 seconds</a:t>
             </a:r>
           </a:p>
           <a:p/>
@@ -3675,7 +3676,7 @@
           <a:lstStyle/>
           <a:p>
             <a:r>
-              <a:t>SLIDE 9 · GATE-BASED VS. ANNEALING, PIECE BY PIECE · speak for about 45 seconds</a:t>
+              <a:t>SLIDE 10 · GATE-BASED VS. ANNEALING, PIECE BY PIECE · speak for about 45 seconds</a:t>
             </a:r>
           </a:p>
           <a:p/>
@@ -3686,7 +3687,7 @@
           </a:p>
           <a:p>
             <a:r>
-              <a:t>"Now the key comparison, on the real IBM chip. We split one decision, drug funding plus clinical-trial sites, into three pieces and ran both quantum computers on every piece. Gate-based wins the dense drug piece: 0.55 versus 0.34. Annealing wins both loosely connected trial-site pieces: 0.42 versus 0.38, and 0.73 versus 0.41. Annealing needs about seven times more error-prone linking steps, so it only pays off where choices are loosely linked. Q-Router's mix scores 0.55, beating all gate-based at 0.45 and all annealing at 0.49."</a:t>
+              <a:t>"Now the key comparison, on the real IBM chip: one decision split into three pieces, each solved by both quantum computers. Gate-based wins the dense drug piece: 0.55 versus 0.34. Annealing wins both loosely connected trial-site pieces: 0.42 versus 0.38, and 0.73 versus 0.41. Annealing needs about seven times more error-prone linking steps, so it only pays off where choices are loosely linked. Q-Router's mix scores 0.55, beating all gate-based at 0.45 and all annealing at 0.49."</a:t>
             </a:r>
           </a:p>
           <a:p/>
@@ -3839,7 +3840,7 @@
           <a:lstStyle/>
           <a:p>
             <a:r>
-              <a:t>SLIDE 10 · REAL IBM HARDWARE · speak for about 40 seconds</a:t>
+              <a:t>SLIDE 11 · REAL IBM HARDWARE · speak for about 40 seconds</a:t>
             </a:r>
           </a:p>
           <a:p/>
@@ -3850,7 +3851,7 @@
           </a:p>
           <a:p>
             <a:r>
-              <a:t>"Finally, the full real-hardware test on IBM's 156-qubit ibm_kingston. We ran our drug problem, choosing 3 of 8 drugs, four ways. On a perfect simulator with no errors, annealing beats gate-based: 0.80 versus 0.72. On the real chip it flips: gate-based 0.64, annealing 0.55, because annealing needs about six times more error-prone steps. That's exactly why a router is needed. The chip's most common answer was a good set, not the best, but the true best showed up in every run, two to three times more often than random guessing. IBM's error fixes actually made scores worse. Overall: on the real chip gate-based beat annealing, and the laptop beat both."</a:t>
+              <a:t>"Finally, IBM's real 156-qubit ibm_kingston, on our drug problem. With no errors, annealing beats gate-based, 0.80 to 0.72. On the real chip it flips, 0.64 to 0.55, because annealing needs about six times more error-prone steps. That's why a router is needed. The chip's most common answer was a good set, not the best, but the true best showed up in every run, two to three times more often than random guessing. IBM's error fixes actually made scores worse. Overall: on the real chip gate-based beat annealing, and the laptop beat both."</a:t>
             </a:r>
           </a:p>
           <a:p/>
@@ -3955,6 +3956,200 @@
           <a:p>
             <a:r>
               <a:t>A: Yes: the true best set was among the chip's answers in every run, but its most common answer wasn't it. A laptop finds the best set every time, which is why we claim no quantum advantage.</a:t>
+            </a:r>
+          </a:p>
+        </p:txBody>
+      </p:sp>
+    </p:spTree>
+  </p:cSld>
+  <p:clrMapOvr>
+    <a:masterClrMapping/>
+  </p:clrMapOvr>
+</p:notes>
+</file>
+
+<file path=ppt/notesSlides/notesSlide18.xml><?xml version="1.0" encoding="utf-8"?>
+<p:notes xmlns:a="http://schemas.openxmlformats.org/drawingml/2006/main" xmlns:p="http://schemas.openxmlformats.org/presentationml/2006/main" xmlns:r="http://schemas.openxmlformats.org/officeDocument/2006/relationships">
+  <p:cSld>
+    <p:spTree>
+      <p:nvGrpSpPr>
+        <p:cNvPr id="1" name=""/>
+        <p:cNvGrpSpPr/>
+        <p:nvPr/>
+      </p:nvGrpSpPr>
+      <p:grpSpPr>
+        <a:xfrm>
+          <a:off x="0" y="0"/>
+          <a:ext cx="0" cy="0"/>
+          <a:chOff x="0" y="0"/>
+          <a:chExt cx="0" cy="0"/>
+        </a:xfrm>
+      </p:grpSpPr>
+      <p:sp>
+        <p:nvSpPr>
+          <p:cNvPr id="2" name="Slide Image Placeholder 1"/>
+          <p:cNvSpPr>
+            <a:spLocks noGrp="1"/>
+          </p:cNvSpPr>
+          <p:nvPr>
+            <p:ph type="sldImg" idx="2"/>
+          </p:nvPr>
+        </p:nvSpPr>
+        <p:spPr/>
+      </p:sp>
+      <p:sp>
+        <p:nvSpPr>
+          <p:cNvPr id="3" name="Notes Placeholder 2"/>
+          <p:cNvSpPr>
+            <a:spLocks noGrp="1"/>
+          </p:cNvSpPr>
+          <p:nvPr>
+            <p:ph type="body" idx="1"/>
+          </p:nvPr>
+        </p:nvSpPr>
+        <p:spPr/>
+        <p:txBody>
+          <a:bodyPr/>
+          <a:lstStyle/>
+          <a:p>
+            <a:r>
+              <a:t>SLIDE 8 · THE TWIN METHOD, SOLVING TWO INDUSTRIES · speak for about 40 seconds</a:t>
+            </a:r>
+          </a:p>
+          <a:p/>
+          <a:p>
+            <a:r>
+              <a:t>WHAT TO SAY</a:t>
+            </a:r>
+          </a:p>
+          <a:p>
+            <a:r>
+              <a:t>"Here's the twin method producing real decisions in two industries. Finance: which 2 of 6 healthcare stocks to hold. Q-Router copied its dials from a drug-pipeline problem with the same shape, ran once, and answered HCA and ISRG, the true best: the two highest returns with moderate risk. Healthcare: which tumor measurements to order for a breast-cancer diagnosis. It copied dials from a network problem and answered texture, area and compactness, also the true best. It skips radius and perimeter because they just repeat area. Both answers are correct, each found with one run instead of about sixty."</a:t>
+            </a:r>
+          </a:p>
+          <a:p/>
+          <a:p>
+            <a:r>
+              <a:t>HOW TO READ OUR SCORES: every score is between 0 and 1. 1 = the perfect (true best) answer. 0 = no better than picking at random. So 0.64 means "64% of the way from a random guess to the perfect answer."</a:t>
+            </a:r>
+          </a:p>
+          <a:p/>
+          <a:p>
+            <a:r>
+              <a:t>FINANCE EXAMPLE (left card)</a:t>
+            </a:r>
+          </a:p>
+          <a:p>
+            <a:r>
+              <a:t>- "Hold 2 of 6" = choose 2 stocks out of 6 (ABBV, ABT, CI, CVS, HCA, ISRG). There are 15 possible pairs.</a:t>
+            </a:r>
+          </a:p>
+          <a:p>
+            <a:r>
+              <a:t>- "Return/yr" = how much the stock grew per year on average, 2023-2025, from real prices. HCA 26% a year, ISRG 30% a year (the two highest).</a:t>
+            </a:r>
+          </a:p>
+          <a:p>
+            <a:r>
+              <a:t>- "Risk/yr" = how much the price swings up and down in a typical year. HCA 25%, ISRG 31%. Similar to the others, so taking the two best performers doesn't add extra risk.</a:t>
+            </a:r>
+          </a:p>
+          <a:p>
+            <a:r>
+              <a:t>- HCA = HCA Healthcare (hospitals); ISRG = Intuitive Surgical (surgical robots).</a:t>
+            </a:r>
+          </a:p>
+          <a:p>
+            <a:r>
+              <a:t>- "Dials copied from drug pipeline" = the closest-shaped problem in our library came from a different industry (pharma); both are fully connected 6-choice problems, so its two dial numbers were reused.</a:t>
+            </a:r>
+          </a:p>
+          <a:p>
+            <a:r>
+              <a:t>- "Picked in 4.7% of shots (random: 1.6%)" = out of 4,096 measurements of the recipe, 4.7% gave exactly HCA + ISRG; a random guess would land on it 1.6% of the time (1 in 64). It was also the single most common answer.</a:t>
+            </a:r>
+          </a:p>
+          <a:p>
+            <a:r>
+              <a:t>- "Score 0.68, same as full tuning (0.68)" = the copied dials worked exactly as well as tuning from scratch: the answers were 68% of the way from random to perfect, for 1 run instead of about 60.</a:t>
+            </a:r>
+          </a:p>
+          <a:p/>
+          <a:p>
+            <a:r>
+              <a:t>HEALTHCARE EXAMPLE (right card)</a:t>
+            </a:r>
+          </a:p>
+          <a:p>
+            <a:r>
+              <a:t>- "6 tests" = six tumor measurements from a real breast-cancer dataset of 569 patients: radius, texture, perimeter, area, smoothness, compactness.</a:t>
+            </a:r>
+          </a:p>
+          <a:p>
+            <a:r>
+              <a:t>- "Most useful, least repetitive" = each test gets points for how well it predicts the diagnosis, and loses points if it repeats information another chosen test already gives. There is no fixed number to pick.</a:t>
+            </a:r>
+          </a:p>
+          <a:p>
+            <a:r>
+              <a:t>- Answer: texture + area + compactness. Radius, perimeter and area all measure the tumor's size, so choosing area covers all three; smoothness adds little.</a:t>
+            </a:r>
+          </a:p>
+          <a:p>
+            <a:r>
+              <a:t>- "Dials copied from network split" = its closest-shaped problem came from the networks industry (both loosely connected).</a:t>
+            </a:r>
+          </a:p>
+          <a:p>
+            <a:r>
+              <a:t>- "Picked in 8.8% of shots (random: 1.6%)" = the correct set of tests came up in 8.8% of measurements, about 5 times more often than a random guess. It was also the most common answer.</a:t>
+            </a:r>
+          </a:p>
+          <a:p>
+            <a:r>
+              <a:t>- "Score 0.25 vs 0.39 with full tuning" = here copied dials worked less well than tuning from scratch (25% vs 39% of the way to perfect), even though the most common answer was still right. This matches our finding that copying helps medical-test problems least.</a:t>
+            </a:r>
+          </a:p>
+          <a:p/>
+          <a:p>
+            <a:r>
+              <a:t>IMPORTANT CONTEXT</a:t>
+            </a:r>
+          </a:p>
+          <a:p>
+            <a:r>
+              <a:t>- These two runs are on the simulator (a normal computer imitating a perfect quantum computer), not the real chip.</a:t>
+            </a:r>
+          </a:p>
+          <a:p>
+            <a:r>
+              <a:t>- A laptop also finds both answers (scores 0.95 and 1.00), which is why we claim no quantum advantage. The point of the slide is that the twin method does produce correct real-world decisions, with much less tuning.</a:t>
+            </a:r>
+          </a:p>
+          <a:p/>
+          <a:p>
+            <a:r>
+              <a:t>IF A JUDGE ASKS</a:t>
+            </a:r>
+          </a:p>
+          <a:p>
+            <a:r>
+              <a:t>Q: Does your system actually solve the problems?</a:t>
+            </a:r>
+          </a:p>
+          <a:p>
+            <a:r>
+              <a:t>A: Yes: for both examples the answer matches the true best, which we verify by checking every combination.</a:t>
+            </a:r>
+          </a:p>
+          <a:p>
+            <a:r>
+              <a:t>Q: Why did a healthcare problem copy settings from a network problem?</a:t>
+            </a:r>
+          </a:p>
+          <a:p>
+            <a:r>
+              <a:t>A: Because their shapes are similar; the router matches by shape, not by industry.</a:t>
             </a:r>
           </a:p>
         </p:txBody>
@@ -4062,7 +4257,7 @@
           </a:p>
           <a:p>
             <a:r>
-              <a:t>"Companies keep making the same kind of decision: pick the best few out of many. Which 4 of 10 drug candidates to fund, which stocks to hold, which medical tests to order. Quantum computers might help, but quantum time is rare and expensive: our free IBM plan gives us 10 minutes a month, and companies pay by the second. There are two kinds of quantum computer, and today's chips make errors, so sending a problem to the wrong machine wastes money and gives a bad answer. Q-Router answers three questions: is quantum worth it, which kind, and for which part of the problem."</a:t>
+              <a:t>"Companies keep making the same kind of decision: pick the best few out of many, like which 4 of 10 drugs to fund, which stocks to hold, which tests to order. Quantum computers might help, but quantum time is scarce: our free IBM plan gives 10 minutes a month. There are two kinds of quantum computer, and today's chips make errors, so sending a problem to the wrong machine wastes money and gives a bad answer. Q-Router answers three questions: is quantum worth it, which kind, and for which part of the problem."</a:t>
             </a:r>
           </a:p>
           <a:p/>
@@ -21303,7 +21498,7 @@
                 <a:cs typeface="Arial"/>
                 <a:sym typeface="Arial"/>
               </a:rPr>
-              <a:t>11</a:t>
+              <a:t>12</a:t>
             </a:r>
             <a:endParaRPr/>
           </a:p>
@@ -21353,7 +21548,7 @@
                 <a:cs typeface="Arial"/>
                 <a:sym typeface="Arial"/>
               </a:rPr>
-              <a:t>10 / WHAT'S NEXT</a:t>
+              <a:t>11 / WHAT'S NEXT</a:t>
             </a:r>
             <a:endParaRPr/>
           </a:p>
@@ -31738,7 +31933,7 @@
                 <a:cs typeface="Arial"/>
                 <a:sym typeface="Arial"/>
               </a:rPr>
-              <a:t>08</a:t>
+              <a:t>09</a:t>
             </a:r>
             <a:endParaRPr/>
           </a:p>
@@ -31788,7 +31983,7 @@
                 <a:cs typeface="Arial"/>
                 <a:sym typeface="Arial"/>
               </a:rPr>
-              <a:t>07 / SAVING QUANTUM TIME</a:t>
+              <a:t>08 / SAVING QUANTUM TIME</a:t>
             </a:r>
             <a:endParaRPr/>
           </a:p>
@@ -34299,7 +34494,7 @@
                 <a:cs typeface="Arial"/>
                 <a:sym typeface="Arial"/>
               </a:rPr>
-              <a:t>09</a:t>
+              <a:t>10</a:t>
             </a:r>
             <a:endParaRPr/>
           </a:p>
@@ -34349,7 +34544,7 @@
                 <a:cs typeface="Arial"/>
                 <a:sym typeface="Arial"/>
               </a:rPr>
-              <a:t>08 / GATE-BASED VS. ANNEALING</a:t>
+              <a:t>09 / GATE-BASED VS. ANNEALING</a:t>
             </a:r>
             <a:endParaRPr/>
           </a:p>
@@ -36172,7 +36367,7 @@
                 <a:cs typeface="Arial"/>
                 <a:sym typeface="Arial"/>
               </a:rPr>
-              <a:t>10</a:t>
+              <a:t>11</a:t>
             </a:r>
             <a:endParaRPr/>
           </a:p>
@@ -36222,7 +36417,7 @@
                 <a:cs typeface="Arial"/>
                 <a:sym typeface="Arial"/>
               </a:rPr>
-              <a:t>09 / REAL IBM HARDWARE</a:t>
+              <a:t>10 / REAL IBM HARDWARE</a:t>
             </a:r>
             <a:endParaRPr/>
           </a:p>
@@ -36749,6 +36944,2935 @@
                 <a:latin typeface="Arial"/>
               </a:rPr>
               <a:t>OVERALL ON THE REAL CHIP: GATE-BASED 0.64 BEATS ANNEALING 0.55 · THE LAPTOP (0.93) STILL WINS</a:t>
+            </a:r>
+          </a:p>
+        </p:txBody>
+      </p:sp>
+    </p:spTree>
+  </p:cSld>
+  <p:clrMapOvr>
+    <a:masterClrMapping/>
+  </p:clrMapOvr>
+</p:sld>
+</file>
+
+<file path=ppt/slides/slide18.xml><?xml version="1.0" encoding="utf-8"?>
+<p:sld xmlns:a="http://schemas.openxmlformats.org/drawingml/2006/main" xmlns:p="http://schemas.openxmlformats.org/presentationml/2006/main" xmlns:r="http://schemas.openxmlformats.org/officeDocument/2006/relationships">
+  <p:cSld>
+    <p:bg>
+      <p:bgPr>
+        <a:solidFill>
+          <a:srgbClr val="050816"/>
+        </a:solidFill>
+        <a:effectLst/>
+      </p:bgPr>
+    </p:bg>
+    <p:spTree>
+      <p:nvGrpSpPr>
+        <p:cNvPr id="1" name=""/>
+        <p:cNvGrpSpPr/>
+        <p:nvPr/>
+      </p:nvGrpSpPr>
+      <p:grpSpPr/>
+      <p:cxnSp>
+        <p:nvCxnSpPr>
+          <p:cNvPr id="222" name="Google Shape;222;p2"/>
+          <p:cNvCxnSpPr/>
+          <p:nvPr/>
+        </p:nvCxnSpPr>
+        <p:spPr>
+          <a:xfrm>
+            <a:off x="457200" y="320040"/>
+            <a:ext cx="0" cy="6217920"/>
+          </a:xfrm>
+          <a:prstGeom prst="straightConnector1">
+            <a:avLst/>
+          </a:prstGeom>
+          <a:noFill/>
+          <a:ln cap="flat" cmpd="sng" w="9525">
+            <a:solidFill>
+              <a:srgbClr val="1C2948"/>
+            </a:solidFill>
+            <a:prstDash val="solid"/>
+            <a:round/>
+            <a:headEnd len="sm" w="sm" type="none"/>
+            <a:tailEnd len="sm" w="sm" type="none"/>
+          </a:ln>
+          <a:effectLst>
+            <a:outerShdw blurRad="40000" rotWithShape="0" dir="5400000" dist="20000">
+              <a:srgbClr val="000000">
+                <a:alpha val="38039"/>
+              </a:srgbClr>
+            </a:outerShdw>
+          </a:effectLst>
+        </p:spPr>
+      </p:cxnSp>
+      <p:cxnSp>
+        <p:nvCxnSpPr>
+          <p:cNvPr id="223" name="Google Shape;223;p2"/>
+          <p:cNvCxnSpPr/>
+          <p:nvPr/>
+        </p:nvCxnSpPr>
+        <p:spPr>
+          <a:xfrm>
+            <a:off x="1371600" y="320040"/>
+            <a:ext cx="0" cy="6217920"/>
+          </a:xfrm>
+          <a:prstGeom prst="straightConnector1">
+            <a:avLst/>
+          </a:prstGeom>
+          <a:noFill/>
+          <a:ln cap="flat" cmpd="sng" w="9525">
+            <a:solidFill>
+              <a:srgbClr val="1C2948"/>
+            </a:solidFill>
+            <a:prstDash val="solid"/>
+            <a:round/>
+            <a:headEnd len="sm" w="sm" type="none"/>
+            <a:tailEnd len="sm" w="sm" type="none"/>
+          </a:ln>
+          <a:effectLst>
+            <a:outerShdw blurRad="40000" rotWithShape="0" dir="5400000" dist="20000">
+              <a:srgbClr val="000000">
+                <a:alpha val="38039"/>
+              </a:srgbClr>
+            </a:outerShdw>
+          </a:effectLst>
+        </p:spPr>
+      </p:cxnSp>
+      <p:cxnSp>
+        <p:nvCxnSpPr>
+          <p:cNvPr id="224" name="Google Shape;224;p2"/>
+          <p:cNvCxnSpPr/>
+          <p:nvPr/>
+        </p:nvCxnSpPr>
+        <p:spPr>
+          <a:xfrm>
+            <a:off x="2286000" y="320040"/>
+            <a:ext cx="0" cy="6217920"/>
+          </a:xfrm>
+          <a:prstGeom prst="straightConnector1">
+            <a:avLst/>
+          </a:prstGeom>
+          <a:noFill/>
+          <a:ln cap="flat" cmpd="sng" w="9525">
+            <a:solidFill>
+              <a:srgbClr val="1C2948"/>
+            </a:solidFill>
+            <a:prstDash val="solid"/>
+            <a:round/>
+            <a:headEnd len="sm" w="sm" type="none"/>
+            <a:tailEnd len="sm" w="sm" type="none"/>
+          </a:ln>
+          <a:effectLst>
+            <a:outerShdw blurRad="40000" rotWithShape="0" dir="5400000" dist="20000">
+              <a:srgbClr val="000000">
+                <a:alpha val="38039"/>
+              </a:srgbClr>
+            </a:outerShdw>
+          </a:effectLst>
+        </p:spPr>
+      </p:cxnSp>
+      <p:cxnSp>
+        <p:nvCxnSpPr>
+          <p:cNvPr id="225" name="Google Shape;225;p2"/>
+          <p:cNvCxnSpPr/>
+          <p:nvPr/>
+        </p:nvCxnSpPr>
+        <p:spPr>
+          <a:xfrm>
+            <a:off x="3200400" y="320040"/>
+            <a:ext cx="0" cy="6217920"/>
+          </a:xfrm>
+          <a:prstGeom prst="straightConnector1">
+            <a:avLst/>
+          </a:prstGeom>
+          <a:noFill/>
+          <a:ln cap="flat" cmpd="sng" w="9525">
+            <a:solidFill>
+              <a:srgbClr val="1C2948"/>
+            </a:solidFill>
+            <a:prstDash val="solid"/>
+            <a:round/>
+            <a:headEnd len="sm" w="sm" type="none"/>
+            <a:tailEnd len="sm" w="sm" type="none"/>
+          </a:ln>
+          <a:effectLst>
+            <a:outerShdw blurRad="40000" rotWithShape="0" dir="5400000" dist="20000">
+              <a:srgbClr val="000000">
+                <a:alpha val="38039"/>
+              </a:srgbClr>
+            </a:outerShdw>
+          </a:effectLst>
+        </p:spPr>
+      </p:cxnSp>
+      <p:cxnSp>
+        <p:nvCxnSpPr>
+          <p:cNvPr id="226" name="Google Shape;226;p2"/>
+          <p:cNvCxnSpPr/>
+          <p:nvPr/>
+        </p:nvCxnSpPr>
+        <p:spPr>
+          <a:xfrm>
+            <a:off x="4114800" y="320040"/>
+            <a:ext cx="0" cy="6217920"/>
+          </a:xfrm>
+          <a:prstGeom prst="straightConnector1">
+            <a:avLst/>
+          </a:prstGeom>
+          <a:noFill/>
+          <a:ln cap="flat" cmpd="sng" w="9525">
+            <a:solidFill>
+              <a:srgbClr val="1C2948"/>
+            </a:solidFill>
+            <a:prstDash val="solid"/>
+            <a:round/>
+            <a:headEnd len="sm" w="sm" type="none"/>
+            <a:tailEnd len="sm" w="sm" type="none"/>
+          </a:ln>
+          <a:effectLst>
+            <a:outerShdw blurRad="40000" rotWithShape="0" dir="5400000" dist="20000">
+              <a:srgbClr val="000000">
+                <a:alpha val="38039"/>
+              </a:srgbClr>
+            </a:outerShdw>
+          </a:effectLst>
+        </p:spPr>
+      </p:cxnSp>
+      <p:cxnSp>
+        <p:nvCxnSpPr>
+          <p:cNvPr id="227" name="Google Shape;227;p2"/>
+          <p:cNvCxnSpPr/>
+          <p:nvPr/>
+        </p:nvCxnSpPr>
+        <p:spPr>
+          <a:xfrm>
+            <a:off x="5029200" y="320040"/>
+            <a:ext cx="0" cy="6217920"/>
+          </a:xfrm>
+          <a:prstGeom prst="straightConnector1">
+            <a:avLst/>
+          </a:prstGeom>
+          <a:noFill/>
+          <a:ln cap="flat" cmpd="sng" w="9525">
+            <a:solidFill>
+              <a:srgbClr val="1C2948"/>
+            </a:solidFill>
+            <a:prstDash val="solid"/>
+            <a:round/>
+            <a:headEnd len="sm" w="sm" type="none"/>
+            <a:tailEnd len="sm" w="sm" type="none"/>
+          </a:ln>
+          <a:effectLst>
+            <a:outerShdw blurRad="40000" rotWithShape="0" dir="5400000" dist="20000">
+              <a:srgbClr val="000000">
+                <a:alpha val="38039"/>
+              </a:srgbClr>
+            </a:outerShdw>
+          </a:effectLst>
+        </p:spPr>
+      </p:cxnSp>
+      <p:cxnSp>
+        <p:nvCxnSpPr>
+          <p:cNvPr id="228" name="Google Shape;228;p2"/>
+          <p:cNvCxnSpPr/>
+          <p:nvPr/>
+        </p:nvCxnSpPr>
+        <p:spPr>
+          <a:xfrm>
+            <a:off x="5943600" y="320040"/>
+            <a:ext cx="0" cy="6217920"/>
+          </a:xfrm>
+          <a:prstGeom prst="straightConnector1">
+            <a:avLst/>
+          </a:prstGeom>
+          <a:noFill/>
+          <a:ln cap="flat" cmpd="sng" w="9525">
+            <a:solidFill>
+              <a:srgbClr val="1C2948"/>
+            </a:solidFill>
+            <a:prstDash val="solid"/>
+            <a:round/>
+            <a:headEnd len="sm" w="sm" type="none"/>
+            <a:tailEnd len="sm" w="sm" type="none"/>
+          </a:ln>
+          <a:effectLst>
+            <a:outerShdw blurRad="40000" rotWithShape="0" dir="5400000" dist="20000">
+              <a:srgbClr val="000000">
+                <a:alpha val="38039"/>
+              </a:srgbClr>
+            </a:outerShdw>
+          </a:effectLst>
+        </p:spPr>
+      </p:cxnSp>
+      <p:cxnSp>
+        <p:nvCxnSpPr>
+          <p:cNvPr id="229" name="Google Shape;229;p2"/>
+          <p:cNvCxnSpPr/>
+          <p:nvPr/>
+        </p:nvCxnSpPr>
+        <p:spPr>
+          <a:xfrm>
+            <a:off x="6858000" y="320040"/>
+            <a:ext cx="0" cy="6217920"/>
+          </a:xfrm>
+          <a:prstGeom prst="straightConnector1">
+            <a:avLst/>
+          </a:prstGeom>
+          <a:noFill/>
+          <a:ln cap="flat" cmpd="sng" w="9525">
+            <a:solidFill>
+              <a:srgbClr val="1C2948"/>
+            </a:solidFill>
+            <a:prstDash val="solid"/>
+            <a:round/>
+            <a:headEnd len="sm" w="sm" type="none"/>
+            <a:tailEnd len="sm" w="sm" type="none"/>
+          </a:ln>
+          <a:effectLst>
+            <a:outerShdw blurRad="40000" rotWithShape="0" dir="5400000" dist="20000">
+              <a:srgbClr val="000000">
+                <a:alpha val="38039"/>
+              </a:srgbClr>
+            </a:outerShdw>
+          </a:effectLst>
+        </p:spPr>
+      </p:cxnSp>
+      <p:cxnSp>
+        <p:nvCxnSpPr>
+          <p:cNvPr id="230" name="Google Shape;230;p2"/>
+          <p:cNvCxnSpPr/>
+          <p:nvPr/>
+        </p:nvCxnSpPr>
+        <p:spPr>
+          <a:xfrm>
+            <a:off x="7772400" y="320040"/>
+            <a:ext cx="0" cy="6217920"/>
+          </a:xfrm>
+          <a:prstGeom prst="straightConnector1">
+            <a:avLst/>
+          </a:prstGeom>
+          <a:noFill/>
+          <a:ln cap="flat" cmpd="sng" w="9525">
+            <a:solidFill>
+              <a:srgbClr val="1C2948"/>
+            </a:solidFill>
+            <a:prstDash val="solid"/>
+            <a:round/>
+            <a:headEnd len="sm" w="sm" type="none"/>
+            <a:tailEnd len="sm" w="sm" type="none"/>
+          </a:ln>
+          <a:effectLst>
+            <a:outerShdw blurRad="40000" rotWithShape="0" dir="5400000" dist="20000">
+              <a:srgbClr val="000000">
+                <a:alpha val="38039"/>
+              </a:srgbClr>
+            </a:outerShdw>
+          </a:effectLst>
+        </p:spPr>
+      </p:cxnSp>
+      <p:cxnSp>
+        <p:nvCxnSpPr>
+          <p:cNvPr id="231" name="Google Shape;231;p2"/>
+          <p:cNvCxnSpPr/>
+          <p:nvPr/>
+        </p:nvCxnSpPr>
+        <p:spPr>
+          <a:xfrm>
+            <a:off x="8686800" y="320040"/>
+            <a:ext cx="0" cy="6217920"/>
+          </a:xfrm>
+          <a:prstGeom prst="straightConnector1">
+            <a:avLst/>
+          </a:prstGeom>
+          <a:noFill/>
+          <a:ln cap="flat" cmpd="sng" w="9525">
+            <a:solidFill>
+              <a:srgbClr val="1C2948"/>
+            </a:solidFill>
+            <a:prstDash val="solid"/>
+            <a:round/>
+            <a:headEnd len="sm" w="sm" type="none"/>
+            <a:tailEnd len="sm" w="sm" type="none"/>
+          </a:ln>
+          <a:effectLst>
+            <a:outerShdw blurRad="40000" rotWithShape="0" dir="5400000" dist="20000">
+              <a:srgbClr val="000000">
+                <a:alpha val="38039"/>
+              </a:srgbClr>
+            </a:outerShdw>
+          </a:effectLst>
+        </p:spPr>
+      </p:cxnSp>
+      <p:cxnSp>
+        <p:nvCxnSpPr>
+          <p:cNvPr id="232" name="Google Shape;232;p2"/>
+          <p:cNvCxnSpPr/>
+          <p:nvPr/>
+        </p:nvCxnSpPr>
+        <p:spPr>
+          <a:xfrm>
+            <a:off x="9601200" y="320040"/>
+            <a:ext cx="0" cy="6217920"/>
+          </a:xfrm>
+          <a:prstGeom prst="straightConnector1">
+            <a:avLst/>
+          </a:prstGeom>
+          <a:noFill/>
+          <a:ln cap="flat" cmpd="sng" w="9525">
+            <a:solidFill>
+              <a:srgbClr val="1C2948"/>
+            </a:solidFill>
+            <a:prstDash val="solid"/>
+            <a:round/>
+            <a:headEnd len="sm" w="sm" type="none"/>
+            <a:tailEnd len="sm" w="sm" type="none"/>
+          </a:ln>
+          <a:effectLst>
+            <a:outerShdw blurRad="40000" rotWithShape="0" dir="5400000" dist="20000">
+              <a:srgbClr val="000000">
+                <a:alpha val="38039"/>
+              </a:srgbClr>
+            </a:outerShdw>
+          </a:effectLst>
+        </p:spPr>
+      </p:cxnSp>
+      <p:cxnSp>
+        <p:nvCxnSpPr>
+          <p:cNvPr id="233" name="Google Shape;233;p2"/>
+          <p:cNvCxnSpPr/>
+          <p:nvPr/>
+        </p:nvCxnSpPr>
+        <p:spPr>
+          <a:xfrm>
+            <a:off x="10515600" y="320040"/>
+            <a:ext cx="0" cy="6217920"/>
+          </a:xfrm>
+          <a:prstGeom prst="straightConnector1">
+            <a:avLst/>
+          </a:prstGeom>
+          <a:noFill/>
+          <a:ln cap="flat" cmpd="sng" w="9525">
+            <a:solidFill>
+              <a:srgbClr val="1C2948"/>
+            </a:solidFill>
+            <a:prstDash val="solid"/>
+            <a:round/>
+            <a:headEnd len="sm" w="sm" type="none"/>
+            <a:tailEnd len="sm" w="sm" type="none"/>
+          </a:ln>
+          <a:effectLst>
+            <a:outerShdw blurRad="40000" rotWithShape="0" dir="5400000" dist="20000">
+              <a:srgbClr val="000000">
+                <a:alpha val="38039"/>
+              </a:srgbClr>
+            </a:outerShdw>
+          </a:effectLst>
+        </p:spPr>
+      </p:cxnSp>
+      <p:cxnSp>
+        <p:nvCxnSpPr>
+          <p:cNvPr id="234" name="Google Shape;234;p2"/>
+          <p:cNvCxnSpPr/>
+          <p:nvPr/>
+        </p:nvCxnSpPr>
+        <p:spPr>
+          <a:xfrm>
+            <a:off x="11430000" y="320040"/>
+            <a:ext cx="0" cy="6217920"/>
+          </a:xfrm>
+          <a:prstGeom prst="straightConnector1">
+            <a:avLst/>
+          </a:prstGeom>
+          <a:noFill/>
+          <a:ln cap="flat" cmpd="sng" w="9525">
+            <a:solidFill>
+              <a:srgbClr val="1C2948"/>
+            </a:solidFill>
+            <a:prstDash val="solid"/>
+            <a:round/>
+            <a:headEnd len="sm" w="sm" type="none"/>
+            <a:tailEnd len="sm" w="sm" type="none"/>
+          </a:ln>
+          <a:effectLst>
+            <a:outerShdw blurRad="40000" rotWithShape="0" dir="5400000" dist="20000">
+              <a:srgbClr val="000000">
+                <a:alpha val="38039"/>
+              </a:srgbClr>
+            </a:outerShdw>
+          </a:effectLst>
+        </p:spPr>
+      </p:cxnSp>
+      <p:cxnSp>
+        <p:nvCxnSpPr>
+          <p:cNvPr id="235" name="Google Shape;235;p2"/>
+          <p:cNvCxnSpPr/>
+          <p:nvPr/>
+        </p:nvCxnSpPr>
+        <p:spPr>
+          <a:xfrm>
+            <a:off x="320040" y="914400"/>
+            <a:ext cx="11548872" cy="0"/>
+          </a:xfrm>
+          <a:prstGeom prst="straightConnector1">
+            <a:avLst/>
+          </a:prstGeom>
+          <a:noFill/>
+          <a:ln cap="flat" cmpd="sng" w="9525">
+            <a:solidFill>
+              <a:srgbClr val="1C2948"/>
+            </a:solidFill>
+            <a:prstDash val="solid"/>
+            <a:round/>
+            <a:headEnd len="sm" w="sm" type="none"/>
+            <a:tailEnd len="sm" w="sm" type="none"/>
+          </a:ln>
+          <a:effectLst>
+            <a:outerShdw blurRad="40000" rotWithShape="0" dir="5400000" dist="20000">
+              <a:srgbClr val="000000">
+                <a:alpha val="38039"/>
+              </a:srgbClr>
+            </a:outerShdw>
+          </a:effectLst>
+        </p:spPr>
+      </p:cxnSp>
+      <p:cxnSp>
+        <p:nvCxnSpPr>
+          <p:cNvPr id="236" name="Google Shape;236;p2"/>
+          <p:cNvCxnSpPr/>
+          <p:nvPr/>
+        </p:nvCxnSpPr>
+        <p:spPr>
+          <a:xfrm>
+            <a:off x="320040" y="1828800"/>
+            <a:ext cx="11548872" cy="0"/>
+          </a:xfrm>
+          <a:prstGeom prst="straightConnector1">
+            <a:avLst/>
+          </a:prstGeom>
+          <a:noFill/>
+          <a:ln cap="flat" cmpd="sng" w="9525">
+            <a:solidFill>
+              <a:srgbClr val="1C2948"/>
+            </a:solidFill>
+            <a:prstDash val="solid"/>
+            <a:round/>
+            <a:headEnd len="sm" w="sm" type="none"/>
+            <a:tailEnd len="sm" w="sm" type="none"/>
+          </a:ln>
+          <a:effectLst>
+            <a:outerShdw blurRad="40000" rotWithShape="0" dir="5400000" dist="20000">
+              <a:srgbClr val="000000">
+                <a:alpha val="38039"/>
+              </a:srgbClr>
+            </a:outerShdw>
+          </a:effectLst>
+        </p:spPr>
+      </p:cxnSp>
+      <p:cxnSp>
+        <p:nvCxnSpPr>
+          <p:cNvPr id="237" name="Google Shape;237;p2"/>
+          <p:cNvCxnSpPr/>
+          <p:nvPr/>
+        </p:nvCxnSpPr>
+        <p:spPr>
+          <a:xfrm>
+            <a:off x="320040" y="2743200"/>
+            <a:ext cx="11548872" cy="0"/>
+          </a:xfrm>
+          <a:prstGeom prst="straightConnector1">
+            <a:avLst/>
+          </a:prstGeom>
+          <a:noFill/>
+          <a:ln cap="flat" cmpd="sng" w="9525">
+            <a:solidFill>
+              <a:srgbClr val="1C2948"/>
+            </a:solidFill>
+            <a:prstDash val="solid"/>
+            <a:round/>
+            <a:headEnd len="sm" w="sm" type="none"/>
+            <a:tailEnd len="sm" w="sm" type="none"/>
+          </a:ln>
+          <a:effectLst>
+            <a:outerShdw blurRad="40000" rotWithShape="0" dir="5400000" dist="20000">
+              <a:srgbClr val="000000">
+                <a:alpha val="38039"/>
+              </a:srgbClr>
+            </a:outerShdw>
+          </a:effectLst>
+        </p:spPr>
+      </p:cxnSp>
+      <p:cxnSp>
+        <p:nvCxnSpPr>
+          <p:cNvPr id="238" name="Google Shape;238;p2"/>
+          <p:cNvCxnSpPr/>
+          <p:nvPr/>
+        </p:nvCxnSpPr>
+        <p:spPr>
+          <a:xfrm>
+            <a:off x="320040" y="3657600"/>
+            <a:ext cx="11548872" cy="0"/>
+          </a:xfrm>
+          <a:prstGeom prst="straightConnector1">
+            <a:avLst/>
+          </a:prstGeom>
+          <a:noFill/>
+          <a:ln cap="flat" cmpd="sng" w="9525">
+            <a:solidFill>
+              <a:srgbClr val="1C2948"/>
+            </a:solidFill>
+            <a:prstDash val="solid"/>
+            <a:round/>
+            <a:headEnd len="sm" w="sm" type="none"/>
+            <a:tailEnd len="sm" w="sm" type="none"/>
+          </a:ln>
+          <a:effectLst>
+            <a:outerShdw blurRad="40000" rotWithShape="0" dir="5400000" dist="20000">
+              <a:srgbClr val="000000">
+                <a:alpha val="38039"/>
+              </a:srgbClr>
+            </a:outerShdw>
+          </a:effectLst>
+        </p:spPr>
+      </p:cxnSp>
+      <p:cxnSp>
+        <p:nvCxnSpPr>
+          <p:cNvPr id="239" name="Google Shape;239;p2"/>
+          <p:cNvCxnSpPr/>
+          <p:nvPr/>
+        </p:nvCxnSpPr>
+        <p:spPr>
+          <a:xfrm>
+            <a:off x="320040" y="4572000"/>
+            <a:ext cx="11548872" cy="0"/>
+          </a:xfrm>
+          <a:prstGeom prst="straightConnector1">
+            <a:avLst/>
+          </a:prstGeom>
+          <a:noFill/>
+          <a:ln cap="flat" cmpd="sng" w="9525">
+            <a:solidFill>
+              <a:srgbClr val="1C2948"/>
+            </a:solidFill>
+            <a:prstDash val="solid"/>
+            <a:round/>
+            <a:headEnd len="sm" w="sm" type="none"/>
+            <a:tailEnd len="sm" w="sm" type="none"/>
+          </a:ln>
+          <a:effectLst>
+            <a:outerShdw blurRad="40000" rotWithShape="0" dir="5400000" dist="20000">
+              <a:srgbClr val="000000">
+                <a:alpha val="38039"/>
+              </a:srgbClr>
+            </a:outerShdw>
+          </a:effectLst>
+        </p:spPr>
+      </p:cxnSp>
+      <p:cxnSp>
+        <p:nvCxnSpPr>
+          <p:cNvPr id="240" name="Google Shape;240;p2"/>
+          <p:cNvCxnSpPr/>
+          <p:nvPr/>
+        </p:nvCxnSpPr>
+        <p:spPr>
+          <a:xfrm>
+            <a:off x="320040" y="5486400"/>
+            <a:ext cx="11548872" cy="0"/>
+          </a:xfrm>
+          <a:prstGeom prst="straightConnector1">
+            <a:avLst/>
+          </a:prstGeom>
+          <a:noFill/>
+          <a:ln cap="flat" cmpd="sng" w="9525">
+            <a:solidFill>
+              <a:srgbClr val="1C2948"/>
+            </a:solidFill>
+            <a:prstDash val="solid"/>
+            <a:round/>
+            <a:headEnd len="sm" w="sm" type="none"/>
+            <a:tailEnd len="sm" w="sm" type="none"/>
+          </a:ln>
+          <a:effectLst>
+            <a:outerShdw blurRad="40000" rotWithShape="0" dir="5400000" dist="20000">
+              <a:srgbClr val="000000">
+                <a:alpha val="38039"/>
+              </a:srgbClr>
+            </a:outerShdw>
+          </a:effectLst>
+        </p:spPr>
+      </p:cxnSp>
+      <p:cxnSp>
+        <p:nvCxnSpPr>
+          <p:cNvPr id="241" name="Google Shape;241;p2"/>
+          <p:cNvCxnSpPr/>
+          <p:nvPr/>
+        </p:nvCxnSpPr>
+        <p:spPr>
+          <a:xfrm>
+            <a:off x="320040" y="6400800"/>
+            <a:ext cx="11548872" cy="0"/>
+          </a:xfrm>
+          <a:prstGeom prst="straightConnector1">
+            <a:avLst/>
+          </a:prstGeom>
+          <a:noFill/>
+          <a:ln cap="flat" cmpd="sng" w="9525">
+            <a:solidFill>
+              <a:srgbClr val="1C2948"/>
+            </a:solidFill>
+            <a:prstDash val="solid"/>
+            <a:round/>
+            <a:headEnd len="sm" w="sm" type="none"/>
+            <a:tailEnd len="sm" w="sm" type="none"/>
+          </a:ln>
+          <a:effectLst>
+            <a:outerShdw blurRad="40000" rotWithShape="0" dir="5400000" dist="20000">
+              <a:srgbClr val="000000">
+                <a:alpha val="38039"/>
+              </a:srgbClr>
+            </a:outerShdw>
+          </a:effectLst>
+        </p:spPr>
+      </p:cxnSp>
+      <p:sp>
+        <p:nvSpPr>
+          <p:cNvPr id="242" name="Google Shape;242;p2"/>
+          <p:cNvSpPr/>
+          <p:nvPr/>
+        </p:nvSpPr>
+        <p:spPr>
+          <a:xfrm>
+            <a:off x="411480" y="347472"/>
+            <a:ext cx="502920" cy="41148"/>
+          </a:xfrm>
+          <a:prstGeom prst="rect">
+            <a:avLst/>
+          </a:prstGeom>
+          <a:solidFill>
+            <a:srgbClr val="27D6FF"/>
+          </a:solidFill>
+          <a:ln>
+            <a:noFill/>
+          </a:ln>
+          <a:effectLst>
+            <a:outerShdw blurRad="40000" rotWithShape="0" dir="5400000" dist="23000">
+              <a:srgbClr val="000000">
+                <a:alpha val="34902"/>
+              </a:srgbClr>
+            </a:outerShdw>
+          </a:effectLst>
+        </p:spPr>
+        <p:txBody>
+          <a:bodyPr anchorCtr="0" anchor="ctr" bIns="45700" lIns="91425" spcFirstLastPara="1" rIns="91425" wrap="square" tIns="45700">
+            <a:noAutofit/>
+          </a:bodyPr>
+          <a:lstStyle/>
+          <a:p>
+            <a:pPr indent="0" lvl="0" marL="0" marR="0" rtl="0" algn="ctr">
+              <a:spcBef>
+                <a:spcPts val="0"/>
+              </a:spcBef>
+              <a:spcAft>
+                <a:spcPts val="0"/>
+              </a:spcAft>
+              <a:buNone/>
+            </a:pPr>
+            <a:r>
+              <a:t/>
+            </a:r>
+            <a:endParaRPr b="0" i="0" sz="1800" u="none" cap="none" strike="noStrike">
+              <a:solidFill>
+                <a:schemeClr val="dk1"/>
+              </a:solidFill>
+              <a:latin typeface="Calibri"/>
+              <a:ea typeface="Calibri"/>
+              <a:cs typeface="Calibri"/>
+              <a:sym typeface="Calibri"/>
+            </a:endParaRPr>
+          </a:p>
+        </p:txBody>
+      </p:sp>
+      <p:sp>
+        <p:nvSpPr>
+          <p:cNvPr id="243" name="Google Shape;243;p2"/>
+          <p:cNvSpPr/>
+          <p:nvPr/>
+        </p:nvSpPr>
+        <p:spPr>
+          <a:xfrm>
+            <a:off x="932688" y="347472"/>
+            <a:ext cx="201168" cy="41148"/>
+          </a:xfrm>
+          <a:prstGeom prst="rect">
+            <a:avLst/>
+          </a:prstGeom>
+          <a:solidFill>
+            <a:srgbClr val="D948FF"/>
+          </a:solidFill>
+          <a:ln>
+            <a:noFill/>
+          </a:ln>
+          <a:effectLst>
+            <a:outerShdw blurRad="40000" rotWithShape="0" dir="5400000" dist="23000">
+              <a:srgbClr val="000000">
+                <a:alpha val="34902"/>
+              </a:srgbClr>
+            </a:outerShdw>
+          </a:effectLst>
+        </p:spPr>
+        <p:txBody>
+          <a:bodyPr anchorCtr="0" anchor="ctr" bIns="45700" lIns="91425" spcFirstLastPara="1" rIns="91425" wrap="square" tIns="45700">
+            <a:noAutofit/>
+          </a:bodyPr>
+          <a:lstStyle/>
+          <a:p>
+            <a:pPr indent="0" lvl="0" marL="0" marR="0" rtl="0" algn="ctr">
+              <a:spcBef>
+                <a:spcPts val="0"/>
+              </a:spcBef>
+              <a:spcAft>
+                <a:spcPts val="0"/>
+              </a:spcAft>
+              <a:buNone/>
+            </a:pPr>
+            <a:r>
+              <a:t/>
+            </a:r>
+            <a:endParaRPr b="0" i="0" sz="1800" u="none" cap="none" strike="noStrike">
+              <a:solidFill>
+                <a:schemeClr val="dk1"/>
+              </a:solidFill>
+              <a:latin typeface="Calibri"/>
+              <a:ea typeface="Calibri"/>
+              <a:cs typeface="Calibri"/>
+              <a:sym typeface="Calibri"/>
+            </a:endParaRPr>
+          </a:p>
+        </p:txBody>
+      </p:sp>
+      <p:sp>
+        <p:nvSpPr>
+          <p:cNvPr id="244" name="Google Shape;244;p2"/>
+          <p:cNvSpPr txBox="1"/>
+          <p:nvPr/>
+        </p:nvSpPr>
+        <p:spPr>
+          <a:xfrm>
+            <a:off x="438912" y="475488"/>
+            <a:ext cx="7315200" cy="201168"/>
+          </a:xfrm>
+          <a:prstGeom prst="rect">
+            <a:avLst/>
+          </a:prstGeom>
+          <a:noFill/>
+          <a:ln>
+            <a:noFill/>
+          </a:ln>
+        </p:spPr>
+        <p:txBody>
+          <a:bodyPr anchorCtr="0" anchor="t" bIns="22850" lIns="27425" spcFirstLastPara="1" rIns="27425" wrap="square" tIns="22850">
+            <a:spAutoFit/>
+          </a:bodyPr>
+          <a:lstStyle/>
+          <a:p>
+            <a:pPr indent="0" lvl="0" marL="0" marR="0" rtl="0" algn="l">
+              <a:spcBef>
+                <a:spcPts val="0"/>
+              </a:spcBef>
+              <a:spcAft>
+                <a:spcPts val="0"/>
+              </a:spcAft>
+              <a:buNone/>
+            </a:pPr>
+            <a:r>
+              <a:rPr b="1" i="0" lang="en-US" sz="900" u="none" cap="none" strike="noStrike">
+                <a:solidFill>
+                  <a:srgbClr val="A1B1CD"/>
+                </a:solidFill>
+                <a:latin typeface="Arial"/>
+                <a:ea typeface="Arial"/>
+                <a:cs typeface="Arial"/>
+                <a:sym typeface="Arial"/>
+              </a:rPr>
+              <a:t>Q-ROUTER  /  FAU QISKIT FALL FEST 2026</a:t>
+            </a:r>
+            <a:endParaRPr/>
+          </a:p>
+        </p:txBody>
+      </p:sp>
+      <p:sp>
+        <p:nvSpPr>
+          <p:cNvPr id="245" name="Google Shape;245;p2"/>
+          <p:cNvSpPr txBox="1"/>
+          <p:nvPr/>
+        </p:nvSpPr>
+        <p:spPr>
+          <a:xfrm>
+            <a:off x="9144000" y="420624"/>
+            <a:ext cx="2514600" cy="201168"/>
+          </a:xfrm>
+          <a:prstGeom prst="rect">
+            <a:avLst/>
+          </a:prstGeom>
+          <a:noFill/>
+          <a:ln>
+            <a:noFill/>
+          </a:ln>
+        </p:spPr>
+        <p:txBody>
+          <a:bodyPr anchorCtr="0" anchor="t" bIns="22850" lIns="27425" spcFirstLastPara="1" rIns="27425" wrap="square" tIns="22850">
+            <a:spAutoFit/>
+          </a:bodyPr>
+          <a:lstStyle/>
+          <a:p>
+            <a:pPr indent="0" lvl="0" marL="0" marR="0" rtl="0" algn="r">
+              <a:spcBef>
+                <a:spcPts val="0"/>
+              </a:spcBef>
+              <a:spcAft>
+                <a:spcPts val="0"/>
+              </a:spcAft>
+              <a:buNone/>
+            </a:pPr>
+            <a:r>
+              <a:rPr b="1" i="0" lang="en-US" sz="1000" u="none" cap="none" strike="noStrike">
+                <a:solidFill>
+                  <a:srgbClr val="F4F8FF"/>
+                </a:solidFill>
+                <a:latin typeface="Arial"/>
+                <a:ea typeface="Arial"/>
+                <a:cs typeface="Arial"/>
+                <a:sym typeface="Arial"/>
+              </a:rPr>
+              <a:t>FLORIDA ATLANTIC</a:t>
+            </a:r>
+            <a:endParaRPr/>
+          </a:p>
+        </p:txBody>
+      </p:sp>
+      <p:sp>
+        <p:nvSpPr>
+          <p:cNvPr id="246" name="Google Shape;246;p2"/>
+          <p:cNvSpPr txBox="1"/>
+          <p:nvPr/>
+        </p:nvSpPr>
+        <p:spPr>
+          <a:xfrm>
+            <a:off x="10378440" y="621792"/>
+            <a:ext cx="1280160" cy="146304"/>
+          </a:xfrm>
+          <a:prstGeom prst="rect">
+            <a:avLst/>
+          </a:prstGeom>
+          <a:noFill/>
+          <a:ln>
+            <a:noFill/>
+          </a:ln>
+        </p:spPr>
+        <p:txBody>
+          <a:bodyPr anchorCtr="0" anchor="t" bIns="22850" lIns="27425" spcFirstLastPara="1" rIns="27425" wrap="square" tIns="22850">
+            <a:spAutoFit/>
+          </a:bodyPr>
+          <a:lstStyle/>
+          <a:p>
+            <a:pPr indent="0" lvl="0" marL="0" marR="0" rtl="0" algn="r">
+              <a:spcBef>
+                <a:spcPts val="0"/>
+              </a:spcBef>
+              <a:spcAft>
+                <a:spcPts val="0"/>
+              </a:spcAft>
+              <a:buNone/>
+            </a:pPr>
+            <a:r>
+              <a:rPr b="1" i="0" lang="en-US" sz="700" u="none" cap="none" strike="noStrike">
+                <a:solidFill>
+                  <a:srgbClr val="DC415F"/>
+                </a:solidFill>
+                <a:latin typeface="Arial"/>
+                <a:ea typeface="Arial"/>
+                <a:cs typeface="Arial"/>
+                <a:sym typeface="Arial"/>
+              </a:rPr>
+              <a:t>UNIVERSITY</a:t>
+            </a:r>
+            <a:endParaRPr/>
+          </a:p>
+        </p:txBody>
+      </p:sp>
+      <p:cxnSp>
+        <p:nvCxnSpPr>
+          <p:cNvPr id="247" name="Google Shape;247;p2"/>
+          <p:cNvCxnSpPr/>
+          <p:nvPr/>
+        </p:nvCxnSpPr>
+        <p:spPr>
+          <a:xfrm>
+            <a:off x="9144000" y="841248"/>
+            <a:ext cx="2514600" cy="0"/>
+          </a:xfrm>
+          <a:prstGeom prst="straightConnector1">
+            <a:avLst/>
+          </a:prstGeom>
+          <a:noFill/>
+          <a:ln cap="flat" cmpd="sng" w="10150">
+            <a:solidFill>
+              <a:srgbClr val="374D73"/>
+            </a:solidFill>
+            <a:prstDash val="solid"/>
+            <a:round/>
+            <a:headEnd len="sm" w="sm" type="none"/>
+            <a:tailEnd len="sm" w="sm" type="none"/>
+          </a:ln>
+          <a:effectLst>
+            <a:outerShdw blurRad="40000" rotWithShape="0" dir="5400000" dist="20000">
+              <a:srgbClr val="000000">
+                <a:alpha val="38039"/>
+              </a:srgbClr>
+            </a:outerShdw>
+          </a:effectLst>
+        </p:spPr>
+      </p:cxnSp>
+      <p:sp>
+        <p:nvSpPr>
+          <p:cNvPr id="248" name="Google Shape;248;p2"/>
+          <p:cNvSpPr txBox="1"/>
+          <p:nvPr/>
+        </p:nvSpPr>
+        <p:spPr>
+          <a:xfrm>
+            <a:off x="11247120" y="6510528"/>
+            <a:ext cx="411480" cy="164592"/>
+          </a:xfrm>
+          <a:prstGeom prst="rect">
+            <a:avLst/>
+          </a:prstGeom>
+          <a:noFill/>
+          <a:ln>
+            <a:noFill/>
+          </a:ln>
+        </p:spPr>
+        <p:txBody>
+          <a:bodyPr anchorCtr="0" anchor="t" bIns="22850" lIns="27425" spcFirstLastPara="1" rIns="27425" wrap="square" tIns="22850">
+            <a:spAutoFit/>
+          </a:bodyPr>
+          <a:lstStyle/>
+          <a:p>
+            <a:pPr indent="0" lvl="0" marL="0" marR="0" rtl="0" algn="r">
+              <a:spcBef>
+                <a:spcPts val="0"/>
+              </a:spcBef>
+              <a:spcAft>
+                <a:spcPts val="0"/>
+              </a:spcAft>
+              <a:buNone/>
+            </a:pPr>
+            <a:r>
+              <a:rPr b="1" i="0" lang="en-US" sz="900" u="none" cap="none" strike="noStrike">
+                <a:solidFill>
+                  <a:srgbClr val="A1B1CD"/>
+                </a:solidFill>
+                <a:latin typeface="Arial"/>
+                <a:ea typeface="Arial"/>
+                <a:cs typeface="Arial"/>
+                <a:sym typeface="Arial"/>
+              </a:rPr>
+              <a:t>08</a:t>
+            </a:r>
+            <a:endParaRPr/>
+          </a:p>
+        </p:txBody>
+      </p:sp>
+      <p:sp>
+        <p:nvSpPr>
+          <p:cNvPr id="249" name="Google Shape;249;p2"/>
+          <p:cNvSpPr txBox="1"/>
+          <p:nvPr/>
+        </p:nvSpPr>
+        <p:spPr>
+          <a:xfrm>
+            <a:off x="530352" y="932688"/>
+            <a:ext cx="10789920" cy="228600"/>
+          </a:xfrm>
+          <a:prstGeom prst="rect">
+            <a:avLst/>
+          </a:prstGeom>
+          <a:noFill/>
+          <a:ln>
+            <a:noFill/>
+          </a:ln>
+        </p:spPr>
+        <p:txBody>
+          <a:bodyPr anchorCtr="0" anchor="t" bIns="22850" lIns="27425" spcFirstLastPara="1" rIns="27425" wrap="square" tIns="22850">
+            <a:spAutoFit/>
+          </a:bodyPr>
+          <a:lstStyle/>
+          <a:p>
+            <a:pPr indent="0" lvl="0" marL="0" marR="0" rtl="0" algn="l">
+              <a:spcBef>
+                <a:spcPts val="0"/>
+              </a:spcBef>
+              <a:spcAft>
+                <a:spcPts val="0"/>
+              </a:spcAft>
+              <a:buNone/>
+            </a:pPr>
+            <a:r>
+              <a:rPr b="1" i="0" lang="en-US" sz="1000" u="none" cap="none" strike="noStrike">
+                <a:solidFill>
+                  <a:srgbClr val="27D6FF"/>
+                </a:solidFill>
+                <a:latin typeface="Arial"/>
+                <a:ea typeface="Arial"/>
+                <a:cs typeface="Arial"/>
+                <a:sym typeface="Arial"/>
+              </a:rPr>
+              <a:t>07 / SOLUTIONS</a:t>
+            </a:r>
+            <a:endParaRPr/>
+          </a:p>
+        </p:txBody>
+      </p:sp>
+      <p:sp>
+        <p:nvSpPr>
+          <p:cNvPr id="250" name="Google Shape;250;p2"/>
+          <p:cNvSpPr txBox="1"/>
+          <p:nvPr/>
+        </p:nvSpPr>
+        <p:spPr>
+          <a:xfrm>
+            <a:off x="530352" y="1225296"/>
+            <a:ext cx="10972800" cy="512064"/>
+          </a:xfrm>
+          <a:prstGeom prst="rect">
+            <a:avLst/>
+          </a:prstGeom>
+          <a:noFill/>
+          <a:ln>
+            <a:noFill/>
+          </a:ln>
+        </p:spPr>
+        <p:txBody>
+          <a:bodyPr anchorCtr="0" anchor="t" bIns="22850" lIns="27425" spcFirstLastPara="1" rIns="27425" wrap="square" tIns="22850">
+            <a:spAutoFit/>
+          </a:bodyPr>
+          <a:lstStyle/>
+          <a:p>
+            <a:pPr indent="0" lvl="0" marL="0" marR="0" rtl="0" algn="l">
+              <a:spcBef>
+                <a:spcPts val="0"/>
+              </a:spcBef>
+              <a:spcAft>
+                <a:spcPts val="0"/>
+              </a:spcAft>
+              <a:buNone/>
+            </a:pPr>
+            <a:r>
+              <a:rPr b="1" i="0" lang="en-US" sz="2700" u="none" cap="none" strike="noStrike">
+                <a:solidFill>
+                  <a:srgbClr val="F4F8FF"/>
+                </a:solidFill>
+                <a:latin typeface="Arial"/>
+                <a:ea typeface="Arial"/>
+                <a:cs typeface="Arial"/>
+                <a:sym typeface="Arial"/>
+              </a:rPr>
+              <a:t>The twin method, solving two industries.</a:t>
+            </a:r>
+            <a:endParaRPr/>
+          </a:p>
+        </p:txBody>
+      </p:sp>
+      <p:sp>
+        <p:nvSpPr>
+          <p:cNvPr id="251" name="Google Shape;251;p2"/>
+          <p:cNvSpPr txBox="1"/>
+          <p:nvPr/>
+        </p:nvSpPr>
+        <p:spPr>
+          <a:xfrm>
+            <a:off x="566928" y="1801368"/>
+            <a:ext cx="10789920" cy="365760"/>
+          </a:xfrm>
+          <a:prstGeom prst="rect">
+            <a:avLst/>
+          </a:prstGeom>
+          <a:noFill/>
+          <a:ln>
+            <a:noFill/>
+          </a:ln>
+        </p:spPr>
+        <p:txBody>
+          <a:bodyPr anchorCtr="0" anchor="t" bIns="22850" lIns="27425" spcFirstLastPara="1" rIns="27425" wrap="square" tIns="22850">
+            <a:spAutoFit/>
+          </a:bodyPr>
+          <a:lstStyle/>
+          <a:p>
+            <a:pPr indent="0" lvl="0" marL="0" marR="0" rtl="0" algn="l">
+              <a:spcBef>
+                <a:spcPts val="0"/>
+              </a:spcBef>
+              <a:spcAft>
+                <a:spcPts val="0"/>
+              </a:spcAft>
+              <a:buNone/>
+            </a:pPr>
+            <a:r>
+              <a:rPr b="0" i="0" lang="en-US" sz="1300" u="none" cap="none" strike="noStrike">
+                <a:solidFill>
+                  <a:srgbClr val="A1B1CD"/>
+                </a:solidFill>
+                <a:latin typeface="Arial"/>
+                <a:ea typeface="Arial"/>
+                <a:cs typeface="Arial"/>
+                <a:sym typeface="Arial"/>
+              </a:rPr>
+              <a:t>Each problem copies the dials of a same-shaped problem from another industry, runs once, and returns a real decision.</a:t>
+            </a:r>
+            <a:endParaRPr/>
+          </a:p>
+        </p:txBody>
+      </p:sp>
+      <p:sp>
+        <p:nvSpPr>
+          <p:cNvPr id="252" name="Rounded Rectangle 251"/>
+          <p:cNvSpPr/>
+          <p:nvPr/>
+        </p:nvSpPr>
+        <p:spPr>
+          <a:xfrm>
+            <a:off x="548640" y="2103120"/>
+            <a:ext cx="5440680" cy="3383280"/>
+          </a:xfrm>
+          <a:prstGeom prst="roundRect">
+            <a:avLst>
+              <a:gd name="adj" fmla="val 12000"/>
+            </a:avLst>
+          </a:prstGeom>
+          <a:solidFill>
+            <a:srgbClr val="0D132A"/>
+          </a:solidFill>
+          <a:ln w="12700">
+            <a:solidFill>
+              <a:srgbClr val="233558"/>
+            </a:solidFill>
+          </a:ln>
+          <a:effectLst/>
+        </p:spPr>
+        <p:style>
+          <a:lnRef idx="1">
+            <a:schemeClr val="accent1"/>
+          </a:lnRef>
+          <a:fillRef idx="3">
+            <a:schemeClr val="accent1"/>
+          </a:fillRef>
+          <a:effectRef idx="2">
+            <a:schemeClr val="accent1"/>
+          </a:effectRef>
+          <a:fontRef idx="minor">
+            <a:schemeClr val="lt1"/>
+          </a:fontRef>
+        </p:style>
+        <p:txBody>
+          <a:bodyPr rtlCol="0" anchor="ctr"/>
+          <a:lstStyle/>
+          <a:p>
+            <a:pPr algn="ctr"/>
+          </a:p>
+        </p:txBody>
+      </p:sp>
+      <p:sp>
+        <p:nvSpPr>
+          <p:cNvPr id="253" name="Rectangle 252"/>
+          <p:cNvSpPr/>
+          <p:nvPr/>
+        </p:nvSpPr>
+        <p:spPr>
+          <a:xfrm>
+            <a:off x="713232" y="2267712"/>
+            <a:ext cx="50292" cy="3054096"/>
+          </a:xfrm>
+          <a:prstGeom prst="rect">
+            <a:avLst/>
+          </a:prstGeom>
+          <a:solidFill>
+            <a:srgbClr val="27D6FF"/>
+          </a:solidFill>
+          <a:ln>
+            <a:noFill/>
+          </a:ln>
+          <a:effectLst/>
+        </p:spPr>
+        <p:style>
+          <a:lnRef idx="1">
+            <a:schemeClr val="accent1"/>
+          </a:lnRef>
+          <a:fillRef idx="3">
+            <a:schemeClr val="accent1"/>
+          </a:fillRef>
+          <a:effectRef idx="2">
+            <a:schemeClr val="accent1"/>
+          </a:effectRef>
+          <a:fontRef idx="minor">
+            <a:schemeClr val="lt1"/>
+          </a:fontRef>
+        </p:style>
+        <p:txBody>
+          <a:bodyPr rtlCol="0" anchor="ctr"/>
+          <a:lstStyle/>
+          <a:p>
+            <a:pPr algn="ctr"/>
+          </a:p>
+        </p:txBody>
+      </p:sp>
+      <p:sp>
+        <p:nvSpPr>
+          <p:cNvPr id="254" name="TextBox 253"/>
+          <p:cNvSpPr txBox="1"/>
+          <p:nvPr/>
+        </p:nvSpPr>
+        <p:spPr>
+          <a:xfrm>
+            <a:off x="877824" y="2231136"/>
+            <a:ext cx="4937760" cy="201168"/>
+          </a:xfrm>
+          <a:prstGeom prst="rect">
+            <a:avLst/>
+          </a:prstGeom>
+          <a:noFill/>
+        </p:spPr>
+        <p:txBody>
+          <a:bodyPr wrap="square" lIns="27425" rIns="27425" tIns="22850" bIns="22850" anchor="t">
+            <a:spAutoFit/>
+          </a:bodyPr>
+          <a:lstStyle/>
+          <a:p>
+            <a:pPr algn="l"/>
+            <a:r>
+              <a:rPr sz="900" b="1">
+                <a:solidFill>
+                  <a:srgbClr val="27D6FF"/>
+                </a:solidFill>
+                <a:latin typeface="Arial"/>
+              </a:rPr>
+              <a:t>FINANCE · STOCK PORTFOLIO</a:t>
+            </a:r>
+          </a:p>
+        </p:txBody>
+      </p:sp>
+      <p:sp>
+        <p:nvSpPr>
+          <p:cNvPr id="255" name="TextBox 254"/>
+          <p:cNvSpPr txBox="1"/>
+          <p:nvPr/>
+        </p:nvSpPr>
+        <p:spPr>
+          <a:xfrm>
+            <a:off x="877824" y="2468880"/>
+            <a:ext cx="4983480" cy="411480"/>
+          </a:xfrm>
+          <a:prstGeom prst="rect">
+            <a:avLst/>
+          </a:prstGeom>
+          <a:noFill/>
+        </p:spPr>
+        <p:txBody>
+          <a:bodyPr wrap="square" lIns="27425" rIns="27425" tIns="22850" bIns="22850" anchor="t">
+            <a:spAutoFit/>
+          </a:bodyPr>
+          <a:lstStyle/>
+          <a:p>
+            <a:pPr algn="l"/>
+            <a:r>
+              <a:rPr sz="1100" b="0">
+                <a:solidFill>
+                  <a:srgbClr val="A1B1CD"/>
+                </a:solidFill>
+                <a:latin typeface="Arial"/>
+              </a:rPr>
+              <a:t>Hold 2 of 6 healthcare stocks: best return for the least risk (real stock prices).</a:t>
+            </a:r>
+          </a:p>
+        </p:txBody>
+      </p:sp>
+      <p:graphicFrame>
+        <p:nvGraphicFramePr>
+          <p:cNvPr id="256" name="Table 255"/>
+          <p:cNvGraphicFramePr>
+            <a:graphicFrameLocks noGrp="1"/>
+          </p:cNvGraphicFramePr>
+          <p:nvPr/>
+        </p:nvGraphicFramePr>
+        <p:xfrm>
+          <a:off x="877824" y="2971800"/>
+          <a:ext cx="2331720" cy="1536192"/>
+        </p:xfrm>
+        <a:graphic>
+          <a:graphicData uri="http://schemas.openxmlformats.org/drawingml/2006/table">
+            <a:tbl>
+              <a:tblPr firstRow="0" bandRow="0"/>
+              <a:tblGrid>
+                <a:gridCol w="777240"/>
+                <a:gridCol w="777240"/>
+                <a:gridCol w="777240"/>
+              </a:tblGrid>
+              <a:tr h="219456">
+                <a:tc>
+                  <a:txBody>
+                    <a:bodyPr/>
+                    <a:lstStyle/>
+                    <a:p>
+                      <a:r>
+                        <a:rPr sz="900" b="1">
+                          <a:solidFill>
+                            <a:srgbClr val="F4F8FF"/>
+                          </a:solidFill>
+                          <a:latin typeface="Arial"/>
+                        </a:rPr>
+                        <a:t>Stock</a:t>
+                      </a:r>
+                    </a:p>
+                  </a:txBody>
+                  <a:tcPr marL="54864" marR="54864" marT="18288" marB="18288" anchor="ctr">
+                    <a:solidFill>
+                      <a:srgbClr val="233558"/>
+                    </a:solidFill>
+                  </a:tcPr>
+                </a:tc>
+                <a:tc>
+                  <a:txBody>
+                    <a:bodyPr/>
+                    <a:lstStyle/>
+                    <a:p>
+                      <a:r>
+                        <a:rPr sz="900" b="1">
+                          <a:solidFill>
+                            <a:srgbClr val="F4F8FF"/>
+                          </a:solidFill>
+                          <a:latin typeface="Arial"/>
+                        </a:rPr>
+                        <a:t>Return/yr</a:t>
+                      </a:r>
+                    </a:p>
+                  </a:txBody>
+                  <a:tcPr marL="54864" marR="54864" marT="18288" marB="18288" anchor="ctr">
+                    <a:solidFill>
+                      <a:srgbClr val="233558"/>
+                    </a:solidFill>
+                  </a:tcPr>
+                </a:tc>
+                <a:tc>
+                  <a:txBody>
+                    <a:bodyPr/>
+                    <a:lstStyle/>
+                    <a:p>
+                      <a:r>
+                        <a:rPr sz="900" b="1">
+                          <a:solidFill>
+                            <a:srgbClr val="F4F8FF"/>
+                          </a:solidFill>
+                          <a:latin typeface="Arial"/>
+                        </a:rPr>
+                        <a:t>Risk/yr</a:t>
+                      </a:r>
+                    </a:p>
+                  </a:txBody>
+                  <a:tcPr marL="54864" marR="54864" marT="18288" marB="18288" anchor="ctr">
+                    <a:solidFill>
+                      <a:srgbClr val="233558"/>
+                    </a:solidFill>
+                  </a:tcPr>
+                </a:tc>
+              </a:tr>
+              <a:tr h="219456">
+                <a:tc>
+                  <a:txBody>
+                    <a:bodyPr/>
+                    <a:lstStyle/>
+                    <a:p>
+                      <a:r>
+                        <a:rPr sz="900" b="0">
+                          <a:solidFill>
+                            <a:srgbClr val="A1B1CD"/>
+                          </a:solidFill>
+                          <a:latin typeface="Arial"/>
+                        </a:rPr>
+                        <a:t>ABBV</a:t>
+                      </a:r>
+                    </a:p>
+                  </a:txBody>
+                  <a:tcPr marL="54864" marR="54864" marT="18288" marB="18288" anchor="ctr">
+                    <a:solidFill>
+                      <a:srgbClr val="0D132A"/>
+                    </a:solidFill>
+                  </a:tcPr>
+                </a:tc>
+                <a:tc>
+                  <a:txBody>
+                    <a:bodyPr/>
+                    <a:lstStyle/>
+                    <a:p>
+                      <a:r>
+                        <a:rPr sz="900" b="0">
+                          <a:solidFill>
+                            <a:srgbClr val="A1B1CD"/>
+                          </a:solidFill>
+                          <a:latin typeface="Arial"/>
+                        </a:rPr>
+                        <a:t>18%</a:t>
+                      </a:r>
+                    </a:p>
+                  </a:txBody>
+                  <a:tcPr marL="54864" marR="54864" marT="18288" marB="18288" anchor="ctr">
+                    <a:solidFill>
+                      <a:srgbClr val="0D132A"/>
+                    </a:solidFill>
+                  </a:tcPr>
+                </a:tc>
+                <a:tc>
+                  <a:txBody>
+                    <a:bodyPr/>
+                    <a:lstStyle/>
+                    <a:p>
+                      <a:r>
+                        <a:rPr sz="900" b="0">
+                          <a:solidFill>
+                            <a:srgbClr val="A1B1CD"/>
+                          </a:solidFill>
+                          <a:latin typeface="Arial"/>
+                        </a:rPr>
+                        <a:t>23%</a:t>
+                      </a:r>
+                    </a:p>
+                  </a:txBody>
+                  <a:tcPr marL="54864" marR="54864" marT="18288" marB="18288" anchor="ctr">
+                    <a:solidFill>
+                      <a:srgbClr val="0D132A"/>
+                    </a:solidFill>
+                  </a:tcPr>
+                </a:tc>
+              </a:tr>
+              <a:tr h="219456">
+                <a:tc>
+                  <a:txBody>
+                    <a:bodyPr/>
+                    <a:lstStyle/>
+                    <a:p>
+                      <a:r>
+                        <a:rPr sz="900" b="0">
+                          <a:solidFill>
+                            <a:srgbClr val="A1B1CD"/>
+                          </a:solidFill>
+                          <a:latin typeface="Arial"/>
+                        </a:rPr>
+                        <a:t>ABT</a:t>
+                      </a:r>
+                    </a:p>
+                  </a:txBody>
+                  <a:tcPr marL="54864" marR="54864" marT="18288" marB="18288" anchor="ctr">
+                    <a:solidFill>
+                      <a:srgbClr val="0D132A"/>
+                    </a:solidFill>
+                  </a:tcPr>
+                </a:tc>
+                <a:tc>
+                  <a:txBody>
+                    <a:bodyPr/>
+                    <a:lstStyle/>
+                    <a:p>
+                      <a:r>
+                        <a:rPr sz="900" b="0">
+                          <a:solidFill>
+                            <a:srgbClr val="A1B1CD"/>
+                          </a:solidFill>
+                          <a:latin typeface="Arial"/>
+                        </a:rPr>
+                        <a:t>8%</a:t>
+                      </a:r>
+                    </a:p>
+                  </a:txBody>
+                  <a:tcPr marL="54864" marR="54864" marT="18288" marB="18288" anchor="ctr">
+                    <a:solidFill>
+                      <a:srgbClr val="0D132A"/>
+                    </a:solidFill>
+                  </a:tcPr>
+                </a:tc>
+                <a:tc>
+                  <a:txBody>
+                    <a:bodyPr/>
+                    <a:lstStyle/>
+                    <a:p>
+                      <a:r>
+                        <a:rPr sz="900" b="0">
+                          <a:solidFill>
+                            <a:srgbClr val="A1B1CD"/>
+                          </a:solidFill>
+                          <a:latin typeface="Arial"/>
+                        </a:rPr>
+                        <a:t>20%</a:t>
+                      </a:r>
+                    </a:p>
+                  </a:txBody>
+                  <a:tcPr marL="54864" marR="54864" marT="18288" marB="18288" anchor="ctr">
+                    <a:solidFill>
+                      <a:srgbClr val="0D132A"/>
+                    </a:solidFill>
+                  </a:tcPr>
+                </a:tc>
+              </a:tr>
+              <a:tr h="219456">
+                <a:tc>
+                  <a:txBody>
+                    <a:bodyPr/>
+                    <a:lstStyle/>
+                    <a:p>
+                      <a:r>
+                        <a:rPr sz="900" b="0">
+                          <a:solidFill>
+                            <a:srgbClr val="A1B1CD"/>
+                          </a:solidFill>
+                          <a:latin typeface="Arial"/>
+                        </a:rPr>
+                        <a:t>CI</a:t>
+                      </a:r>
+                    </a:p>
+                  </a:txBody>
+                  <a:tcPr marL="54864" marR="54864" marT="18288" marB="18288" anchor="ctr">
+                    <a:solidFill>
+                      <a:srgbClr val="0D132A"/>
+                    </a:solidFill>
+                  </a:tcPr>
+                </a:tc>
+                <a:tc>
+                  <a:txBody>
+                    <a:bodyPr/>
+                    <a:lstStyle/>
+                    <a:p>
+                      <a:r>
+                        <a:rPr sz="900" b="0">
+                          <a:solidFill>
+                            <a:srgbClr val="A1B1CD"/>
+                          </a:solidFill>
+                          <a:latin typeface="Arial"/>
+                        </a:rPr>
+                        <a:t>1%</a:t>
+                      </a:r>
+                    </a:p>
+                  </a:txBody>
+                  <a:tcPr marL="54864" marR="54864" marT="18288" marB="18288" anchor="ctr">
+                    <a:solidFill>
+                      <a:srgbClr val="0D132A"/>
+                    </a:solidFill>
+                  </a:tcPr>
+                </a:tc>
+                <a:tc>
+                  <a:txBody>
+                    <a:bodyPr/>
+                    <a:lstStyle/>
+                    <a:p>
+                      <a:r>
+                        <a:rPr sz="900" b="0">
+                          <a:solidFill>
+                            <a:srgbClr val="A1B1CD"/>
+                          </a:solidFill>
+                          <a:latin typeface="Arial"/>
+                        </a:rPr>
+                        <a:t>30%</a:t>
+                      </a:r>
+                    </a:p>
+                  </a:txBody>
+                  <a:tcPr marL="54864" marR="54864" marT="18288" marB="18288" anchor="ctr">
+                    <a:solidFill>
+                      <a:srgbClr val="0D132A"/>
+                    </a:solidFill>
+                  </a:tcPr>
+                </a:tc>
+              </a:tr>
+              <a:tr h="219456">
+                <a:tc>
+                  <a:txBody>
+                    <a:bodyPr/>
+                    <a:lstStyle/>
+                    <a:p>
+                      <a:r>
+                        <a:rPr sz="900" b="0">
+                          <a:solidFill>
+                            <a:srgbClr val="A1B1CD"/>
+                          </a:solidFill>
+                          <a:latin typeface="Arial"/>
+                        </a:rPr>
+                        <a:t>CVS</a:t>
+                      </a:r>
+                    </a:p>
+                  </a:txBody>
+                  <a:tcPr marL="54864" marR="54864" marT="18288" marB="18288" anchor="ctr">
+                    <a:solidFill>
+                      <a:srgbClr val="0D132A"/>
+                    </a:solidFill>
+                  </a:tcPr>
+                </a:tc>
+                <a:tc>
+                  <a:txBody>
+                    <a:bodyPr/>
+                    <a:lstStyle/>
+                    <a:p>
+                      <a:r>
+                        <a:rPr sz="900" b="0">
+                          <a:solidFill>
+                            <a:srgbClr val="A1B1CD"/>
+                          </a:solidFill>
+                          <a:latin typeface="Arial"/>
+                        </a:rPr>
+                        <a:t>4%</a:t>
+                      </a:r>
+                    </a:p>
+                  </a:txBody>
+                  <a:tcPr marL="54864" marR="54864" marT="18288" marB="18288" anchor="ctr">
+                    <a:solidFill>
+                      <a:srgbClr val="0D132A"/>
+                    </a:solidFill>
+                  </a:tcPr>
+                </a:tc>
+                <a:tc>
+                  <a:txBody>
+                    <a:bodyPr/>
+                    <a:lstStyle/>
+                    <a:p>
+                      <a:r>
+                        <a:rPr sz="900" b="0">
+                          <a:solidFill>
+                            <a:srgbClr val="A1B1CD"/>
+                          </a:solidFill>
+                          <a:latin typeface="Arial"/>
+                        </a:rPr>
+                        <a:t>31%</a:t>
+                      </a:r>
+                    </a:p>
+                  </a:txBody>
+                  <a:tcPr marL="54864" marR="54864" marT="18288" marB="18288" anchor="ctr">
+                    <a:solidFill>
+                      <a:srgbClr val="0D132A"/>
+                    </a:solidFill>
+                  </a:tcPr>
+                </a:tc>
+              </a:tr>
+              <a:tr h="219456">
+                <a:tc>
+                  <a:txBody>
+                    <a:bodyPr/>
+                    <a:lstStyle/>
+                    <a:p>
+                      <a:r>
+                        <a:rPr sz="900" b="1">
+                          <a:solidFill>
+                            <a:srgbClr val="F4F8FF"/>
+                          </a:solidFill>
+                          <a:latin typeface="Arial"/>
+                        </a:rPr>
+                        <a:t>HCA</a:t>
+                      </a:r>
+                    </a:p>
+                  </a:txBody>
+                  <a:tcPr marL="54864" marR="54864" marT="18288" marB="18288" anchor="ctr">
+                    <a:solidFill>
+                      <a:srgbClr val="121B37"/>
+                    </a:solidFill>
+                  </a:tcPr>
+                </a:tc>
+                <a:tc>
+                  <a:txBody>
+                    <a:bodyPr/>
+                    <a:lstStyle/>
+                    <a:p>
+                      <a:r>
+                        <a:rPr sz="900" b="1">
+                          <a:solidFill>
+                            <a:srgbClr val="F4F8FF"/>
+                          </a:solidFill>
+                          <a:latin typeface="Arial"/>
+                        </a:rPr>
+                        <a:t>26%</a:t>
+                      </a:r>
+                    </a:p>
+                  </a:txBody>
+                  <a:tcPr marL="54864" marR="54864" marT="18288" marB="18288" anchor="ctr">
+                    <a:solidFill>
+                      <a:srgbClr val="121B37"/>
+                    </a:solidFill>
+                  </a:tcPr>
+                </a:tc>
+                <a:tc>
+                  <a:txBody>
+                    <a:bodyPr/>
+                    <a:lstStyle/>
+                    <a:p>
+                      <a:r>
+                        <a:rPr sz="900" b="1">
+                          <a:solidFill>
+                            <a:srgbClr val="F4F8FF"/>
+                          </a:solidFill>
+                          <a:latin typeface="Arial"/>
+                        </a:rPr>
+                        <a:t>25%</a:t>
+                      </a:r>
+                    </a:p>
+                  </a:txBody>
+                  <a:tcPr marL="54864" marR="54864" marT="18288" marB="18288" anchor="ctr">
+                    <a:solidFill>
+                      <a:srgbClr val="121B37"/>
+                    </a:solidFill>
+                  </a:tcPr>
+                </a:tc>
+              </a:tr>
+              <a:tr h="219456">
+                <a:tc>
+                  <a:txBody>
+                    <a:bodyPr/>
+                    <a:lstStyle/>
+                    <a:p>
+                      <a:r>
+                        <a:rPr sz="900" b="1">
+                          <a:solidFill>
+                            <a:srgbClr val="F4F8FF"/>
+                          </a:solidFill>
+                          <a:latin typeface="Arial"/>
+                        </a:rPr>
+                        <a:t>ISRG</a:t>
+                      </a:r>
+                    </a:p>
+                  </a:txBody>
+                  <a:tcPr marL="54864" marR="54864" marT="18288" marB="18288" anchor="ctr">
+                    <a:solidFill>
+                      <a:srgbClr val="121B37"/>
+                    </a:solidFill>
+                  </a:tcPr>
+                </a:tc>
+                <a:tc>
+                  <a:txBody>
+                    <a:bodyPr/>
+                    <a:lstStyle/>
+                    <a:p>
+                      <a:r>
+                        <a:rPr sz="900" b="1">
+                          <a:solidFill>
+                            <a:srgbClr val="F4F8FF"/>
+                          </a:solidFill>
+                          <a:latin typeface="Arial"/>
+                        </a:rPr>
+                        <a:t>30%</a:t>
+                      </a:r>
+                    </a:p>
+                  </a:txBody>
+                  <a:tcPr marL="54864" marR="54864" marT="18288" marB="18288" anchor="ctr">
+                    <a:solidFill>
+                      <a:srgbClr val="121B37"/>
+                    </a:solidFill>
+                  </a:tcPr>
+                </a:tc>
+                <a:tc>
+                  <a:txBody>
+                    <a:bodyPr/>
+                    <a:lstStyle/>
+                    <a:p>
+                      <a:r>
+                        <a:rPr sz="900" b="1">
+                          <a:solidFill>
+                            <a:srgbClr val="F4F8FF"/>
+                          </a:solidFill>
+                          <a:latin typeface="Arial"/>
+                        </a:rPr>
+                        <a:t>31%</a:t>
+                      </a:r>
+                    </a:p>
+                  </a:txBody>
+                  <a:tcPr marL="54864" marR="54864" marT="18288" marB="18288" anchor="ctr">
+                    <a:solidFill>
+                      <a:srgbClr val="121B37"/>
+                    </a:solidFill>
+                  </a:tcPr>
+                </a:tc>
+              </a:tr>
+            </a:tbl>
+          </a:graphicData>
+        </a:graphic>
+      </p:graphicFrame>
+      <p:sp>
+        <p:nvSpPr>
+          <p:cNvPr id="257" name="TextBox 256"/>
+          <p:cNvSpPr txBox="1"/>
+          <p:nvPr/>
+        </p:nvSpPr>
+        <p:spPr>
+          <a:xfrm>
+            <a:off x="3383280" y="2944368"/>
+            <a:ext cx="2468880" cy="182880"/>
+          </a:xfrm>
+          <a:prstGeom prst="rect">
+            <a:avLst/>
+          </a:prstGeom>
+          <a:noFill/>
+        </p:spPr>
+        <p:txBody>
+          <a:bodyPr wrap="square" lIns="27425" rIns="27425" tIns="22850" bIns="22850" anchor="t">
+            <a:spAutoFit/>
+          </a:bodyPr>
+          <a:lstStyle/>
+          <a:p>
+            <a:pPr algn="l"/>
+            <a:r>
+              <a:rPr sz="800" b="1">
+                <a:solidFill>
+                  <a:srgbClr val="27D6FF"/>
+                </a:solidFill>
+                <a:latin typeface="Arial"/>
+              </a:rPr>
+              <a:t>DIALS COPIED FROM</a:t>
+            </a:r>
+          </a:p>
+        </p:txBody>
+      </p:sp>
+      <p:sp>
+        <p:nvSpPr>
+          <p:cNvPr id="258" name="TextBox 257"/>
+          <p:cNvSpPr txBox="1"/>
+          <p:nvPr/>
+        </p:nvSpPr>
+        <p:spPr>
+          <a:xfrm>
+            <a:off x="3383280" y="3127248"/>
+            <a:ext cx="2468880" cy="457200"/>
+          </a:xfrm>
+          <a:prstGeom prst="rect">
+            <a:avLst/>
+          </a:prstGeom>
+          <a:noFill/>
+        </p:spPr>
+        <p:txBody>
+          <a:bodyPr wrap="square" lIns="27425" rIns="27425" tIns="22850" bIns="22850" anchor="t">
+            <a:spAutoFit/>
+          </a:bodyPr>
+          <a:lstStyle/>
+          <a:p>
+            <a:pPr algn="l"/>
+            <a:r>
+              <a:rPr sz="1000" b="0">
+                <a:solidFill>
+                  <a:srgbClr val="F4F8FF"/>
+                </a:solidFill>
+                <a:latin typeface="Arial"/>
+              </a:rPr>
+              <a:t>Drug pipeline (pharma): same fully connected shape</a:t>
+            </a:r>
+          </a:p>
+        </p:txBody>
+      </p:sp>
+      <p:sp>
+        <p:nvSpPr>
+          <p:cNvPr id="259" name="TextBox 258"/>
+          <p:cNvSpPr txBox="1"/>
+          <p:nvPr/>
+        </p:nvSpPr>
+        <p:spPr>
+          <a:xfrm>
+            <a:off x="3383280" y="3639312"/>
+            <a:ext cx="2468880" cy="182880"/>
+          </a:xfrm>
+          <a:prstGeom prst="rect">
+            <a:avLst/>
+          </a:prstGeom>
+          <a:noFill/>
+        </p:spPr>
+        <p:txBody>
+          <a:bodyPr wrap="square" lIns="27425" rIns="27425" tIns="22850" bIns="22850" anchor="t">
+            <a:spAutoFit/>
+          </a:bodyPr>
+          <a:lstStyle/>
+          <a:p>
+            <a:pPr algn="l"/>
+            <a:r>
+              <a:rPr sz="800" b="1">
+                <a:solidFill>
+                  <a:srgbClr val="27D6FF"/>
+                </a:solidFill>
+                <a:latin typeface="Arial"/>
+              </a:rPr>
+              <a:t>ANSWER</a:t>
+            </a:r>
+          </a:p>
+        </p:txBody>
+      </p:sp>
+      <p:sp>
+        <p:nvSpPr>
+          <p:cNvPr id="260" name="TextBox 259"/>
+          <p:cNvSpPr txBox="1"/>
+          <p:nvPr/>
+        </p:nvSpPr>
+        <p:spPr>
+          <a:xfrm>
+            <a:off x="3383280" y="3822191"/>
+            <a:ext cx="2468880" cy="457200"/>
+          </a:xfrm>
+          <a:prstGeom prst="rect">
+            <a:avLst/>
+          </a:prstGeom>
+          <a:noFill/>
+        </p:spPr>
+        <p:txBody>
+          <a:bodyPr wrap="square" lIns="27425" rIns="27425" tIns="22850" bIns="22850" anchor="t">
+            <a:spAutoFit/>
+          </a:bodyPr>
+          <a:lstStyle/>
+          <a:p>
+            <a:pPr algn="l"/>
+            <a:r>
+              <a:rPr sz="1500" b="1">
+                <a:solidFill>
+                  <a:srgbClr val="F4F8FF"/>
+                </a:solidFill>
+                <a:latin typeface="Arial"/>
+              </a:rPr>
+              <a:t>HCA + ISRG</a:t>
+            </a:r>
+          </a:p>
+        </p:txBody>
+      </p:sp>
+      <p:sp>
+        <p:nvSpPr>
+          <p:cNvPr id="261" name="TextBox 260"/>
+          <p:cNvSpPr txBox="1"/>
+          <p:nvPr/>
+        </p:nvSpPr>
+        <p:spPr>
+          <a:xfrm>
+            <a:off x="3383280" y="4297680"/>
+            <a:ext cx="2468880" cy="228600"/>
+          </a:xfrm>
+          <a:prstGeom prst="rect">
+            <a:avLst/>
+          </a:prstGeom>
+          <a:noFill/>
+        </p:spPr>
+        <p:txBody>
+          <a:bodyPr wrap="square" lIns="27425" rIns="27425" tIns="22850" bIns="22850" anchor="t">
+            <a:spAutoFit/>
+          </a:bodyPr>
+          <a:lstStyle/>
+          <a:p>
+            <a:pPr algn="l"/>
+            <a:r>
+              <a:rPr sz="1000" b="1">
+                <a:solidFill>
+                  <a:srgbClr val="5BF0B9"/>
+                </a:solidFill>
+                <a:latin typeface="Arial"/>
+              </a:rPr>
+              <a:t>✓ matches the true best</a:t>
+            </a:r>
+          </a:p>
+        </p:txBody>
+      </p:sp>
+      <p:sp>
+        <p:nvSpPr>
+          <p:cNvPr id="262" name="TextBox 261"/>
+          <p:cNvSpPr txBox="1"/>
+          <p:nvPr/>
+        </p:nvSpPr>
+        <p:spPr>
+          <a:xfrm>
+            <a:off x="3383280" y="4535424"/>
+            <a:ext cx="2468880" cy="457200"/>
+          </a:xfrm>
+          <a:prstGeom prst="rect">
+            <a:avLst/>
+          </a:prstGeom>
+          <a:noFill/>
+        </p:spPr>
+        <p:txBody>
+          <a:bodyPr wrap="square" lIns="27425" rIns="27425" tIns="22850" bIns="22850" anchor="t">
+            <a:spAutoFit/>
+          </a:bodyPr>
+          <a:lstStyle/>
+          <a:p>
+            <a:pPr algn="l"/>
+            <a:r>
+              <a:rPr sz="1000" b="0">
+                <a:solidFill>
+                  <a:srgbClr val="A1B1CD"/>
+                </a:solidFill>
+                <a:latin typeface="Arial"/>
+              </a:rPr>
+              <a:t>Highest yearly returns (26% and 30%) with moderate risk.</a:t>
+            </a:r>
+          </a:p>
+        </p:txBody>
+      </p:sp>
+      <p:sp>
+        <p:nvSpPr>
+          <p:cNvPr id="263" name="TextBox 262"/>
+          <p:cNvSpPr txBox="1"/>
+          <p:nvPr/>
+        </p:nvSpPr>
+        <p:spPr>
+          <a:xfrm>
+            <a:off x="877824" y="5074920"/>
+            <a:ext cx="4983480" cy="365760"/>
+          </a:xfrm>
+          <a:prstGeom prst="rect">
+            <a:avLst/>
+          </a:prstGeom>
+          <a:noFill/>
+        </p:spPr>
+        <p:txBody>
+          <a:bodyPr wrap="square" lIns="27425" rIns="27425" tIns="22850" bIns="22850" anchor="t">
+            <a:spAutoFit/>
+          </a:bodyPr>
+          <a:lstStyle/>
+          <a:p>
+            <a:pPr algn="l"/>
+            <a:r>
+              <a:rPr sz="900" b="0">
+                <a:solidFill>
+                  <a:srgbClr val="A1B1CD"/>
+                </a:solidFill>
+                <a:latin typeface="Arial"/>
+              </a:rPr>
+              <a:t>Picked in 4.7% of shots (random: 1.6%) · score 0.68, same as full tuning (0.68)</a:t>
+            </a:r>
+          </a:p>
+        </p:txBody>
+      </p:sp>
+      <p:sp>
+        <p:nvSpPr>
+          <p:cNvPr id="264" name="Rounded Rectangle 263"/>
+          <p:cNvSpPr/>
+          <p:nvPr/>
+        </p:nvSpPr>
+        <p:spPr>
+          <a:xfrm>
+            <a:off x="6217920" y="2103120"/>
+            <a:ext cx="5440680" cy="3383280"/>
+          </a:xfrm>
+          <a:prstGeom prst="roundRect">
+            <a:avLst>
+              <a:gd name="adj" fmla="val 12000"/>
+            </a:avLst>
+          </a:prstGeom>
+          <a:solidFill>
+            <a:srgbClr val="0D132A"/>
+          </a:solidFill>
+          <a:ln w="12700">
+            <a:solidFill>
+              <a:srgbClr val="233558"/>
+            </a:solidFill>
+          </a:ln>
+          <a:effectLst/>
+        </p:spPr>
+        <p:style>
+          <a:lnRef idx="1">
+            <a:schemeClr val="accent1"/>
+          </a:lnRef>
+          <a:fillRef idx="3">
+            <a:schemeClr val="accent1"/>
+          </a:fillRef>
+          <a:effectRef idx="2">
+            <a:schemeClr val="accent1"/>
+          </a:effectRef>
+          <a:fontRef idx="minor">
+            <a:schemeClr val="lt1"/>
+          </a:fontRef>
+        </p:style>
+        <p:txBody>
+          <a:bodyPr rtlCol="0" anchor="ctr"/>
+          <a:lstStyle/>
+          <a:p>
+            <a:pPr algn="ctr"/>
+          </a:p>
+        </p:txBody>
+      </p:sp>
+      <p:sp>
+        <p:nvSpPr>
+          <p:cNvPr id="265" name="Rectangle 264"/>
+          <p:cNvSpPr/>
+          <p:nvPr/>
+        </p:nvSpPr>
+        <p:spPr>
+          <a:xfrm>
+            <a:off x="6382512" y="2267712"/>
+            <a:ext cx="50292" cy="3054096"/>
+          </a:xfrm>
+          <a:prstGeom prst="rect">
+            <a:avLst/>
+          </a:prstGeom>
+          <a:solidFill>
+            <a:srgbClr val="D948FF"/>
+          </a:solidFill>
+          <a:ln>
+            <a:noFill/>
+          </a:ln>
+          <a:effectLst/>
+        </p:spPr>
+        <p:style>
+          <a:lnRef idx="1">
+            <a:schemeClr val="accent1"/>
+          </a:lnRef>
+          <a:fillRef idx="3">
+            <a:schemeClr val="accent1"/>
+          </a:fillRef>
+          <a:effectRef idx="2">
+            <a:schemeClr val="accent1"/>
+          </a:effectRef>
+          <a:fontRef idx="minor">
+            <a:schemeClr val="lt1"/>
+          </a:fontRef>
+        </p:style>
+        <p:txBody>
+          <a:bodyPr rtlCol="0" anchor="ctr"/>
+          <a:lstStyle/>
+          <a:p>
+            <a:pPr algn="ctr"/>
+          </a:p>
+        </p:txBody>
+      </p:sp>
+      <p:sp>
+        <p:nvSpPr>
+          <p:cNvPr id="266" name="TextBox 265"/>
+          <p:cNvSpPr txBox="1"/>
+          <p:nvPr/>
+        </p:nvSpPr>
+        <p:spPr>
+          <a:xfrm>
+            <a:off x="6547104" y="2231136"/>
+            <a:ext cx="4937760" cy="201168"/>
+          </a:xfrm>
+          <a:prstGeom prst="rect">
+            <a:avLst/>
+          </a:prstGeom>
+          <a:noFill/>
+        </p:spPr>
+        <p:txBody>
+          <a:bodyPr wrap="square" lIns="27425" rIns="27425" tIns="22850" bIns="22850" anchor="t">
+            <a:spAutoFit/>
+          </a:bodyPr>
+          <a:lstStyle/>
+          <a:p>
+            <a:pPr algn="l"/>
+            <a:r>
+              <a:rPr sz="900" b="1">
+                <a:solidFill>
+                  <a:srgbClr val="D948FF"/>
+                </a:solidFill>
+                <a:latin typeface="Arial"/>
+              </a:rPr>
+              <a:t>HEALTHCARE · DIAGNOSTIC TESTS</a:t>
+            </a:r>
+          </a:p>
+        </p:txBody>
+      </p:sp>
+      <p:sp>
+        <p:nvSpPr>
+          <p:cNvPr id="267" name="TextBox 266"/>
+          <p:cNvSpPr txBox="1"/>
+          <p:nvPr/>
+        </p:nvSpPr>
+        <p:spPr>
+          <a:xfrm>
+            <a:off x="6547104" y="2468880"/>
+            <a:ext cx="4983480" cy="411480"/>
+          </a:xfrm>
+          <a:prstGeom prst="rect">
+            <a:avLst/>
+          </a:prstGeom>
+          <a:noFill/>
+        </p:spPr>
+        <p:txBody>
+          <a:bodyPr wrap="square" lIns="27425" rIns="27425" tIns="22850" bIns="22850" anchor="t">
+            <a:spAutoFit/>
+          </a:bodyPr>
+          <a:lstStyle/>
+          <a:p>
+            <a:pPr algn="l"/>
+            <a:r>
+              <a:rPr sz="1100" b="0">
+                <a:solidFill>
+                  <a:srgbClr val="A1B1CD"/>
+                </a:solidFill>
+                <a:latin typeface="Arial"/>
+              </a:rPr>
+              <a:t>Pick the most useful, least repetitive tumor measurements for a diagnosis (real data, 569 patients).</a:t>
+            </a:r>
+          </a:p>
+        </p:txBody>
+      </p:sp>
+      <p:graphicFrame>
+        <p:nvGraphicFramePr>
+          <p:cNvPr id="268" name="Table 267"/>
+          <p:cNvGraphicFramePr>
+            <a:graphicFrameLocks noGrp="1"/>
+          </p:cNvGraphicFramePr>
+          <p:nvPr/>
+        </p:nvGraphicFramePr>
+        <p:xfrm>
+          <a:off x="6547104" y="2971800"/>
+          <a:ext cx="2331720" cy="1536192"/>
+        </p:xfrm>
+        <a:graphic>
+          <a:graphicData uri="http://schemas.openxmlformats.org/drawingml/2006/table">
+            <a:tbl>
+              <a:tblPr firstRow="0" bandRow="0"/>
+              <a:tblGrid>
+                <a:gridCol w="1417320"/>
+                <a:gridCol w="914400"/>
+              </a:tblGrid>
+              <a:tr h="219456">
+                <a:tc>
+                  <a:txBody>
+                    <a:bodyPr/>
+                    <a:lstStyle/>
+                    <a:p>
+                      <a:r>
+                        <a:rPr sz="900" b="1">
+                          <a:solidFill>
+                            <a:srgbClr val="F4F8FF"/>
+                          </a:solidFill>
+                          <a:latin typeface="Arial"/>
+                        </a:rPr>
+                        <a:t>Test</a:t>
+                      </a:r>
+                    </a:p>
+                  </a:txBody>
+                  <a:tcPr marL="54864" marR="54864" marT="18288" marB="18288" anchor="ctr">
+                    <a:solidFill>
+                      <a:srgbClr val="233558"/>
+                    </a:solidFill>
+                  </a:tcPr>
+                </a:tc>
+                <a:tc>
+                  <a:txBody>
+                    <a:bodyPr/>
+                    <a:lstStyle/>
+                    <a:p>
+                      <a:r>
+                        <a:rPr sz="900" b="1">
+                          <a:solidFill>
+                            <a:srgbClr val="F4F8FF"/>
+                          </a:solidFill>
+                          <a:latin typeface="Arial"/>
+                        </a:rPr>
+                        <a:t>Chosen?</a:t>
+                      </a:r>
+                    </a:p>
+                  </a:txBody>
+                  <a:tcPr marL="54864" marR="54864" marT="18288" marB="18288" anchor="ctr">
+                    <a:solidFill>
+                      <a:srgbClr val="233558"/>
+                    </a:solidFill>
+                  </a:tcPr>
+                </a:tc>
+              </a:tr>
+              <a:tr h="219456">
+                <a:tc>
+                  <a:txBody>
+                    <a:bodyPr/>
+                    <a:lstStyle/>
+                    <a:p>
+                      <a:r>
+                        <a:rPr sz="900" b="0">
+                          <a:solidFill>
+                            <a:srgbClr val="A1B1CD"/>
+                          </a:solidFill>
+                          <a:latin typeface="Arial"/>
+                        </a:rPr>
+                        <a:t>radius</a:t>
+                      </a:r>
+                    </a:p>
+                  </a:txBody>
+                  <a:tcPr marL="54864" marR="54864" marT="18288" marB="18288" anchor="ctr">
+                    <a:solidFill>
+                      <a:srgbClr val="0D132A"/>
+                    </a:solidFill>
+                  </a:tcPr>
+                </a:tc>
+                <a:tc>
+                  <a:txBody>
+                    <a:bodyPr/>
+                    <a:lstStyle/>
+                    <a:p>
+                      <a:r>
+                        <a:rPr sz="900" b="0">
+                          <a:solidFill>
+                            <a:srgbClr val="A1B1CD"/>
+                          </a:solidFill>
+                          <a:latin typeface="Arial"/>
+                        </a:rPr>
+                        <a:t>-</a:t>
+                      </a:r>
+                    </a:p>
+                  </a:txBody>
+                  <a:tcPr marL="54864" marR="54864" marT="18288" marB="18288" anchor="ctr">
+                    <a:solidFill>
+                      <a:srgbClr val="0D132A"/>
+                    </a:solidFill>
+                  </a:tcPr>
+                </a:tc>
+              </a:tr>
+              <a:tr h="219456">
+                <a:tc>
+                  <a:txBody>
+                    <a:bodyPr/>
+                    <a:lstStyle/>
+                    <a:p>
+                      <a:r>
+                        <a:rPr sz="900" b="1">
+                          <a:solidFill>
+                            <a:srgbClr val="F4F8FF"/>
+                          </a:solidFill>
+                          <a:latin typeface="Arial"/>
+                        </a:rPr>
+                        <a:t>texture</a:t>
+                      </a:r>
+                    </a:p>
+                  </a:txBody>
+                  <a:tcPr marL="54864" marR="54864" marT="18288" marB="18288" anchor="ctr">
+                    <a:solidFill>
+                      <a:srgbClr val="121B37"/>
+                    </a:solidFill>
+                  </a:tcPr>
+                </a:tc>
+                <a:tc>
+                  <a:txBody>
+                    <a:bodyPr/>
+                    <a:lstStyle/>
+                    <a:p>
+                      <a:r>
+                        <a:rPr sz="900" b="1">
+                          <a:solidFill>
+                            <a:srgbClr val="F4F8FF"/>
+                          </a:solidFill>
+                          <a:latin typeface="Arial"/>
+                        </a:rPr>
+                        <a:t>yes</a:t>
+                      </a:r>
+                    </a:p>
+                  </a:txBody>
+                  <a:tcPr marL="54864" marR="54864" marT="18288" marB="18288" anchor="ctr">
+                    <a:solidFill>
+                      <a:srgbClr val="121B37"/>
+                    </a:solidFill>
+                  </a:tcPr>
+                </a:tc>
+              </a:tr>
+              <a:tr h="219456">
+                <a:tc>
+                  <a:txBody>
+                    <a:bodyPr/>
+                    <a:lstStyle/>
+                    <a:p>
+                      <a:r>
+                        <a:rPr sz="900" b="0">
+                          <a:solidFill>
+                            <a:srgbClr val="A1B1CD"/>
+                          </a:solidFill>
+                          <a:latin typeface="Arial"/>
+                        </a:rPr>
+                        <a:t>perimeter</a:t>
+                      </a:r>
+                    </a:p>
+                  </a:txBody>
+                  <a:tcPr marL="54864" marR="54864" marT="18288" marB="18288" anchor="ctr">
+                    <a:solidFill>
+                      <a:srgbClr val="0D132A"/>
+                    </a:solidFill>
+                  </a:tcPr>
+                </a:tc>
+                <a:tc>
+                  <a:txBody>
+                    <a:bodyPr/>
+                    <a:lstStyle/>
+                    <a:p>
+                      <a:r>
+                        <a:rPr sz="900" b="0">
+                          <a:solidFill>
+                            <a:srgbClr val="A1B1CD"/>
+                          </a:solidFill>
+                          <a:latin typeface="Arial"/>
+                        </a:rPr>
+                        <a:t>-</a:t>
+                      </a:r>
+                    </a:p>
+                  </a:txBody>
+                  <a:tcPr marL="54864" marR="54864" marT="18288" marB="18288" anchor="ctr">
+                    <a:solidFill>
+                      <a:srgbClr val="0D132A"/>
+                    </a:solidFill>
+                  </a:tcPr>
+                </a:tc>
+              </a:tr>
+              <a:tr h="219456">
+                <a:tc>
+                  <a:txBody>
+                    <a:bodyPr/>
+                    <a:lstStyle/>
+                    <a:p>
+                      <a:r>
+                        <a:rPr sz="900" b="1">
+                          <a:solidFill>
+                            <a:srgbClr val="F4F8FF"/>
+                          </a:solidFill>
+                          <a:latin typeface="Arial"/>
+                        </a:rPr>
+                        <a:t>area</a:t>
+                      </a:r>
+                    </a:p>
+                  </a:txBody>
+                  <a:tcPr marL="54864" marR="54864" marT="18288" marB="18288" anchor="ctr">
+                    <a:solidFill>
+                      <a:srgbClr val="121B37"/>
+                    </a:solidFill>
+                  </a:tcPr>
+                </a:tc>
+                <a:tc>
+                  <a:txBody>
+                    <a:bodyPr/>
+                    <a:lstStyle/>
+                    <a:p>
+                      <a:r>
+                        <a:rPr sz="900" b="1">
+                          <a:solidFill>
+                            <a:srgbClr val="F4F8FF"/>
+                          </a:solidFill>
+                          <a:latin typeface="Arial"/>
+                        </a:rPr>
+                        <a:t>yes</a:t>
+                      </a:r>
+                    </a:p>
+                  </a:txBody>
+                  <a:tcPr marL="54864" marR="54864" marT="18288" marB="18288" anchor="ctr">
+                    <a:solidFill>
+                      <a:srgbClr val="121B37"/>
+                    </a:solidFill>
+                  </a:tcPr>
+                </a:tc>
+              </a:tr>
+              <a:tr h="219456">
+                <a:tc>
+                  <a:txBody>
+                    <a:bodyPr/>
+                    <a:lstStyle/>
+                    <a:p>
+                      <a:r>
+                        <a:rPr sz="900" b="0">
+                          <a:solidFill>
+                            <a:srgbClr val="A1B1CD"/>
+                          </a:solidFill>
+                          <a:latin typeface="Arial"/>
+                        </a:rPr>
+                        <a:t>smoothness</a:t>
+                      </a:r>
+                    </a:p>
+                  </a:txBody>
+                  <a:tcPr marL="54864" marR="54864" marT="18288" marB="18288" anchor="ctr">
+                    <a:solidFill>
+                      <a:srgbClr val="0D132A"/>
+                    </a:solidFill>
+                  </a:tcPr>
+                </a:tc>
+                <a:tc>
+                  <a:txBody>
+                    <a:bodyPr/>
+                    <a:lstStyle/>
+                    <a:p>
+                      <a:r>
+                        <a:rPr sz="900" b="0">
+                          <a:solidFill>
+                            <a:srgbClr val="A1B1CD"/>
+                          </a:solidFill>
+                          <a:latin typeface="Arial"/>
+                        </a:rPr>
+                        <a:t>-</a:t>
+                      </a:r>
+                    </a:p>
+                  </a:txBody>
+                  <a:tcPr marL="54864" marR="54864" marT="18288" marB="18288" anchor="ctr">
+                    <a:solidFill>
+                      <a:srgbClr val="0D132A"/>
+                    </a:solidFill>
+                  </a:tcPr>
+                </a:tc>
+              </a:tr>
+              <a:tr h="219456">
+                <a:tc>
+                  <a:txBody>
+                    <a:bodyPr/>
+                    <a:lstStyle/>
+                    <a:p>
+                      <a:r>
+                        <a:rPr sz="900" b="1">
+                          <a:solidFill>
+                            <a:srgbClr val="F4F8FF"/>
+                          </a:solidFill>
+                          <a:latin typeface="Arial"/>
+                        </a:rPr>
+                        <a:t>compactness</a:t>
+                      </a:r>
+                    </a:p>
+                  </a:txBody>
+                  <a:tcPr marL="54864" marR="54864" marT="18288" marB="18288" anchor="ctr">
+                    <a:solidFill>
+                      <a:srgbClr val="121B37"/>
+                    </a:solidFill>
+                  </a:tcPr>
+                </a:tc>
+                <a:tc>
+                  <a:txBody>
+                    <a:bodyPr/>
+                    <a:lstStyle/>
+                    <a:p>
+                      <a:r>
+                        <a:rPr sz="900" b="1">
+                          <a:solidFill>
+                            <a:srgbClr val="F4F8FF"/>
+                          </a:solidFill>
+                          <a:latin typeface="Arial"/>
+                        </a:rPr>
+                        <a:t>yes</a:t>
+                      </a:r>
+                    </a:p>
+                  </a:txBody>
+                  <a:tcPr marL="54864" marR="54864" marT="18288" marB="18288" anchor="ctr">
+                    <a:solidFill>
+                      <a:srgbClr val="121B37"/>
+                    </a:solidFill>
+                  </a:tcPr>
+                </a:tc>
+              </a:tr>
+            </a:tbl>
+          </a:graphicData>
+        </a:graphic>
+      </p:graphicFrame>
+      <p:sp>
+        <p:nvSpPr>
+          <p:cNvPr id="269" name="TextBox 268"/>
+          <p:cNvSpPr txBox="1"/>
+          <p:nvPr/>
+        </p:nvSpPr>
+        <p:spPr>
+          <a:xfrm>
+            <a:off x="9052560" y="2944368"/>
+            <a:ext cx="2468880" cy="182880"/>
+          </a:xfrm>
+          <a:prstGeom prst="rect">
+            <a:avLst/>
+          </a:prstGeom>
+          <a:noFill/>
+        </p:spPr>
+        <p:txBody>
+          <a:bodyPr wrap="square" lIns="27425" rIns="27425" tIns="22850" bIns="22850" anchor="t">
+            <a:spAutoFit/>
+          </a:bodyPr>
+          <a:lstStyle/>
+          <a:p>
+            <a:pPr algn="l"/>
+            <a:r>
+              <a:rPr sz="800" b="1">
+                <a:solidFill>
+                  <a:srgbClr val="D948FF"/>
+                </a:solidFill>
+                <a:latin typeface="Arial"/>
+              </a:rPr>
+              <a:t>DIALS COPIED FROM</a:t>
+            </a:r>
+          </a:p>
+        </p:txBody>
+      </p:sp>
+      <p:sp>
+        <p:nvSpPr>
+          <p:cNvPr id="270" name="TextBox 269"/>
+          <p:cNvSpPr txBox="1"/>
+          <p:nvPr/>
+        </p:nvSpPr>
+        <p:spPr>
+          <a:xfrm>
+            <a:off x="9052560" y="3127248"/>
+            <a:ext cx="2468880" cy="457200"/>
+          </a:xfrm>
+          <a:prstGeom prst="rect">
+            <a:avLst/>
+          </a:prstGeom>
+          <a:noFill/>
+        </p:spPr>
+        <p:txBody>
+          <a:bodyPr wrap="square" lIns="27425" rIns="27425" tIns="22850" bIns="22850" anchor="t">
+            <a:spAutoFit/>
+          </a:bodyPr>
+          <a:lstStyle/>
+          <a:p>
+            <a:pPr algn="l"/>
+            <a:r>
+              <a:rPr sz="1000" b="0">
+                <a:solidFill>
+                  <a:srgbClr val="F4F8FF"/>
+                </a:solidFill>
+                <a:latin typeface="Arial"/>
+              </a:rPr>
+              <a:t>Network split (networks): similar loosely connected shape</a:t>
+            </a:r>
+          </a:p>
+        </p:txBody>
+      </p:sp>
+      <p:sp>
+        <p:nvSpPr>
+          <p:cNvPr id="271" name="TextBox 270"/>
+          <p:cNvSpPr txBox="1"/>
+          <p:nvPr/>
+        </p:nvSpPr>
+        <p:spPr>
+          <a:xfrm>
+            <a:off x="9052560" y="3639312"/>
+            <a:ext cx="2468880" cy="182880"/>
+          </a:xfrm>
+          <a:prstGeom prst="rect">
+            <a:avLst/>
+          </a:prstGeom>
+          <a:noFill/>
+        </p:spPr>
+        <p:txBody>
+          <a:bodyPr wrap="square" lIns="27425" rIns="27425" tIns="22850" bIns="22850" anchor="t">
+            <a:spAutoFit/>
+          </a:bodyPr>
+          <a:lstStyle/>
+          <a:p>
+            <a:pPr algn="l"/>
+            <a:r>
+              <a:rPr sz="800" b="1">
+                <a:solidFill>
+                  <a:srgbClr val="D948FF"/>
+                </a:solidFill>
+                <a:latin typeface="Arial"/>
+              </a:rPr>
+              <a:t>ANSWER</a:t>
+            </a:r>
+          </a:p>
+        </p:txBody>
+      </p:sp>
+      <p:sp>
+        <p:nvSpPr>
+          <p:cNvPr id="272" name="TextBox 271"/>
+          <p:cNvSpPr txBox="1"/>
+          <p:nvPr/>
+        </p:nvSpPr>
+        <p:spPr>
+          <a:xfrm>
+            <a:off x="9052560" y="3822191"/>
+            <a:ext cx="2468880" cy="457200"/>
+          </a:xfrm>
+          <a:prstGeom prst="rect">
+            <a:avLst/>
+          </a:prstGeom>
+          <a:noFill/>
+        </p:spPr>
+        <p:txBody>
+          <a:bodyPr wrap="square" lIns="27425" rIns="27425" tIns="22850" bIns="22850" anchor="t">
+            <a:spAutoFit/>
+          </a:bodyPr>
+          <a:lstStyle/>
+          <a:p>
+            <a:pPr algn="l"/>
+            <a:r>
+              <a:rPr sz="1300" b="1">
+                <a:solidFill>
+                  <a:srgbClr val="F4F8FF"/>
+                </a:solidFill>
+                <a:latin typeface="Arial"/>
+              </a:rPr>
+              <a:t>texture + area + compactness</a:t>
+            </a:r>
+          </a:p>
+        </p:txBody>
+      </p:sp>
+      <p:sp>
+        <p:nvSpPr>
+          <p:cNvPr id="273" name="TextBox 272"/>
+          <p:cNvSpPr txBox="1"/>
+          <p:nvPr/>
+        </p:nvSpPr>
+        <p:spPr>
+          <a:xfrm>
+            <a:off x="9052560" y="4297680"/>
+            <a:ext cx="2468880" cy="228600"/>
+          </a:xfrm>
+          <a:prstGeom prst="rect">
+            <a:avLst/>
+          </a:prstGeom>
+          <a:noFill/>
+        </p:spPr>
+        <p:txBody>
+          <a:bodyPr wrap="square" lIns="27425" rIns="27425" tIns="22850" bIns="22850" anchor="t">
+            <a:spAutoFit/>
+          </a:bodyPr>
+          <a:lstStyle/>
+          <a:p>
+            <a:pPr algn="l"/>
+            <a:r>
+              <a:rPr sz="1000" b="1">
+                <a:solidFill>
+                  <a:srgbClr val="5BF0B9"/>
+                </a:solidFill>
+                <a:latin typeface="Arial"/>
+              </a:rPr>
+              <a:t>✓ matches the true best</a:t>
+            </a:r>
+          </a:p>
+        </p:txBody>
+      </p:sp>
+      <p:sp>
+        <p:nvSpPr>
+          <p:cNvPr id="274" name="TextBox 273"/>
+          <p:cNvSpPr txBox="1"/>
+          <p:nvPr/>
+        </p:nvSpPr>
+        <p:spPr>
+          <a:xfrm>
+            <a:off x="9052560" y="4535424"/>
+            <a:ext cx="2468880" cy="457200"/>
+          </a:xfrm>
+          <a:prstGeom prst="rect">
+            <a:avLst/>
+          </a:prstGeom>
+          <a:noFill/>
+        </p:spPr>
+        <p:txBody>
+          <a:bodyPr wrap="square" lIns="27425" rIns="27425" tIns="22850" bIns="22850" anchor="t">
+            <a:spAutoFit/>
+          </a:bodyPr>
+          <a:lstStyle/>
+          <a:p>
+            <a:pPr algn="l"/>
+            <a:r>
+              <a:rPr sz="1000" b="0">
+                <a:solidFill>
+                  <a:srgbClr val="A1B1CD"/>
+                </a:solidFill>
+                <a:latin typeface="Arial"/>
+              </a:rPr>
+              <a:t>Radius and perimeter just repeat area (all measure size).</a:t>
+            </a:r>
+          </a:p>
+        </p:txBody>
+      </p:sp>
+      <p:sp>
+        <p:nvSpPr>
+          <p:cNvPr id="275" name="TextBox 274"/>
+          <p:cNvSpPr txBox="1"/>
+          <p:nvPr/>
+        </p:nvSpPr>
+        <p:spPr>
+          <a:xfrm>
+            <a:off x="6547104" y="5074920"/>
+            <a:ext cx="4983480" cy="365760"/>
+          </a:xfrm>
+          <a:prstGeom prst="rect">
+            <a:avLst/>
+          </a:prstGeom>
+          <a:noFill/>
+        </p:spPr>
+        <p:txBody>
+          <a:bodyPr wrap="square" lIns="27425" rIns="27425" tIns="22850" bIns="22850" anchor="t">
+            <a:spAutoFit/>
+          </a:bodyPr>
+          <a:lstStyle/>
+          <a:p>
+            <a:pPr algn="l"/>
+            <a:r>
+              <a:rPr sz="900" b="0">
+                <a:solidFill>
+                  <a:srgbClr val="A1B1CD"/>
+                </a:solidFill>
+                <a:latin typeface="Arial"/>
+              </a:rPr>
+              <a:t>Picked in 8.8% of shots (random: 1.6%) · score 0.25 vs 0.39 with full tuning</a:t>
+            </a:r>
+          </a:p>
+        </p:txBody>
+      </p:sp>
+      <p:sp>
+        <p:nvSpPr>
+          <p:cNvPr id="276" name="Rounded Rectangle 275"/>
+          <p:cNvSpPr/>
+          <p:nvPr/>
+        </p:nvSpPr>
+        <p:spPr>
+          <a:xfrm>
+            <a:off x="822960" y="5623560"/>
+            <a:ext cx="10424160" cy="438912"/>
+          </a:xfrm>
+          <a:prstGeom prst="roundRect">
+            <a:avLst>
+              <a:gd name="adj" fmla="val 20000"/>
+            </a:avLst>
+          </a:prstGeom>
+          <a:solidFill>
+            <a:srgbClr val="121B37"/>
+          </a:solidFill>
+          <a:ln w="12700">
+            <a:solidFill>
+              <a:srgbClr val="FFCA5C"/>
+            </a:solidFill>
+          </a:ln>
+          <a:effectLst/>
+        </p:spPr>
+        <p:style>
+          <a:lnRef idx="1">
+            <a:schemeClr val="accent1"/>
+          </a:lnRef>
+          <a:fillRef idx="3">
+            <a:schemeClr val="accent1"/>
+          </a:fillRef>
+          <a:effectRef idx="2">
+            <a:schemeClr val="accent1"/>
+          </a:effectRef>
+          <a:fontRef idx="minor">
+            <a:schemeClr val="lt1"/>
+          </a:fontRef>
+        </p:style>
+        <p:txBody>
+          <a:bodyPr rtlCol="0" anchor="ctr"/>
+          <a:lstStyle/>
+          <a:p>
+            <a:pPr algn="ctr"/>
+          </a:p>
+        </p:txBody>
+      </p:sp>
+      <p:sp>
+        <p:nvSpPr>
+          <p:cNvPr id="277" name="TextBox 276"/>
+          <p:cNvSpPr txBox="1"/>
+          <p:nvPr/>
+        </p:nvSpPr>
+        <p:spPr>
+          <a:xfrm>
+            <a:off x="1005840" y="5623560"/>
+            <a:ext cx="10058400" cy="438912"/>
+          </a:xfrm>
+          <a:prstGeom prst="rect">
+            <a:avLst/>
+          </a:prstGeom>
+          <a:noFill/>
+        </p:spPr>
+        <p:txBody>
+          <a:bodyPr wrap="square" lIns="27425" rIns="27425" tIns="22850" bIns="22850" anchor="ctr">
+            <a:spAutoFit/>
+          </a:bodyPr>
+          <a:lstStyle/>
+          <a:p>
+            <a:pPr algn="ctr"/>
+            <a:r>
+              <a:rPr sz="1200" b="1">
+                <a:solidFill>
+                  <a:srgbClr val="FFCA5C"/>
+                </a:solidFill>
+                <a:latin typeface="Arial"/>
+              </a:rPr>
+              <a:t>BOTH ANSWERS MATCH THE TRUE BEST · FOUND WITH 1 RUN INSTEAD OF ~60 TUNING RUNS (SIMULATOR)</a:t>
             </a:r>
           </a:p>
         </p:txBody>

</xml_diff>